<commit_message>
docs: PPT v4 — tambah diagram arsitektur + split alur keputusan
- Slide 3: diagram arsitektur soar-architecture.png + keterangan stack
- Slide 4: alur keputusan (flow diagram + tabel 5 jalur)
- Slide 5: hasil pengukuran
- Slide 6: kontribusi & kebaruan
- Slide 7: rencana ke depan
- Slide 8: penutup
Total 8 slides
</commit_message>
<xml_diff>
--- a/docs/BIMBINGAN-TA-SOAR.pptx
+++ b/docs/BIMBINGAN-TA-SOAR.pptx
@@ -12,6 +12,7 @@
     <p:sldId id="260" r:id="rId11"/>
     <p:sldId id="261" r:id="rId12"/>
     <p:sldId id="262" r:id="rId13"/>
+    <p:sldId id="263" r:id="rId14"/>
   </p:sldIdLst>
   <p:sldSz cx="12191695" cy="6858000" type="screen4x3"/>
   <p:notesSz cx="6858000" cy="9144000"/>
@@ -3162,7 +3163,7 @@
             <a:pPr algn="ctr">
               <a:defRPr sz="2000" b="0">
                 <a:solidFill>
-                  <a:srgbClr val="555555"/>
+                  <a:srgbClr val="666666"/>
                 </a:solidFill>
               </a:defRPr>
             </a:pPr>
@@ -3275,7 +3276,7 @@
             <a:pPr algn="ctr">
               <a:defRPr sz="1800" b="0">
                 <a:solidFill>
-                  <a:srgbClr val="555555"/>
+                  <a:srgbClr val="666666"/>
                 </a:solidFill>
               </a:defRPr>
             </a:pPr>
@@ -3440,7 +3441,7 @@
           <a:p>
             <a:pPr>
               <a:spcBef>
-                <a:spcPts val="600"/>
+                <a:spcPts val="500"/>
               </a:spcBef>
               <a:defRPr sz="1500">
                 <a:solidFill>
@@ -3455,7 +3456,7 @@
           <a:p>
             <a:pPr>
               <a:spcBef>
-                <a:spcPts val="600"/>
+                <a:spcPts val="500"/>
               </a:spcBef>
               <a:defRPr sz="1500">
                 <a:solidFill>
@@ -3470,7 +3471,7 @@
           <a:p>
             <a:pPr>
               <a:spcBef>
-                <a:spcPts val="600"/>
+                <a:spcPts val="500"/>
               </a:spcBef>
               <a:defRPr sz="1500">
                 <a:solidFill>
@@ -3485,7 +3486,7 @@
           <a:p>
             <a:pPr>
               <a:spcBef>
-                <a:spcPts val="600"/>
+                <a:spcPts val="500"/>
               </a:spcBef>
               <a:defRPr sz="1500">
                 <a:solidFill>
@@ -3500,7 +3501,7 @@
           <a:p>
             <a:pPr>
               <a:spcBef>
-                <a:spcPts val="600"/>
+                <a:spcPts val="500"/>
               </a:spcBef>
               <a:defRPr sz="1500">
                 <a:solidFill>
@@ -3515,7 +3516,7 @@
           <a:p>
             <a:pPr>
               <a:spcBef>
-                <a:spcPts val="600"/>
+                <a:spcPts val="500"/>
               </a:spcBef>
               <a:defRPr sz="1500">
                 <a:solidFill>
@@ -3527,7 +3528,7 @@
           <a:p>
             <a:pPr>
               <a:spcBef>
-                <a:spcPts val="600"/>
+                <a:spcPts val="500"/>
               </a:spcBef>
               <a:defRPr sz="1500">
                 <a:solidFill>
@@ -3542,7 +3543,7 @@
           <a:p>
             <a:pPr>
               <a:spcBef>
-                <a:spcPts val="600"/>
+                <a:spcPts val="500"/>
               </a:spcBef>
               <a:defRPr sz="1500">
                 <a:solidFill>
@@ -3557,7 +3558,7 @@
           <a:p>
             <a:pPr>
               <a:spcBef>
-                <a:spcPts val="600"/>
+                <a:spcPts val="500"/>
               </a:spcBef>
               <a:defRPr sz="1500">
                 <a:solidFill>
@@ -3572,7 +3573,7 @@
           <a:p>
             <a:pPr>
               <a:spcBef>
-                <a:spcPts val="600"/>
+                <a:spcPts val="500"/>
               </a:spcBef>
               <a:defRPr sz="1500">
                 <a:solidFill>
@@ -3587,7 +3588,7 @@
           <a:p>
             <a:pPr>
               <a:spcBef>
-                <a:spcPts val="600"/>
+                <a:spcPts val="500"/>
               </a:spcBef>
               <a:defRPr sz="1500">
                 <a:solidFill>
@@ -3625,7 +3626,7 @@
           <a:p>
             <a:pPr>
               <a:spcBef>
-                <a:spcPts val="600"/>
+                <a:spcPts val="500"/>
               </a:spcBef>
               <a:defRPr sz="1500">
                 <a:solidFill>
@@ -3640,7 +3641,7 @@
           <a:p>
             <a:pPr>
               <a:spcBef>
-                <a:spcPts val="600"/>
+                <a:spcPts val="500"/>
               </a:spcBef>
               <a:defRPr sz="1500">
                 <a:solidFill>
@@ -3655,7 +3656,7 @@
           <a:p>
             <a:pPr>
               <a:spcBef>
-                <a:spcPts val="600"/>
+                <a:spcPts val="500"/>
               </a:spcBef>
               <a:defRPr sz="1500">
                 <a:solidFill>
@@ -3670,7 +3671,7 @@
           <a:p>
             <a:pPr>
               <a:spcBef>
-                <a:spcPts val="600"/>
+                <a:spcPts val="500"/>
               </a:spcBef>
               <a:defRPr sz="1500">
                 <a:solidFill>
@@ -3685,7 +3686,7 @@
           <a:p>
             <a:pPr>
               <a:spcBef>
-                <a:spcPts val="600"/>
+                <a:spcPts val="500"/>
               </a:spcBef>
               <a:defRPr sz="1500">
                 <a:solidFill>
@@ -3700,7 +3701,7 @@
           <a:p>
             <a:pPr>
               <a:spcBef>
-                <a:spcPts val="600"/>
+                <a:spcPts val="500"/>
               </a:spcBef>
               <a:defRPr sz="1500">
                 <a:solidFill>
@@ -3712,7 +3713,7 @@
           <a:p>
             <a:pPr>
               <a:spcBef>
-                <a:spcPts val="600"/>
+                <a:spcPts val="500"/>
               </a:spcBef>
               <a:defRPr sz="1500">
                 <a:solidFill>
@@ -3727,7 +3728,7 @@
           <a:p>
             <a:pPr>
               <a:spcBef>
-                <a:spcPts val="600"/>
+                <a:spcPts val="500"/>
               </a:spcBef>
               <a:defRPr sz="1500">
                 <a:solidFill>
@@ -3742,7 +3743,7 @@
           <a:p>
             <a:pPr>
               <a:spcBef>
-                <a:spcPts val="600"/>
+                <a:spcPts val="500"/>
               </a:spcBef>
               <a:defRPr sz="1500">
                 <a:solidFill>
@@ -3757,7 +3758,7 @@
           <a:p>
             <a:pPr>
               <a:spcBef>
-                <a:spcPts val="600"/>
+                <a:spcPts val="500"/>
               </a:spcBef>
               <a:defRPr sz="1500">
                 <a:solidFill>
@@ -3772,7 +3773,7 @@
           <a:p>
             <a:pPr>
               <a:spcBef>
-                <a:spcPts val="600"/>
+                <a:spcPts val="500"/>
               </a:spcBef>
               <a:defRPr sz="1500">
                 <a:solidFill>
@@ -3834,7 +3835,7 @@
               </a:defRPr>
             </a:pPr>
             <a:r>
-              <a:t>Cara Kerja Sistem</a:t>
+              <a:t>Arsitektur Sistem</a:t>
             </a:r>
           </a:p>
         </p:txBody>
@@ -3882,16 +3883,40 @@
           </a:p>
         </p:txBody>
       </p:sp>
-      <p:sp>
-        <p:nvSpPr>
-          <p:cNvPr id="4" name="TextBox 3"/>
+      <p:pic>
+        <p:nvPicPr>
+          <p:cNvPr id="4" name="Picture 3" descr="soar-architecture.png"/>
+          <p:cNvPicPr>
+            <a:picLocks noChangeAspect="1"/>
+          </p:cNvPicPr>
+          <p:nvPr/>
+        </p:nvPicPr>
+        <p:blipFill>
+          <a:blip r:embed="rId2"/>
+          <a:stretch>
+            <a:fillRect/>
+          </a:stretch>
+        </p:blipFill>
+        <p:spPr>
+          <a:xfrm>
+            <a:off x="457200" y="1005840"/>
+            <a:ext cx="7772400" cy="5303520"/>
+          </a:xfrm>
+          <a:prstGeom prst="rect">
+            <a:avLst/>
+          </a:prstGeom>
+        </p:spPr>
+      </p:pic>
+      <p:sp>
+        <p:nvSpPr>
+          <p:cNvPr id="5" name="TextBox 4"/>
           <p:cNvSpPr txBox="1"/>
           <p:nvPr/>
         </p:nvSpPr>
         <p:spPr>
           <a:xfrm>
-            <a:off x="457200" y="1097280"/>
-            <a:ext cx="10972800" cy="457200"/>
+            <a:off x="8503920" y="1097280"/>
+            <a:ext cx="3474720" cy="5029200"/>
           </a:xfrm>
           <a:prstGeom prst="rect">
             <a:avLst/>
@@ -3904,29 +3929,292 @@
           </a:bodyPr>
           <a:lstStyle/>
           <a:p>
+            <a:pPr>
+              <a:spcBef>
+                <a:spcPts val="500"/>
+              </a:spcBef>
+              <a:defRPr sz="1300">
+                <a:solidFill>
+                  <a:srgbClr val="666666"/>
+                </a:solidFill>
+              </a:defRPr>
+            </a:pPr>
+            <a:r>
+              <a:t>Stack:</a:t>
+            </a:r>
+          </a:p>
+          <a:p>
+            <a:pPr>
+              <a:spcBef>
+                <a:spcPts val="500"/>
+              </a:spcBef>
+              <a:defRPr sz="1300">
+                <a:solidFill>
+                  <a:srgbClr val="666666"/>
+                </a:solidFill>
+              </a:defRPr>
+            </a:pPr>
+            <a:r>
+              <a:t>  Wazuh 4.9.2</a:t>
+            </a:r>
+          </a:p>
+          <a:p>
+            <a:pPr>
+              <a:spcBef>
+                <a:spcPts val="500"/>
+              </a:spcBef>
+              <a:defRPr sz="1300">
+                <a:solidFill>
+                  <a:srgbClr val="666666"/>
+                </a:solidFill>
+              </a:defRPr>
+            </a:pPr>
+            <a:r>
+              <a:t>  n8n 2.36.9</a:t>
+            </a:r>
+          </a:p>
+          <a:p>
+            <a:pPr>
+              <a:spcBef>
+                <a:spcPts val="500"/>
+              </a:spcBef>
+              <a:defRPr sz="1300">
+                <a:solidFill>
+                  <a:srgbClr val="666666"/>
+                </a:solidFill>
+              </a:defRPr>
+            </a:pPr>
+            <a:r>
+              <a:t>  Ollama llama3.2:3b</a:t>
+            </a:r>
+          </a:p>
+          <a:p>
+            <a:pPr>
+              <a:spcBef>
+                <a:spcPts val="500"/>
+              </a:spcBef>
+              <a:defRPr sz="1300">
+                <a:solidFill>
+                  <a:srgbClr val="666666"/>
+                </a:solidFill>
+              </a:defRPr>
+            </a:pPr>
+            <a:r>
+              <a:t>  VirusTotal API</a:t>
+            </a:r>
+          </a:p>
+          <a:p>
+            <a:pPr>
+              <a:spcBef>
+                <a:spcPts val="500"/>
+              </a:spcBef>
+              <a:defRPr sz="1300">
+                <a:solidFill>
+                  <a:srgbClr val="666666"/>
+                </a:solidFill>
+              </a:defRPr>
+            </a:pPr>
+            <a:r>
+              <a:t>  Google Safe Browsing</a:t>
+            </a:r>
+          </a:p>
+          <a:p>
+            <a:pPr>
+              <a:spcBef>
+                <a:spcPts val="500"/>
+              </a:spcBef>
+              <a:defRPr sz="1300">
+                <a:solidFill>
+                  <a:srgbClr val="666666"/>
+                </a:solidFill>
+              </a:defRPr>
+            </a:pPr>
+            <a:r>
+              <a:t>  MalwareBazaar</a:t>
+            </a:r>
+          </a:p>
+          <a:p>
+            <a:pPr>
+              <a:spcBef>
+                <a:spcPts val="500"/>
+              </a:spcBef>
+              <a:defRPr sz="1300">
+                <a:solidFill>
+                  <a:srgbClr val="666666"/>
+                </a:solidFill>
+              </a:defRPr>
+            </a:pPr>
+          </a:p>
+          <a:p>
+            <a:pPr>
+              <a:spcBef>
+                <a:spcPts val="500"/>
+              </a:spcBef>
+              <a:defRPr sz="1300">
+                <a:solidFill>
+                  <a:srgbClr val="666666"/>
+                </a:solidFill>
+              </a:defRPr>
+            </a:pPr>
+            <a:r>
+              <a:t>Container:</a:t>
+            </a:r>
+          </a:p>
+          <a:p>
+            <a:pPr>
+              <a:spcBef>
+                <a:spcPts val="500"/>
+              </a:spcBef>
+              <a:defRPr sz="1300">
+                <a:solidFill>
+                  <a:srgbClr val="666666"/>
+                </a:solidFill>
+              </a:defRPr>
+            </a:pPr>
+            <a:r>
+              <a:t>  - wazuh.manager</a:t>
+            </a:r>
+          </a:p>
+          <a:p>
+            <a:pPr>
+              <a:spcBef>
+                <a:spcPts val="500"/>
+              </a:spcBef>
+              <a:defRPr sz="1300">
+                <a:solidFill>
+                  <a:srgbClr val="666666"/>
+                </a:solidFill>
+              </a:defRPr>
+            </a:pPr>
+            <a:r>
+              <a:t>  - wazuh.indexer</a:t>
+            </a:r>
+          </a:p>
+          <a:p>
+            <a:pPr>
+              <a:spcBef>
+                <a:spcPts val="500"/>
+              </a:spcBef>
+              <a:defRPr sz="1300">
+                <a:solidFill>
+                  <a:srgbClr val="666666"/>
+                </a:solidFill>
+              </a:defRPr>
+            </a:pPr>
+            <a:r>
+              <a:t>  - wazuh.dashboard</a:t>
+            </a:r>
+          </a:p>
+          <a:p>
+            <a:pPr>
+              <a:spcBef>
+                <a:spcPts val="500"/>
+              </a:spcBef>
+              <a:defRPr sz="1300">
+                <a:solidFill>
+                  <a:srgbClr val="666666"/>
+                </a:solidFill>
+              </a:defRPr>
+            </a:pPr>
+            <a:r>
+              <a:t>  - n8n</a:t>
+            </a:r>
+          </a:p>
+          <a:p>
+            <a:pPr>
+              <a:spcBef>
+                <a:spcPts val="500"/>
+              </a:spcBef>
+              <a:defRPr sz="1300">
+                <a:solidFill>
+                  <a:srgbClr val="666666"/>
+                </a:solidFill>
+              </a:defRPr>
+            </a:pPr>
+            <a:r>
+              <a:t>  - tg-callback-poller</a:t>
+            </a:r>
+          </a:p>
+          <a:p>
+            <a:pPr>
+              <a:spcBef>
+                <a:spcPts val="500"/>
+              </a:spcBef>
+              <a:defRPr sz="1300">
+                <a:solidFill>
+                  <a:srgbClr val="666666"/>
+                </a:solidFill>
+              </a:defRPr>
+            </a:pPr>
+            <a:r>
+              <a:t>  - health-monitor</a:t>
+            </a:r>
+          </a:p>
+        </p:txBody>
+      </p:sp>
+    </p:spTree>
+  </p:cSld>
+  <p:clrMapOvr>
+    <a:masterClrMapping/>
+  </p:clrMapOvr>
+</p:sld>
+</file>
+
+<file path=ppt/slides/slide4.xml><?xml version="1.0" encoding="utf-8"?>
+<p:sld xmlns:a="http://schemas.openxmlformats.org/drawingml/2006/main" xmlns:p="http://schemas.openxmlformats.org/presentationml/2006/main" xmlns:r="http://schemas.openxmlformats.org/officeDocument/2006/relationships">
+  <p:cSld>
+    <p:spTree>
+      <p:nvGrpSpPr>
+        <p:cNvPr id="1" name=""/>
+        <p:cNvGrpSpPr/>
+        <p:nvPr/>
+      </p:nvGrpSpPr>
+      <p:grpSpPr/>
+      <p:sp>
+        <p:nvSpPr>
+          <p:cNvPr id="2" name="TextBox 1"/>
+          <p:cNvSpPr txBox="1"/>
+          <p:nvPr/>
+        </p:nvSpPr>
+        <p:spPr>
+          <a:xfrm>
+            <a:off x="457200" y="274320"/>
+            <a:ext cx="10972800" cy="548640"/>
+          </a:xfrm>
+          <a:prstGeom prst="rect">
+            <a:avLst/>
+          </a:prstGeom>
+          <a:noFill/>
+        </p:spPr>
+        <p:txBody>
+          <a:bodyPr wrap="square">
+            <a:spAutoFit/>
+          </a:bodyPr>
+          <a:lstStyle/>
+          <a:p>
             <a:pPr algn="l">
-              <a:defRPr sz="1400" b="0">
-                <a:solidFill>
-                  <a:srgbClr val="666666"/>
-                </a:solidFill>
-              </a:defRPr>
-            </a:pPr>
-            <a:r>
-              <a:t>Stack: Wazuh 4.9.2 + n8n 2.36.9 + Ollama llama3.2:3b + VirusTotal + GSB + MalwareBazaar</a:t>
-            </a:r>
-          </a:p>
-        </p:txBody>
-      </p:sp>
-      <p:sp>
-        <p:nvSpPr>
-          <p:cNvPr id="5" name="Rectangle 4"/>
+              <a:defRPr sz="2800" b="1">
+                <a:solidFill>
+                  <a:srgbClr val="1A568E"/>
+                </a:solidFill>
+              </a:defRPr>
+            </a:pPr>
+            <a:r>
+              <a:t>Alur Keputusan</a:t>
+            </a:r>
+          </a:p>
+        </p:txBody>
+      </p:sp>
+      <p:sp>
+        <p:nvSpPr>
+          <p:cNvPr id="3" name="Rectangle 2"/>
           <p:cNvSpPr/>
           <p:nvPr/>
         </p:nvSpPr>
         <p:spPr>
           <a:xfrm>
-            <a:off x="274320" y="1737360"/>
-            <a:ext cx="1645920" cy="822960"/>
+            <a:off x="457200" y="822960"/>
+            <a:ext cx="2743200" cy="25400"/>
           </a:xfrm>
           <a:prstGeom prst="rect">
             <a:avLst/>
@@ -3953,71 +4241,23 @@
           </a:fontRef>
         </p:style>
         <p:txBody>
-          <a:bodyPr rtlCol="0" anchor="ctr" wrap="square"/>
-          <a:lstStyle/>
-          <a:p>
-            <a:pPr algn="ctr">
-              <a:defRPr sz="1200">
-                <a:solidFill>
-                  <a:srgbClr val="FFFFFF"/>
-                </a:solidFill>
-              </a:defRPr>
-            </a:pPr>
-            <a:r>
-              <a:t>Endpoint</a:t>
-            </a:r>
-            <a:br/>
-            <a:r>
-              <a:t>(FIM/Log)</a:t>
-            </a:r>
-          </a:p>
-        </p:txBody>
-      </p:sp>
-      <p:sp>
-        <p:nvSpPr>
-          <p:cNvPr id="6" name="TextBox 5"/>
-          <p:cNvSpPr txBox="1"/>
+          <a:bodyPr rtlCol="0" anchor="ctr"/>
+          <a:lstStyle/>
+          <a:p>
+            <a:pPr algn="ctr"/>
+          </a:p>
+        </p:txBody>
+      </p:sp>
+      <p:sp>
+        <p:nvSpPr>
+          <p:cNvPr id="4" name="Rectangle 3"/>
+          <p:cNvSpPr/>
           <p:nvPr/>
         </p:nvSpPr>
         <p:spPr>
           <a:xfrm>
-            <a:off x="1920240" y="1920240"/>
-            <a:ext cx="320040" cy="457200"/>
-          </a:xfrm>
-          <a:prstGeom prst="rect">
-            <a:avLst/>
-          </a:prstGeom>
-          <a:noFill/>
-        </p:spPr>
-        <p:txBody>
-          <a:bodyPr wrap="square">
-            <a:spAutoFit/>
-          </a:bodyPr>
-          <a:lstStyle/>
-          <a:p>
-            <a:pPr algn="ctr">
-              <a:defRPr sz="1800" b="1">
-                <a:solidFill>
-                  <a:srgbClr val="000000"/>
-                </a:solidFill>
-              </a:defRPr>
-            </a:pPr>
-            <a:r>
-              <a:t>-&gt;</a:t>
-            </a:r>
-          </a:p>
-        </p:txBody>
-      </p:sp>
-      <p:sp>
-        <p:nvSpPr>
-          <p:cNvPr id="7" name="Rectangle 6"/>
-          <p:cNvSpPr/>
-          <p:nvPr/>
-        </p:nvSpPr>
-        <p:spPr>
-          <a:xfrm>
-            <a:off x="2240279" y="1737360"/>
-            <a:ext cx="1645920" cy="822960"/>
+            <a:off x="457200" y="1188720"/>
+            <a:ext cx="1828800" cy="822960"/>
           </a:xfrm>
           <a:prstGeom prst="rect">
             <a:avLst/>
@@ -4048,32 +4288,32 @@
           <a:lstStyle/>
           <a:p>
             <a:pPr algn="ctr">
-              <a:defRPr sz="1200">
+              <a:defRPr sz="1300">
                 <a:solidFill>
                   <a:srgbClr val="FFFFFF"/>
                 </a:solidFill>
               </a:defRPr>
             </a:pPr>
             <a:r>
-              <a:t>Wazuh</a:t>
+              <a:t>FIM Alert</a:t>
             </a:r>
             <a:br/>
             <a:r>
-              <a:t>Manager</a:t>
-            </a:r>
-          </a:p>
-        </p:txBody>
-      </p:sp>
-      <p:sp>
-        <p:nvSpPr>
-          <p:cNvPr id="8" name="TextBox 7"/>
+              <a:t>(Wazuh)</a:t>
+            </a:r>
+          </a:p>
+        </p:txBody>
+      </p:sp>
+      <p:sp>
+        <p:nvSpPr>
+          <p:cNvPr id="5" name="TextBox 4"/>
           <p:cNvSpPr txBox="1"/>
           <p:nvPr/>
         </p:nvSpPr>
         <p:spPr>
           <a:xfrm>
-            <a:off x="3886200" y="1920240"/>
-            <a:ext cx="320040" cy="457200"/>
+            <a:off x="2286000" y="1371600"/>
+            <a:ext cx="457200" cy="457200"/>
           </a:xfrm>
           <a:prstGeom prst="rect">
             <a:avLst/>
@@ -4101,14 +4341,14 @@
       </p:sp>
       <p:sp>
         <p:nvSpPr>
-          <p:cNvPr id="9" name="Rectangle 8"/>
+          <p:cNvPr id="6" name="Rectangle 5"/>
           <p:cNvSpPr/>
           <p:nvPr/>
         </p:nvSpPr>
         <p:spPr>
           <a:xfrm>
-            <a:off x="4206240" y="1737360"/>
-            <a:ext cx="1645920" cy="822960"/>
+            <a:off x="2743200" y="1188720"/>
+            <a:ext cx="1828800" cy="822960"/>
           </a:xfrm>
           <a:prstGeom prst="rect">
             <a:avLst/>
@@ -4139,32 +4379,32 @@
           <a:lstStyle/>
           <a:p>
             <a:pPr algn="ctr">
-              <a:defRPr sz="1200">
+              <a:defRPr sz="1300">
                 <a:solidFill>
                   <a:srgbClr val="FFFFFF"/>
                 </a:solidFill>
               </a:defRPr>
             </a:pPr>
             <a:r>
-              <a:t>n8n</a:t>
+              <a:t>Filter</a:t>
             </a:r>
             <a:br/>
             <a:r>
-              <a:t>Workflow</a:t>
-            </a:r>
-          </a:p>
-        </p:txBody>
-      </p:sp>
-      <p:sp>
-        <p:nvSpPr>
-          <p:cNvPr id="10" name="TextBox 9"/>
+              <a:t>&amp; Extract</a:t>
+            </a:r>
+          </a:p>
+        </p:txBody>
+      </p:sp>
+      <p:sp>
+        <p:nvSpPr>
+          <p:cNvPr id="7" name="TextBox 6"/>
           <p:cNvSpPr txBox="1"/>
           <p:nvPr/>
         </p:nvSpPr>
         <p:spPr>
           <a:xfrm>
-            <a:off x="5852159" y="1920240"/>
-            <a:ext cx="320040" cy="457200"/>
+            <a:off x="4572000" y="1371600"/>
+            <a:ext cx="457200" cy="457200"/>
           </a:xfrm>
           <a:prstGeom prst="rect">
             <a:avLst/>
@@ -4192,14 +4432,14 @@
       </p:sp>
       <p:sp>
         <p:nvSpPr>
-          <p:cNvPr id="11" name="Rectangle 10"/>
+          <p:cNvPr id="8" name="Rectangle 7"/>
           <p:cNvSpPr/>
           <p:nvPr/>
         </p:nvSpPr>
         <p:spPr>
           <a:xfrm>
-            <a:off x="6172199" y="1737360"/>
-            <a:ext cx="1645920" cy="822960"/>
+            <a:off x="5029200" y="1188720"/>
+            <a:ext cx="1828800" cy="822960"/>
           </a:xfrm>
           <a:prstGeom prst="rect">
             <a:avLst/>
@@ -4230,7 +4470,7 @@
           <a:lstStyle/>
           <a:p>
             <a:pPr algn="ctr">
-              <a:defRPr sz="1200">
+              <a:defRPr sz="1300">
                 <a:solidFill>
                   <a:srgbClr val="FFFFFF"/>
                 </a:solidFill>
@@ -4241,21 +4481,21 @@
             </a:r>
             <a:br/>
             <a:r>
-              <a:t>Ensemble</a:t>
-            </a:r>
-          </a:p>
-        </p:txBody>
-      </p:sp>
-      <p:sp>
-        <p:nvSpPr>
-          <p:cNvPr id="12" name="TextBox 11"/>
+              <a:t>Lookup</a:t>
+            </a:r>
+          </a:p>
+        </p:txBody>
+      </p:sp>
+      <p:sp>
+        <p:nvSpPr>
+          <p:cNvPr id="9" name="TextBox 8"/>
           <p:cNvSpPr txBox="1"/>
           <p:nvPr/>
         </p:nvSpPr>
         <p:spPr>
           <a:xfrm>
-            <a:off x="7818119" y="1920240"/>
-            <a:ext cx="320040" cy="457200"/>
+            <a:off x="6858000" y="1371600"/>
+            <a:ext cx="457200" cy="457200"/>
           </a:xfrm>
           <a:prstGeom prst="rect">
             <a:avLst/>
@@ -4283,14 +4523,14 @@
       </p:sp>
       <p:sp>
         <p:nvSpPr>
-          <p:cNvPr id="13" name="Rectangle 12"/>
+          <p:cNvPr id="10" name="Rectangle 9"/>
           <p:cNvSpPr/>
           <p:nvPr/>
         </p:nvSpPr>
         <p:spPr>
           <a:xfrm>
-            <a:off x="8138160" y="1737360"/>
-            <a:ext cx="1645920" cy="822960"/>
+            <a:off x="7315200" y="1188720"/>
+            <a:ext cx="1828800" cy="822960"/>
           </a:xfrm>
           <a:prstGeom prst="rect">
             <a:avLst/>
@@ -4321,32 +4561,32 @@
           <a:lstStyle/>
           <a:p>
             <a:pPr algn="ctr">
-              <a:defRPr sz="1200">
+              <a:defRPr sz="1300">
                 <a:solidFill>
                   <a:srgbClr val="FFFFFF"/>
                 </a:solidFill>
               </a:defRPr>
             </a:pPr>
             <a:r>
-              <a:t>Ollama</a:t>
+              <a:t>Keputusan</a:t>
             </a:r>
             <a:br/>
             <a:r>
-              <a:t>(AI lokal)</a:t>
-            </a:r>
-          </a:p>
-        </p:txBody>
-      </p:sp>
-      <p:sp>
-        <p:nvSpPr>
-          <p:cNvPr id="14" name="TextBox 13"/>
+              <a:t>(Ollama)</a:t>
+            </a:r>
+          </a:p>
+        </p:txBody>
+      </p:sp>
+      <p:sp>
+        <p:nvSpPr>
+          <p:cNvPr id="11" name="TextBox 10"/>
           <p:cNvSpPr txBox="1"/>
           <p:nvPr/>
         </p:nvSpPr>
         <p:spPr>
           <a:xfrm>
-            <a:off x="9784080" y="1920240"/>
-            <a:ext cx="320040" cy="457200"/>
+            <a:off x="9144000" y="1371600"/>
+            <a:ext cx="457200" cy="457200"/>
           </a:xfrm>
           <a:prstGeom prst="rect">
             <a:avLst/>
@@ -4374,14 +4614,14 @@
       </p:sp>
       <p:sp>
         <p:nvSpPr>
-          <p:cNvPr id="15" name="Rectangle 14"/>
+          <p:cNvPr id="12" name="Rectangle 11"/>
           <p:cNvSpPr/>
           <p:nvPr/>
         </p:nvSpPr>
         <p:spPr>
           <a:xfrm>
-            <a:off x="10104120" y="1737360"/>
-            <a:ext cx="1645920" cy="822960"/>
+            <a:off x="9601200" y="1188720"/>
+            <a:ext cx="1828800" cy="822960"/>
           </a:xfrm>
           <a:prstGeom prst="rect">
             <a:avLst/>
@@ -4412,7 +4652,7 @@
           <a:lstStyle/>
           <a:p>
             <a:pPr algn="ctr">
-              <a:defRPr sz="1200">
+              <a:defRPr sz="1300">
                 <a:solidFill>
                   <a:srgbClr val="FFFFFF"/>
                 </a:solidFill>
@@ -4430,13 +4670,13 @@
       </p:sp>
       <p:sp>
         <p:nvSpPr>
-          <p:cNvPr id="16" name="TextBox 15"/>
+          <p:cNvPr id="13" name="TextBox 12"/>
           <p:cNvSpPr txBox="1"/>
           <p:nvPr/>
         </p:nvSpPr>
         <p:spPr>
           <a:xfrm>
-            <a:off x="457200" y="2926080"/>
+            <a:off x="457200" y="2286000"/>
             <a:ext cx="10972800" cy="457200"/>
           </a:xfrm>
           <a:prstGeom prst="rect">
@@ -4458,22 +4698,22 @@
               </a:defRPr>
             </a:pPr>
             <a:r>
-              <a:t>Keputusan berdasarkan keyakinan:</a:t>
+              <a:t>5 jalur keputusan berdasarkan keyakinan:</a:t>
             </a:r>
           </a:p>
         </p:txBody>
       </p:sp>
       <p:graphicFrame>
         <p:nvGraphicFramePr>
-          <p:cNvPr id="17" name="Table 16"/>
+          <p:cNvPr id="14" name="Table 13"/>
           <p:cNvGraphicFramePr>
             <a:graphicFrameLocks noGrp="1"/>
           </p:cNvGraphicFramePr>
           <p:nvPr/>
         </p:nvGraphicFramePr>
         <p:xfrm>
-          <a:off x="457200" y="3383280"/>
-          <a:ext cx="10972800" cy="2926080"/>
+          <a:off x="457200" y="2743200"/>
+          <a:ext cx="10972800" cy="3200400"/>
         </p:xfrm>
         <a:graphic>
           <a:graphicData uri="http://schemas.openxmlformats.org/drawingml/2006/table">
@@ -4482,10 +4722,11 @@
                 <a:tableStyleId>{5C22544A-7EE6-4342-B048-85BDC9FD1C3A}</a:tableStyleId>
               </a:tblPr>
               <a:tblGrid>
-                <a:gridCol w="4572000"/>
-                <a:gridCol w="6400800"/>
+                <a:gridCol w="3200400"/>
+                <a:gridCol w="2286000"/>
+                <a:gridCol w="5486400"/>
               </a:tblGrid>
-              <a:tr h="487680">
+              <a:tr h="533400">
                 <a:tc>
                   <a:txBody>
                     <a:bodyPr/>
@@ -4499,7 +4740,7 @@
                         </a:defRPr>
                       </a:pPr>
                       <a:r>
-                        <a:t>Situasi</a:t>
+                        <a:t>Kondisi</a:t>
                       </a:r>
                     </a:p>
                   </a:txBody>
@@ -4522,7 +4763,30 @@
                         </a:defRPr>
                       </a:pPr>
                       <a:r>
-                        <a:t>Yang dilakukan</a:t>
+                        <a:t>Tindakan</a:t>
+                      </a:r>
+                    </a:p>
+                  </a:txBody>
+                  <a:tcPr>
+                    <a:solidFill>
+                      <a:srgbClr val="1A568E"/>
+                    </a:solidFill>
+                  </a:tcPr>
+                </a:tc>
+                <a:tc>
+                  <a:txBody>
+                    <a:bodyPr/>
+                    <a:lstStyle/>
+                    <a:p>
+                      <a:pPr>
+                        <a:defRPr sz="1300" b="1">
+                          <a:solidFill>
+                            <a:srgbClr val="FFFFFF"/>
+                          </a:solidFill>
+                        </a:defRPr>
+                      </a:pPr>
+                      <a:r>
+                        <a:t>Keterangan</a:t>
                       </a:r>
                     </a:p>
                   </a:txBody>
@@ -4533,7 +4797,7 @@
                   </a:tcPr>
                 </a:tc>
               </a:tr>
-              <a:tr h="487680">
+              <a:tr h="533400">
                 <a:tc>
                   <a:txBody>
                     <a:bodyPr/>
@@ -4547,7 +4811,7 @@
                         </a:defRPr>
                       </a:pPr>
                       <a:r>
-                        <a:t>VT deteksi &gt;= 20</a:t>
+                        <a:t>VT &gt;= 20 malicious</a:t>
                       </a:r>
                     </a:p>
                   </a:txBody>
@@ -4566,28 +4830,7 @@
                         </a:defRPr>
                       </a:pPr>
                       <a:r>
-                        <a:t>Langsung isolasi file otomatis</a:t>
-                      </a:r>
-                    </a:p>
-                  </a:txBody>
-                  <a:tcPr/>
-                </a:tc>
-              </a:tr>
-              <a:tr h="487680">
-                <a:tc>
-                  <a:txBody>
-                    <a:bodyPr/>
-                    <a:lstStyle/>
-                    <a:p>
-                      <a:pPr>
-                        <a:defRPr sz="1300">
-                          <a:solidFill>
-                            <a:srgbClr val="000000"/>
-                          </a:solidFill>
-                        </a:defRPr>
-                      </a:pPr>
-                      <a:r>
-                        <a:t>VT deteksi 5-19 atau MB match</a:t>
+                        <a:t>Auto isolate</a:t>
                       </a:r>
                     </a:p>
                   </a:txBody>
@@ -4606,14 +4849,14 @@
                         </a:defRPr>
                       </a:pPr>
                       <a:r>
-                        <a:t>Kirim ke Telegram, analis pilih tombol</a:t>
+                        <a:t>Keyakinan tinggi, langsung karantina file</a:t>
                       </a:r>
                     </a:p>
                   </a:txBody>
                   <a:tcPr/>
                 </a:tc>
               </a:tr>
-              <a:tr h="487680">
+              <a:tr h="533400">
                 <a:tc>
                   <a:txBody>
                     <a:bodyPr/>
@@ -4627,7 +4870,7 @@
                         </a:defRPr>
                       </a:pPr>
                       <a:r>
-                        <a:t>VT deteksi 1-4 atau file risky unknown</a:t>
+                        <a:t>VT 5-19 / MB match</a:t>
                       </a:r>
                     </a:p>
                   </a:txBody>
@@ -4646,14 +4889,92 @@
                         </a:defRPr>
                       </a:pPr>
                       <a:r>
-                        <a:t>Kirim notifikasi + minta saran AI</a:t>
+                        <a:t>HITL Telegram</a:t>
+                      </a:r>
+                    </a:p>
+                  </a:txBody>
+                  <a:tcPr/>
+                </a:tc>
+                <a:tc>
+                  <a:txBody>
+                    <a:bodyPr/>
+                    <a:lstStyle/>
+                    <a:p>
+                      <a:pPr>
+                        <a:defRPr sz="1300">
+                          <a:solidFill>
+                            <a:srgbClr val="000000"/>
+                          </a:solidFill>
+                        </a:defRPr>
+                      </a:pPr>
+                      <a:r>
+                        <a:t>Analis pilih: Isolasi atau Abaikan</a:t>
                       </a:r>
                     </a:p>
                   </a:txBody>
                   <a:tcPr/>
                 </a:tc>
               </a:tr>
-              <a:tr h="487680">
+              <a:tr h="533400">
+                <a:tc>
+                  <a:txBody>
+                    <a:bodyPr/>
+                    <a:lstStyle/>
+                    <a:p>
+                      <a:pPr>
+                        <a:defRPr sz="1300">
+                          <a:solidFill>
+                            <a:srgbClr val="000000"/>
+                          </a:solidFill>
+                        </a:defRPr>
+                      </a:pPr>
+                      <a:r>
+                        <a:t>VT 1-4 / risky unknown</a:t>
+                      </a:r>
+                    </a:p>
+                  </a:txBody>
+                  <a:tcPr/>
+                </a:tc>
+                <a:tc>
+                  <a:txBody>
+                    <a:bodyPr/>
+                    <a:lstStyle/>
+                    <a:p>
+                      <a:pPr>
+                        <a:defRPr sz="1300">
+                          <a:solidFill>
+                            <a:srgbClr val="000000"/>
+                          </a:solidFill>
+                        </a:defRPr>
+                      </a:pPr>
+                      <a:r>
+                        <a:t>HITL + LLM advisory</a:t>
+                      </a:r>
+                    </a:p>
+                  </a:txBody>
+                  <a:tcPr/>
+                </a:tc>
+                <a:tc>
+                  <a:txBody>
+                    <a:bodyPr/>
+                    <a:lstStyle/>
+                    <a:p>
+                      <a:pPr>
+                        <a:defRPr sz="1300">
+                          <a:solidFill>
+                            <a:srgbClr val="000000"/>
+                          </a:solidFill>
+                        </a:defRPr>
+                      </a:pPr>
+                      <a:r>
+                        <a:t>Saran AI ditambahkan ke notifikasi</a:t>
+                      </a:r>
+                    </a:p>
+                  </a:txBody>
+                  <a:tcPr/>
+                </a:tc>
+              </a:tr>
+              <a:tr h="533400">
                 <a:tc>
                   <a:txBody>
                     <a:bodyPr/>
@@ -4686,14 +5007,33 @@
                         </a:defRPr>
                       </a:pPr>
                       <a:r>
-                        <a:t>Tandai degradasi, minta verifikasi manual</a:t>
+                        <a:t>Degrade + advisory</a:t>
+                      </a:r>
+                    </a:p>
+                  </a:txBody>
+                  <a:tcPr/>
+                </a:tc>
+                <a:tc>
+                  <a:txBody>
+                    <a:bodyPr/>
+                    <a:lstStyle/>
+                    <a:p>
+                      <a:pPr>
+                        <a:defRPr sz="1300">
+                          <a:solidFill>
+                            <a:srgbClr val="000000"/>
+                          </a:solidFill>
+                        </a:defRPr>
+                      </a:pPr>
+                      <a:r>
+                        <a:t>Sistem jujur: 'tidak bisa verifikasi'</a:t>
                       </a:r>
                     </a:p>
                   </a:txBody>
                   <a:tcPr/>
                 </a:tc>
               </a:tr>
-              <a:tr h="487680">
+              <a:tr h="533400">
                 <a:tc>
                   <a:txBody>
                     <a:bodyPr/>
@@ -4726,7 +5066,26 @@
                         </a:defRPr>
                       </a:pPr>
                       <a:r>
-                        <a:t>Diam saja (tidak ganggu analis)</a:t>
+                        <a:t>Silent</a:t>
+                      </a:r>
+                    </a:p>
+                  </a:txBody>
+                  <a:tcPr/>
+                </a:tc>
+                <a:tc>
+                  <a:txBody>
+                    <a:bodyPr/>
+                    <a:lstStyle/>
+                    <a:p>
+                      <a:pPr>
+                        <a:defRPr sz="1300">
+                          <a:solidFill>
+                            <a:srgbClr val="000000"/>
+                          </a:solidFill>
+                        </a:defRPr>
+                      </a:pPr>
+                      <a:r>
+                        <a:t>Tidak ganggu analis</a:t>
                       </a:r>
                     </a:p>
                   </a:txBody>
@@ -4745,7 +5104,7 @@
 </p:sld>
 </file>
 
-<file path=ppt/slides/slide4.xml><?xml version="1.0" encoding="utf-8"?>
+<file path=ppt/slides/slide5.xml><?xml version="1.0" encoding="utf-8"?>
 <p:sld xmlns:a="http://schemas.openxmlformats.org/drawingml/2006/main" xmlns:p="http://schemas.openxmlformats.org/presentationml/2006/main" xmlns:r="http://schemas.openxmlformats.org/officeDocument/2006/relationships">
   <p:cSld>
     <p:spTree>
@@ -5285,11 +5644,11 @@
           <a:p>
             <a:pPr>
               <a:spcBef>
-                <a:spcPts val="600"/>
+                <a:spcPts val="500"/>
               </a:spcBef>
               <a:defRPr sz="1400">
                 <a:solidFill>
-                  <a:srgbClr val="555555"/>
+                  <a:srgbClr val="666666"/>
                 </a:solidFill>
               </a:defRPr>
             </a:pPr>
@@ -5300,11 +5659,11 @@
           <a:p>
             <a:pPr>
               <a:spcBef>
-                <a:spcPts val="600"/>
+                <a:spcPts val="500"/>
               </a:spcBef>
               <a:defRPr sz="1400">
                 <a:solidFill>
-                  <a:srgbClr val="555555"/>
+                  <a:srgbClr val="666666"/>
                 </a:solidFill>
               </a:defRPr>
             </a:pPr>
@@ -5315,11 +5674,11 @@
           <a:p>
             <a:pPr>
               <a:spcBef>
-                <a:spcPts val="600"/>
+                <a:spcPts val="500"/>
               </a:spcBef>
               <a:defRPr sz="1400">
                 <a:solidFill>
-                  <a:srgbClr val="555555"/>
+                  <a:srgbClr val="666666"/>
                 </a:solidFill>
               </a:defRPr>
             </a:pPr>
@@ -5330,11 +5689,11 @@
           <a:p>
             <a:pPr>
               <a:spcBef>
-                <a:spcPts val="600"/>
+                <a:spcPts val="500"/>
               </a:spcBef>
               <a:defRPr sz="1400">
                 <a:solidFill>
-                  <a:srgbClr val="555555"/>
+                  <a:srgbClr val="666666"/>
                 </a:solidFill>
               </a:defRPr>
             </a:pPr>
@@ -5345,11 +5704,11 @@
           <a:p>
             <a:pPr>
               <a:spcBef>
-                <a:spcPts val="600"/>
+                <a:spcPts val="500"/>
               </a:spcBef>
               <a:defRPr sz="1400">
                 <a:solidFill>
-                  <a:srgbClr val="555555"/>
+                  <a:srgbClr val="666666"/>
                 </a:solidFill>
               </a:defRPr>
             </a:pPr>
@@ -5367,7 +5726,7 @@
 </p:sld>
 </file>
 
-<file path=ppt/slides/slide5.xml><?xml version="1.0" encoding="utf-8"?>
+<file path=ppt/slides/slide6.xml><?xml version="1.0" encoding="utf-8"?>
 <p:sld xmlns:a="http://schemas.openxmlformats.org/drawingml/2006/main" xmlns:p="http://schemas.openxmlformats.org/presentationml/2006/main" xmlns:r="http://schemas.openxmlformats.org/officeDocument/2006/relationships">
   <p:cSld>
     <p:spTree>
@@ -5479,7 +5838,7 @@
           <a:p>
             <a:pPr>
               <a:spcBef>
-                <a:spcPts val="600"/>
+                <a:spcPts val="500"/>
               </a:spcBef>
               <a:defRPr sz="1500">
                 <a:solidFill>
@@ -5494,7 +5853,7 @@
           <a:p>
             <a:pPr>
               <a:spcBef>
-                <a:spcPts val="600"/>
+                <a:spcPts val="500"/>
               </a:spcBef>
               <a:defRPr sz="1500">
                 <a:solidFill>
@@ -5509,7 +5868,7 @@
           <a:p>
             <a:pPr>
               <a:spcBef>
-                <a:spcPts val="600"/>
+                <a:spcPts val="500"/>
               </a:spcBef>
               <a:defRPr sz="1500">
                 <a:solidFill>
@@ -5524,7 +5883,7 @@
           <a:p>
             <a:pPr>
               <a:spcBef>
-                <a:spcPts val="600"/>
+                <a:spcPts val="500"/>
               </a:spcBef>
               <a:defRPr sz="1500">
                 <a:solidFill>
@@ -5539,7 +5898,7 @@
           <a:p>
             <a:pPr>
               <a:spcBef>
-                <a:spcPts val="600"/>
+                <a:spcPts val="500"/>
               </a:spcBef>
               <a:defRPr sz="1500">
                 <a:solidFill>
@@ -5554,7 +5913,7 @@
           <a:p>
             <a:pPr>
               <a:spcBef>
-                <a:spcPts val="600"/>
+                <a:spcPts val="500"/>
               </a:spcBef>
               <a:defRPr sz="1500">
                 <a:solidFill>
@@ -5569,7 +5928,7 @@
           <a:p>
             <a:pPr>
               <a:spcBef>
-                <a:spcPts val="600"/>
+                <a:spcPts val="500"/>
               </a:spcBef>
               <a:defRPr sz="1500">
                 <a:solidFill>
@@ -5584,7 +5943,7 @@
           <a:p>
             <a:pPr>
               <a:spcBef>
-                <a:spcPts val="600"/>
+                <a:spcPts val="500"/>
               </a:spcBef>
               <a:defRPr sz="1500">
                 <a:solidFill>
@@ -5599,7 +5958,7 @@
           <a:p>
             <a:pPr>
               <a:spcBef>
-                <a:spcPts val="600"/>
+                <a:spcPts val="500"/>
               </a:spcBef>
               <a:defRPr sz="1500">
                 <a:solidFill>
@@ -5637,7 +5996,7 @@
           <a:p>
             <a:pPr>
               <a:spcBef>
-                <a:spcPts val="600"/>
+                <a:spcPts val="500"/>
               </a:spcBef>
               <a:defRPr sz="1500">
                 <a:solidFill>
@@ -5652,7 +6011,7 @@
           <a:p>
             <a:pPr>
               <a:spcBef>
-                <a:spcPts val="600"/>
+                <a:spcPts val="500"/>
               </a:spcBef>
               <a:defRPr sz="1500">
                 <a:solidFill>
@@ -5667,7 +6026,7 @@
           <a:p>
             <a:pPr>
               <a:spcBef>
-                <a:spcPts val="600"/>
+                <a:spcPts val="500"/>
               </a:spcBef>
               <a:defRPr sz="1500">
                 <a:solidFill>
@@ -5682,7 +6041,7 @@
           <a:p>
             <a:pPr>
               <a:spcBef>
-                <a:spcPts val="600"/>
+                <a:spcPts val="500"/>
               </a:spcBef>
               <a:defRPr sz="1500">
                 <a:solidFill>
@@ -5697,7 +6056,7 @@
           <a:p>
             <a:pPr>
               <a:spcBef>
-                <a:spcPts val="600"/>
+                <a:spcPts val="500"/>
               </a:spcBef>
               <a:defRPr sz="1500">
                 <a:solidFill>
@@ -5712,7 +6071,7 @@
           <a:p>
             <a:pPr>
               <a:spcBef>
-                <a:spcPts val="600"/>
+                <a:spcPts val="500"/>
               </a:spcBef>
               <a:defRPr sz="1500">
                 <a:solidFill>
@@ -5727,7 +6086,7 @@
           <a:p>
             <a:pPr>
               <a:spcBef>
-                <a:spcPts val="600"/>
+                <a:spcPts val="500"/>
               </a:spcBef>
               <a:defRPr sz="1500">
                 <a:solidFill>
@@ -5742,7 +6101,7 @@
           <a:p>
             <a:pPr>
               <a:spcBef>
-                <a:spcPts val="600"/>
+                <a:spcPts val="500"/>
               </a:spcBef>
               <a:defRPr sz="1500">
                 <a:solidFill>
@@ -5757,7 +6116,7 @@
           <a:p>
             <a:pPr>
               <a:spcBef>
-                <a:spcPts val="600"/>
+                <a:spcPts val="500"/>
               </a:spcBef>
               <a:defRPr sz="1500">
                 <a:solidFill>
@@ -5795,11 +6154,11 @@
           <a:p>
             <a:pPr>
               <a:spcBef>
-                <a:spcPts val="600"/>
+                <a:spcPts val="500"/>
               </a:spcBef>
               <a:defRPr sz="1400">
                 <a:solidFill>
-                  <a:srgbClr val="555555"/>
+                  <a:srgbClr val="666666"/>
                 </a:solidFill>
               </a:defRPr>
             </a:pPr>
@@ -5810,11 +6169,11 @@
           <a:p>
             <a:pPr>
               <a:spcBef>
-                <a:spcPts val="600"/>
+                <a:spcPts val="500"/>
               </a:spcBef>
               <a:defRPr sz="1400">
                 <a:solidFill>
-                  <a:srgbClr val="555555"/>
+                  <a:srgbClr val="666666"/>
                 </a:solidFill>
               </a:defRPr>
             </a:pPr>
@@ -5825,11 +6184,11 @@
           <a:p>
             <a:pPr>
               <a:spcBef>
-                <a:spcPts val="600"/>
+                <a:spcPts val="500"/>
               </a:spcBef>
               <a:defRPr sz="1400">
                 <a:solidFill>
-                  <a:srgbClr val="555555"/>
+                  <a:srgbClr val="666666"/>
                 </a:solidFill>
               </a:defRPr>
             </a:pPr>
@@ -5840,11 +6199,11 @@
           <a:p>
             <a:pPr>
               <a:spcBef>
-                <a:spcPts val="600"/>
+                <a:spcPts val="500"/>
               </a:spcBef>
               <a:defRPr sz="1400">
                 <a:solidFill>
-                  <a:srgbClr val="555555"/>
+                  <a:srgbClr val="666666"/>
                 </a:solidFill>
               </a:defRPr>
             </a:pPr>
@@ -5855,11 +6214,11 @@
           <a:p>
             <a:pPr>
               <a:spcBef>
-                <a:spcPts val="600"/>
+                <a:spcPts val="500"/>
               </a:spcBef>
               <a:defRPr sz="1400">
                 <a:solidFill>
-                  <a:srgbClr val="555555"/>
+                  <a:srgbClr val="666666"/>
                 </a:solidFill>
               </a:defRPr>
             </a:pPr>
@@ -5877,7 +6236,7 @@
 </p:sld>
 </file>
 
-<file path=ppt/slides/slide6.xml><?xml version="1.0" encoding="utf-8"?>
+<file path=ppt/slides/slide7.xml><?xml version="1.0" encoding="utf-8"?>
 <p:sld xmlns:a="http://schemas.openxmlformats.org/drawingml/2006/main" xmlns:p="http://schemas.openxmlformats.org/presentationml/2006/main" xmlns:r="http://schemas.openxmlformats.org/officeDocument/2006/relationships">
   <p:cSld>
     <p:spTree>
@@ -5989,7 +6348,7 @@
           <a:p>
             <a:pPr>
               <a:spcBef>
-                <a:spcPts val="600"/>
+                <a:spcPts val="500"/>
               </a:spcBef>
               <a:defRPr sz="1500">
                 <a:solidFill>
@@ -6004,7 +6363,7 @@
           <a:p>
             <a:pPr>
               <a:spcBef>
-                <a:spcPts val="600"/>
+                <a:spcPts val="500"/>
               </a:spcBef>
               <a:defRPr sz="1500">
                 <a:solidFill>
@@ -6019,7 +6378,7 @@
           <a:p>
             <a:pPr>
               <a:spcBef>
-                <a:spcPts val="600"/>
+                <a:spcPts val="500"/>
               </a:spcBef>
               <a:defRPr sz="1500">
                 <a:solidFill>
@@ -6034,7 +6393,7 @@
           <a:p>
             <a:pPr>
               <a:spcBef>
-                <a:spcPts val="600"/>
+                <a:spcPts val="500"/>
               </a:spcBef>
               <a:defRPr sz="1500">
                 <a:solidFill>
@@ -6046,7 +6405,7 @@
           <a:p>
             <a:pPr>
               <a:spcBef>
-                <a:spcPts val="600"/>
+                <a:spcPts val="500"/>
               </a:spcBef>
               <a:defRPr sz="1500">
                 <a:solidFill>
@@ -6061,7 +6420,7 @@
           <a:p>
             <a:pPr>
               <a:spcBef>
-                <a:spcPts val="600"/>
+                <a:spcPts val="500"/>
               </a:spcBef>
               <a:defRPr sz="1500">
                 <a:solidFill>
@@ -6076,7 +6435,7 @@
           <a:p>
             <a:pPr>
               <a:spcBef>
-                <a:spcPts val="600"/>
+                <a:spcPts val="500"/>
               </a:spcBef>
               <a:defRPr sz="1500">
                 <a:solidFill>
@@ -6091,7 +6450,7 @@
           <a:p>
             <a:pPr>
               <a:spcBef>
-                <a:spcPts val="600"/>
+                <a:spcPts val="500"/>
               </a:spcBef>
               <a:defRPr sz="1500">
                 <a:solidFill>
@@ -6103,7 +6462,7 @@
           <a:p>
             <a:pPr>
               <a:spcBef>
-                <a:spcPts val="600"/>
+                <a:spcPts val="500"/>
               </a:spcBef>
               <a:defRPr sz="1500">
                 <a:solidFill>
@@ -6118,7 +6477,7 @@
           <a:p>
             <a:pPr>
               <a:spcBef>
-                <a:spcPts val="600"/>
+                <a:spcPts val="500"/>
               </a:spcBef>
               <a:defRPr sz="1500">
                 <a:solidFill>
@@ -6133,7 +6492,7 @@
           <a:p>
             <a:pPr>
               <a:spcBef>
-                <a:spcPts val="600"/>
+                <a:spcPts val="500"/>
               </a:spcBef>
               <a:defRPr sz="1500">
                 <a:solidFill>
@@ -6148,7 +6507,7 @@
           <a:p>
             <a:pPr>
               <a:spcBef>
-                <a:spcPts val="600"/>
+                <a:spcPts val="500"/>
               </a:spcBef>
               <a:defRPr sz="1500">
                 <a:solidFill>
@@ -6160,7 +6519,7 @@
           <a:p>
             <a:pPr>
               <a:spcBef>
-                <a:spcPts val="600"/>
+                <a:spcPts val="500"/>
               </a:spcBef>
               <a:defRPr sz="1500">
                 <a:solidFill>
@@ -6175,7 +6534,7 @@
           <a:p>
             <a:pPr>
               <a:spcBef>
-                <a:spcPts val="600"/>
+                <a:spcPts val="500"/>
               </a:spcBef>
               <a:defRPr sz="1500">
                 <a:solidFill>
@@ -6197,7 +6556,7 @@
 </p:sld>
 </file>
 
-<file path=ppt/slides/slide7.xml><?xml version="1.0" encoding="utf-8"?>
+<file path=ppt/slides/slide8.xml><?xml version="1.0" encoding="utf-8"?>
 <p:sld xmlns:a="http://schemas.openxmlformats.org/drawingml/2006/main" xmlns:p="http://schemas.openxmlformats.org/presentationml/2006/main" xmlns:r="http://schemas.openxmlformats.org/officeDocument/2006/relationships">
   <p:cSld>
     <p:spTree>
@@ -6310,7 +6669,7 @@
             <a:pPr algn="ctr">
               <a:defRPr sz="1800" b="0">
                 <a:solidFill>
-                  <a:srgbClr val="555555"/>
+                  <a:srgbClr val="666666"/>
                 </a:solidFill>
               </a:defRPr>
             </a:pPr>

</xml_diff>

<commit_message>
docs: PPT v5 — tambah tabel perbandingan + roadmap
Slide baru:
- Slide 2: Latar belakang (masalah SOC + yang ditawarkan)
- Slide 3: Tabel perbandingan (SOC Manual vs SOAR Komersial vs Shuffle vs Sistem Ini)
- Slide 7: Tabel roadmap (18 item, status + tanggal)

Total 9 slides:
1. Cover
2. Latar Belakang
3. Perbandingan (apa yang unggul)
4. Arsitektur (diagram)
5. Alur Keputusan
6. Hasil Pengukuran
7. Roadmap Pengerjaan
8. Rencana ke Depan
9. Penutup
</commit_message>
<xml_diff>
--- a/docs/BIMBINGAN-TA-SOAR.pptx
+++ b/docs/BIMBINGAN-TA-SOAR.pptx
@@ -13,6 +13,7 @@
     <p:sldId id="261" r:id="rId12"/>
     <p:sldId id="262" r:id="rId13"/>
     <p:sldId id="263" r:id="rId14"/>
+    <p:sldId id="264" r:id="rId15"/>
   </p:sldIdLst>
   <p:sldSz cx="12191695" cy="6858000" type="screen4x3"/>
   <p:notesSz cx="6858000" cy="9144000"/>
@@ -3369,7 +3370,7 @@
               </a:defRPr>
             </a:pPr>
             <a:r>
-              <a:t>Progress Pengerjaan</a:t>
+              <a:t>Latar Belakang</a:t>
             </a:r>
           </a:p>
         </p:txBody>
@@ -3383,7 +3384,7 @@
         <p:spPr>
           <a:xfrm>
             <a:off x="457200" y="822960"/>
-            <a:ext cx="3657600" cy="25400"/>
+            <a:ext cx="2743200" cy="25400"/>
           </a:xfrm>
           <a:prstGeom prst="rect">
             <a:avLst/>
@@ -3426,7 +3427,7 @@
         <p:spPr>
           <a:xfrm>
             <a:off x="457200" y="1097280"/>
-            <a:ext cx="5303520" cy="5029200"/>
+            <a:ext cx="10972800" cy="1828800"/>
           </a:xfrm>
           <a:prstGeom prst="rect">
             <a:avLst/>
@@ -3450,7 +3451,7 @@
               </a:defRPr>
             </a:pPr>
             <a:r>
-              <a:t>Bug fix &amp; deteksi:</a:t>
+              <a:t>Masalah utama di SOC (Security Operations Center):</a:t>
             </a:r>
           </a:p>
           <a:p>
@@ -3465,7 +3466,7 @@
               </a:defRPr>
             </a:pPr>
             <a:r>
-              <a:t>  - block-domain sekarang persist, tidak hilang saat restart</a:t>
+              <a:t>  - Alert fatigue: 67% alert diabaikan karena terlalu banyak false positive</a:t>
             </a:r>
           </a:p>
           <a:p>
@@ -3480,7 +3481,7 @@
               </a:defRPr>
             </a:pPr>
             <a:r>
-              <a:t>  - notifikasi ganda untuk 1 file sudah diperbaiki</a:t>
+              <a:t>  - Response manual: analis butuh menit-jam untuk tangani 1 alert</a:t>
             </a:r>
           </a:p>
           <a:p>
@@ -3495,7 +3496,7 @@
               </a:defRPr>
             </a:pPr>
             <a:r>
-              <a:t>  - file berekstensi berisiko (.sh/.exe) yang tak dikenal VT minta review</a:t>
+              <a:t>  - SOAR komersial mahal (Splunk SOAR, Palo Alto XSOAM)</a:t>
             </a:r>
           </a:p>
           <a:p>
@@ -3510,9 +3511,32 @@
               </a:defRPr>
             </a:pPr>
             <a:r>
-              <a:t>  - file tanpa ekstensi tapi ada execute bit juga tertangkap</a:t>
-            </a:r>
-          </a:p>
+              <a:t>  - SOAR open-source (Shuffle, Cortex) masih punya keterbatasan</a:t>
+            </a:r>
+          </a:p>
+        </p:txBody>
+      </p:sp>
+      <p:sp>
+        <p:nvSpPr>
+          <p:cNvPr id="5" name="TextBox 4"/>
+          <p:cNvSpPr txBox="1"/>
+          <p:nvPr/>
+        </p:nvSpPr>
+        <p:spPr>
+          <a:xfrm>
+            <a:off x="457200" y="2926080"/>
+            <a:ext cx="10972800" cy="1828800"/>
+          </a:xfrm>
+          <a:prstGeom prst="rect">
+            <a:avLst/>
+          </a:prstGeom>
+          <a:noFill/>
+        </p:spPr>
+        <p:txBody>
+          <a:bodyPr wrap="square">
+            <a:spAutoFit/>
+          </a:bodyPr>
+          <a:lstStyle/>
           <a:p>
             <a:pPr>
               <a:spcBef>
@@ -3524,6 +3548,9 @@
                 </a:solidFill>
               </a:defRPr>
             </a:pPr>
+            <a:r>
+              <a:t>Yang ditawarkan tugas akhir ini:</a:t>
+            </a:r>
           </a:p>
           <a:p>
             <a:pPr>
@@ -3537,7 +3564,7 @@
               </a:defRPr>
             </a:pPr>
             <a:r>
-              <a:t>Threat intelligence:</a:t>
+              <a:t>  - SOAR open-source berbasis n8n (gratis, fleksibel)</a:t>
             </a:r>
           </a:p>
           <a:p>
@@ -3552,7 +3579,7 @@
               </a:defRPr>
             </a:pPr>
             <a:r>
-              <a:t>  - sekarang pakai 2 sumber: VirusTotal + MalwareBazaar</a:t>
+              <a:t>  - Confidence-based: keputusan berdasarkan keyakinan, bukan tebakan</a:t>
             </a:r>
           </a:p>
           <a:p>
@@ -3567,7 +3594,7 @@
               </a:defRPr>
             </a:pPr>
             <a:r>
-              <a:t>  - cache VT TTL diferensial (bersih 24 jam, berbahaya 7 hari)</a:t>
+              <a:t>  - Explainable: setiap notifikasi ada alasan kenapa dianggap berbahaya</a:t>
             </a:r>
           </a:p>
           <a:p>
@@ -3582,207 +3609,7 @@
               </a:defRPr>
             </a:pPr>
             <a:r>
-              <a:t>  - phishing proaktif: fetch URLhaus tiap jam, block sebelum user klik</a:t>
-            </a:r>
-          </a:p>
-          <a:p>
-            <a:pPr>
-              <a:spcBef>
-                <a:spcPts val="500"/>
-              </a:spcBef>
-              <a:defRPr sz="1500">
-                <a:solidFill>
-                  <a:srgbClr val="000000"/>
-                </a:solidFill>
-              </a:defRPr>
-            </a:pPr>
-            <a:r>
-              <a:t>  - kalau VT error, sistem tetap jalan dan kasih tahu analis</a:t>
-            </a:r>
-          </a:p>
-        </p:txBody>
-      </p:sp>
-      <p:sp>
-        <p:nvSpPr>
-          <p:cNvPr id="5" name="TextBox 4"/>
-          <p:cNvSpPr txBox="1"/>
-          <p:nvPr/>
-        </p:nvSpPr>
-        <p:spPr>
-          <a:xfrm>
-            <a:off x="6217920" y="1097280"/>
-            <a:ext cx="5303520" cy="5029200"/>
-          </a:xfrm>
-          <a:prstGeom prst="rect">
-            <a:avLst/>
-          </a:prstGeom>
-          <a:noFill/>
-        </p:spPr>
-        <p:txBody>
-          <a:bodyPr wrap="square">
-            <a:spAutoFit/>
-          </a:bodyPr>
-          <a:lstStyle/>
-          <a:p>
-            <a:pPr>
-              <a:spcBef>
-                <a:spcPts val="500"/>
-              </a:spcBef>
-              <a:defRPr sz="1500">
-                <a:solidFill>
-                  <a:srgbClr val="000000"/>
-                </a:solidFill>
-              </a:defRPr>
-            </a:pPr>
-            <a:r>
-              <a:t>Infrastruktur:</a:t>
-            </a:r>
-          </a:p>
-          <a:p>
-            <a:pPr>
-              <a:spcBef>
-                <a:spcPts val="500"/>
-              </a:spcBef>
-              <a:defRPr sz="1500">
-                <a:solidFill>
-                  <a:srgbClr val="000000"/>
-                </a:solidFill>
-              </a:defRPr>
-            </a:pPr>
-            <a:r>
-              <a:t>  - n8n di-update ke 2.36.9 (di atas semua CVE 2026)</a:t>
-            </a:r>
-          </a:p>
-          <a:p>
-            <a:pPr>
-              <a:spcBef>
-                <a:spcPts val="500"/>
-              </a:spcBef>
-              <a:defRPr sz="1500">
-                <a:solidFill>
-                  <a:srgbClr val="000000"/>
-                </a:solidFill>
-              </a:defRPr>
-            </a:pPr>
-            <a:r>
-              <a:t>  - hardening: Caddy reverse-proxy + TLS + basic auth</a:t>
-            </a:r>
-          </a:p>
-          <a:p>
-            <a:pPr>
-              <a:spcBef>
-                <a:spcPts val="500"/>
-              </a:spcBef>
-              <a:defRPr sz="1500">
-                <a:solidFill>
-                  <a:srgbClr val="000000"/>
-                </a:solidFill>
-              </a:defRPr>
-            </a:pPr>
-            <a:r>
-              <a:t>  - IaC pakai Ansible playbook (idempoten)</a:t>
-            </a:r>
-          </a:p>
-          <a:p>
-            <a:pPr>
-              <a:spcBef>
-                <a:spcPts val="500"/>
-              </a:spcBef>
-              <a:defRPr sz="1500">
-                <a:solidFill>
-                  <a:srgbClr val="000000"/>
-                </a:solidFill>
-              </a:defRPr>
-            </a:pPr>
-            <a:r>
-              <a:t>  - health monitor: cek agent/n8n/Ollama, alert saat status berubah</a:t>
-            </a:r>
-          </a:p>
-          <a:p>
-            <a:pPr>
-              <a:spcBef>
-                <a:spcPts val="500"/>
-              </a:spcBef>
-              <a:defRPr sz="1500">
-                <a:solidFill>
-                  <a:srgbClr val="000000"/>
-                </a:solidFill>
-              </a:defRPr>
-            </a:pPr>
-          </a:p>
-          <a:p>
-            <a:pPr>
-              <a:spcBef>
-                <a:spcPts val="500"/>
-              </a:spcBef>
-              <a:defRPr sz="1500">
-                <a:solidFill>
-                  <a:srgbClr val="000000"/>
-                </a:solidFill>
-              </a:defRPr>
-            </a:pPr>
-            <a:r>
-              <a:t>Pengukuran:</a:t>
-            </a:r>
-          </a:p>
-          <a:p>
-            <a:pPr>
-              <a:spcBef>
-                <a:spcPts val="500"/>
-              </a:spcBef>
-              <a:defRPr sz="1500">
-                <a:solidFill>
-                  <a:srgbClr val="000000"/>
-                </a:solidFill>
-              </a:defRPr>
-            </a:pPr>
-            <a:r>
-              <a:t>  - benchmark udah jalan: throughput 34 alert/detik</a:t>
-            </a:r>
-          </a:p>
-          <a:p>
-            <a:pPr>
-              <a:spcBef>
-                <a:spcPts val="500"/>
-              </a:spcBef>
-              <a:defRPr sz="1500">
-                <a:solidFill>
-                  <a:srgbClr val="000000"/>
-                </a:solidFill>
-              </a:defRPr>
-            </a:pPr>
-            <a:r>
-              <a:t>  - FN rate 0% (15/15 file berisiko ketangkep)</a:t>
-            </a:r>
-          </a:p>
-          <a:p>
-            <a:pPr>
-              <a:spcBef>
-                <a:spcPts val="500"/>
-              </a:spcBef>
-              <a:defRPr sz="1500">
-                <a:solidFill>
-                  <a:srgbClr val="000000"/>
-                </a:solidFill>
-              </a:defRPr>
-            </a:pPr>
-            <a:r>
-              <a:t>  - FP suppression 100% (8 alert baseline -&gt; 0 notifikasi)</a:t>
-            </a:r>
-          </a:p>
-          <a:p>
-            <a:pPr>
-              <a:spcBef>
-                <a:spcPts val="500"/>
-              </a:spcBef>
-              <a:defRPr sz="1500">
-                <a:solidFill>
-                  <a:srgbClr val="000000"/>
-                </a:solidFill>
-              </a:defRPr>
-            </a:pPr>
-            <a:r>
-              <a:t>  - mapping ke MITRE ATT&amp;CK: 10 teknik tercakup</a:t>
+              <a:t>  - Self-aware: tahu kapan deteksinya sedang tidak akurat</a:t>
             </a:r>
           </a:p>
         </p:txBody>
@@ -3796,6 +3623,1236 @@
 </file>
 
 <file path=ppt/slides/slide3.xml><?xml version="1.0" encoding="utf-8"?>
+<p:sld xmlns:a="http://schemas.openxmlformats.org/drawingml/2006/main" xmlns:p="http://schemas.openxmlformats.org/presentationml/2006/main" xmlns:r="http://schemas.openxmlformats.org/officeDocument/2006/relationships">
+  <p:cSld>
+    <p:spTree>
+      <p:nvGrpSpPr>
+        <p:cNvPr id="1" name=""/>
+        <p:cNvGrpSpPr/>
+        <p:nvPr/>
+      </p:nvGrpSpPr>
+      <p:grpSpPr/>
+      <p:sp>
+        <p:nvSpPr>
+          <p:cNvPr id="2" name="TextBox 1"/>
+          <p:cNvSpPr txBox="1"/>
+          <p:nvPr/>
+        </p:nvSpPr>
+        <p:spPr>
+          <a:xfrm>
+            <a:off x="457200" y="274320"/>
+            <a:ext cx="10972800" cy="548640"/>
+          </a:xfrm>
+          <a:prstGeom prst="rect">
+            <a:avLst/>
+          </a:prstGeom>
+          <a:noFill/>
+        </p:spPr>
+        <p:txBody>
+          <a:bodyPr wrap="square">
+            <a:spAutoFit/>
+          </a:bodyPr>
+          <a:lstStyle/>
+          <a:p>
+            <a:pPr algn="l">
+              <a:defRPr sz="2800" b="1">
+                <a:solidFill>
+                  <a:srgbClr val="1A568E"/>
+                </a:solidFill>
+              </a:defRPr>
+            </a:pPr>
+            <a:r>
+              <a:t>Perbandingan dengan Pendekatan Lain</a:t>
+            </a:r>
+          </a:p>
+        </p:txBody>
+      </p:sp>
+      <p:sp>
+        <p:nvSpPr>
+          <p:cNvPr id="3" name="Rectangle 2"/>
+          <p:cNvSpPr/>
+          <p:nvPr/>
+        </p:nvSpPr>
+        <p:spPr>
+          <a:xfrm>
+            <a:off x="457200" y="822960"/>
+            <a:ext cx="4572000" cy="25400"/>
+          </a:xfrm>
+          <a:prstGeom prst="rect">
+            <a:avLst/>
+          </a:prstGeom>
+          <a:solidFill>
+            <a:srgbClr val="1A568E"/>
+          </a:solidFill>
+          <a:ln>
+            <a:noFill/>
+          </a:ln>
+        </p:spPr>
+        <p:style>
+          <a:lnRef idx="1">
+            <a:schemeClr val="accent1"/>
+          </a:lnRef>
+          <a:fillRef idx="3">
+            <a:schemeClr val="accent1"/>
+          </a:fillRef>
+          <a:effectRef idx="2">
+            <a:schemeClr val="accent1"/>
+          </a:effectRef>
+          <a:fontRef idx="minor">
+            <a:schemeClr val="lt1"/>
+          </a:fontRef>
+        </p:style>
+        <p:txBody>
+          <a:bodyPr rtlCol="0" anchor="ctr"/>
+          <a:lstStyle/>
+          <a:p>
+            <a:pPr algn="ctr"/>
+          </a:p>
+        </p:txBody>
+      </p:sp>
+      <p:graphicFrame>
+        <p:nvGraphicFramePr>
+          <p:cNvPr id="4" name="Table 3"/>
+          <p:cNvGraphicFramePr>
+            <a:graphicFrameLocks noGrp="1"/>
+          </p:cNvGraphicFramePr>
+          <p:nvPr/>
+        </p:nvGraphicFramePr>
+        <p:xfrm>
+          <a:off x="457200" y="1097280"/>
+          <a:ext cx="11247120" cy="5029200"/>
+        </p:xfrm>
+        <a:graphic>
+          <a:graphicData uri="http://schemas.openxmlformats.org/drawingml/2006/table">
+            <a:tbl>
+              <a:tblPr firstRow="1" bandRow="1">
+                <a:tableStyleId>{5C22544A-7EE6-4342-B048-85BDC9FD1C3A}</a:tableStyleId>
+              </a:tblPr>
+              <a:tblGrid>
+                <a:gridCol w="2011680"/>
+                <a:gridCol w="2103120"/>
+                <a:gridCol w="2377440"/>
+                <a:gridCol w="2286000"/>
+                <a:gridCol w="2468880"/>
+              </a:tblGrid>
+              <a:tr h="502920">
+                <a:tc>
+                  <a:txBody>
+                    <a:bodyPr/>
+                    <a:lstStyle/>
+                    <a:p>
+                      <a:pPr>
+                        <a:defRPr sz="1200" b="1">
+                          <a:solidFill>
+                            <a:srgbClr val="FFFFFF"/>
+                          </a:solidFill>
+                        </a:defRPr>
+                      </a:pPr>
+                      <a:r>
+                        <a:t>Aspek</a:t>
+                      </a:r>
+                    </a:p>
+                  </a:txBody>
+                  <a:tcPr>
+                    <a:solidFill>
+                      <a:srgbClr val="1A568E"/>
+                    </a:solidFill>
+                  </a:tcPr>
+                </a:tc>
+                <a:tc>
+                  <a:txBody>
+                    <a:bodyPr/>
+                    <a:lstStyle/>
+                    <a:p>
+                      <a:pPr>
+                        <a:defRPr sz="1200" b="1">
+                          <a:solidFill>
+                            <a:srgbClr val="FFFFFF"/>
+                          </a:solidFill>
+                        </a:defRPr>
+                      </a:pPr>
+                      <a:r>
+                        <a:t>SOC Manual</a:t>
+                      </a:r>
+                    </a:p>
+                  </a:txBody>
+                  <a:tcPr>
+                    <a:solidFill>
+                      <a:srgbClr val="1A568E"/>
+                    </a:solidFill>
+                  </a:tcPr>
+                </a:tc>
+                <a:tc>
+                  <a:txBody>
+                    <a:bodyPr/>
+                    <a:lstStyle/>
+                    <a:p>
+                      <a:pPr>
+                        <a:defRPr sz="1200" b="1">
+                          <a:solidFill>
+                            <a:srgbClr val="FFFFFF"/>
+                          </a:solidFill>
+                        </a:defRPr>
+                      </a:pPr>
+                      <a:r>
+                        <a:t>SOAR Komersial</a:t>
+                      </a:r>
+                    </a:p>
+                  </a:txBody>
+                  <a:tcPr>
+                    <a:solidFill>
+                      <a:srgbClr val="1A568E"/>
+                    </a:solidFill>
+                  </a:tcPr>
+                </a:tc>
+                <a:tc>
+                  <a:txBody>
+                    <a:bodyPr/>
+                    <a:lstStyle/>
+                    <a:p>
+                      <a:pPr>
+                        <a:defRPr sz="1200" b="1">
+                          <a:solidFill>
+                            <a:srgbClr val="FFFFFF"/>
+                          </a:solidFill>
+                        </a:defRPr>
+                      </a:pPr>
+                      <a:r>
+                        <a:t>Shuffle/Cortex</a:t>
+                      </a:r>
+                    </a:p>
+                  </a:txBody>
+                  <a:tcPr>
+                    <a:solidFill>
+                      <a:srgbClr val="1A568E"/>
+                    </a:solidFill>
+                  </a:tcPr>
+                </a:tc>
+                <a:tc>
+                  <a:txBody>
+                    <a:bodyPr/>
+                    <a:lstStyle/>
+                    <a:p>
+                      <a:pPr>
+                        <a:defRPr sz="1200" b="1">
+                          <a:solidFill>
+                            <a:srgbClr val="FFFFFF"/>
+                          </a:solidFill>
+                        </a:defRPr>
+                      </a:pPr>
+                      <a:r>
+                        <a:t>Sistem Ini (n8n)</a:t>
+                      </a:r>
+                    </a:p>
+                  </a:txBody>
+                  <a:tcPr>
+                    <a:solidFill>
+                      <a:srgbClr val="1A568E"/>
+                    </a:solidFill>
+                  </a:tcPr>
+                </a:tc>
+              </a:tr>
+              <a:tr h="502920">
+                <a:tc>
+                  <a:txBody>
+                    <a:bodyPr/>
+                    <a:lstStyle/>
+                    <a:p>
+                      <a:pPr>
+                        <a:defRPr sz="1200">
+                          <a:solidFill>
+                            <a:srgbClr val="000000"/>
+                          </a:solidFill>
+                        </a:defRPr>
+                      </a:pPr>
+                      <a:r>
+                        <a:t>Biaya</a:t>
+                      </a:r>
+                    </a:p>
+                  </a:txBody>
+                  <a:tcPr/>
+                </a:tc>
+                <a:tc>
+                  <a:txBody>
+                    <a:bodyPr/>
+                    <a:lstStyle/>
+                    <a:p>
+                      <a:pPr>
+                        <a:defRPr sz="1200">
+                          <a:solidFill>
+                            <a:srgbClr val="000000"/>
+                          </a:solidFill>
+                        </a:defRPr>
+                      </a:pPr>
+                      <a:r>
+                        <a:t>Gaji analis tinggi</a:t>
+                      </a:r>
+                    </a:p>
+                  </a:txBody>
+                  <a:tcPr/>
+                </a:tc>
+                <a:tc>
+                  <a:txBody>
+                    <a:bodyPr/>
+                    <a:lstStyle/>
+                    <a:p>
+                      <a:pPr>
+                        <a:defRPr sz="1200">
+                          <a:solidFill>
+                            <a:srgbClr val="000000"/>
+                          </a:solidFill>
+                        </a:defRPr>
+                      </a:pPr>
+                      <a:r>
+                        <a:t>License mahal</a:t>
+                      </a:r>
+                    </a:p>
+                  </a:txBody>
+                  <a:tcPr/>
+                </a:tc>
+                <a:tc>
+                  <a:txBody>
+                    <a:bodyPr/>
+                    <a:lstStyle/>
+                    <a:p>
+                      <a:pPr>
+                        <a:defRPr sz="1200">
+                          <a:solidFill>
+                            <a:srgbClr val="000000"/>
+                          </a:solidFill>
+                        </a:defRPr>
+                      </a:pPr>
+                      <a:r>
+                        <a:t>Gratis</a:t>
+                      </a:r>
+                    </a:p>
+                  </a:txBody>
+                  <a:tcPr/>
+                </a:tc>
+                <a:tc>
+                  <a:txBody>
+                    <a:bodyPr/>
+                    <a:lstStyle/>
+                    <a:p>
+                      <a:pPr>
+                        <a:defRPr sz="1200">
+                          <a:solidFill>
+                            <a:srgbClr val="000000"/>
+                          </a:solidFill>
+                        </a:defRPr>
+                      </a:pPr>
+                      <a:r>
+                        <a:t>Gratis</a:t>
+                      </a:r>
+                    </a:p>
+                  </a:txBody>
+                  <a:tcPr/>
+                </a:tc>
+              </a:tr>
+              <a:tr h="502920">
+                <a:tc>
+                  <a:txBody>
+                    <a:bodyPr/>
+                    <a:lstStyle/>
+                    <a:p>
+                      <a:pPr>
+                        <a:defRPr sz="1200">
+                          <a:solidFill>
+                            <a:srgbClr val="000000"/>
+                          </a:solidFill>
+                        </a:defRPr>
+                      </a:pPr>
+                      <a:r>
+                        <a:t>Kecepatan response</a:t>
+                      </a:r>
+                    </a:p>
+                  </a:txBody>
+                  <a:tcPr>
+                    <a:solidFill>
+                      <a:srgbClr val="F0F0F0"/>
+                    </a:solidFill>
+                  </a:tcPr>
+                </a:tc>
+                <a:tc>
+                  <a:txBody>
+                    <a:bodyPr/>
+                    <a:lstStyle/>
+                    <a:p>
+                      <a:pPr>
+                        <a:defRPr sz="1200">
+                          <a:solidFill>
+                            <a:srgbClr val="000000"/>
+                          </a:solidFill>
+                        </a:defRPr>
+                      </a:pPr>
+                      <a:r>
+                        <a:t>Menit - jam</a:t>
+                      </a:r>
+                    </a:p>
+                  </a:txBody>
+                  <a:tcPr>
+                    <a:solidFill>
+                      <a:srgbClr val="F0F0F0"/>
+                    </a:solidFill>
+                  </a:tcPr>
+                </a:tc>
+                <a:tc>
+                  <a:txBody>
+                    <a:bodyPr/>
+                    <a:lstStyle/>
+                    <a:p>
+                      <a:pPr>
+                        <a:defRPr sz="1200">
+                          <a:solidFill>
+                            <a:srgbClr val="000000"/>
+                          </a:solidFill>
+                        </a:defRPr>
+                      </a:pPr>
+                      <a:r>
+                        <a:t>Detik - menit</a:t>
+                      </a:r>
+                    </a:p>
+                  </a:txBody>
+                  <a:tcPr>
+                    <a:solidFill>
+                      <a:srgbClr val="F0F0F0"/>
+                    </a:solidFill>
+                  </a:tcPr>
+                </a:tc>
+                <a:tc>
+                  <a:txBody>
+                    <a:bodyPr/>
+                    <a:lstStyle/>
+                    <a:p>
+                      <a:pPr>
+                        <a:defRPr sz="1200">
+                          <a:solidFill>
+                            <a:srgbClr val="000000"/>
+                          </a:solidFill>
+                        </a:defRPr>
+                      </a:pPr>
+                      <a:r>
+                        <a:t>Detik - menit</a:t>
+                      </a:r>
+                    </a:p>
+                  </a:txBody>
+                  <a:tcPr>
+                    <a:solidFill>
+                      <a:srgbClr val="F0F0F0"/>
+                    </a:solidFill>
+                  </a:tcPr>
+                </a:tc>
+                <a:tc>
+                  <a:txBody>
+                    <a:bodyPr/>
+                    <a:lstStyle/>
+                    <a:p>
+                      <a:pPr>
+                        <a:defRPr sz="1200">
+                          <a:solidFill>
+                            <a:srgbClr val="000000"/>
+                          </a:solidFill>
+                        </a:defRPr>
+                      </a:pPr>
+                      <a:r>
+                        <a:t>1,68 detik (malware)</a:t>
+                      </a:r>
+                    </a:p>
+                  </a:txBody>
+                  <a:tcPr>
+                    <a:solidFill>
+                      <a:srgbClr val="F0F0F0"/>
+                    </a:solidFill>
+                  </a:tcPr>
+                </a:tc>
+              </a:tr>
+              <a:tr h="502920">
+                <a:tc>
+                  <a:txBody>
+                    <a:bodyPr/>
+                    <a:lstStyle/>
+                    <a:p>
+                      <a:pPr>
+                        <a:defRPr sz="1200">
+                          <a:solidFill>
+                            <a:srgbClr val="000000"/>
+                          </a:solidFill>
+                        </a:defRPr>
+                      </a:pPr>
+                      <a:r>
+                        <a:t>Transparensi</a:t>
+                      </a:r>
+                    </a:p>
+                  </a:txBody>
+                  <a:tcPr/>
+                </a:tc>
+                <a:tc>
+                  <a:txBody>
+                    <a:bodyPr/>
+                    <a:lstStyle/>
+                    <a:p>
+                      <a:pPr>
+                        <a:defRPr sz="1200">
+                          <a:solidFill>
+                            <a:srgbClr val="000000"/>
+                          </a:solidFill>
+                        </a:defRPr>
+                      </a:pPr>
+                      <a:r>
+                        <a:t>Tergantung analis</a:t>
+                      </a:r>
+                    </a:p>
+                  </a:txBody>
+                  <a:tcPr/>
+                </a:tc>
+                <a:tc>
+                  <a:txBody>
+                    <a:bodyPr/>
+                    <a:lstStyle/>
+                    <a:p>
+                      <a:pPr>
+                        <a:defRPr sz="1200">
+                          <a:solidFill>
+                            <a:srgbClr val="000000"/>
+                          </a:solidFill>
+                        </a:defRPr>
+                      </a:pPr>
+                      <a:r>
+                        <a:t>Black-box</a:t>
+                      </a:r>
+                    </a:p>
+                  </a:txBody>
+                  <a:tcPr/>
+                </a:tc>
+                <a:tc>
+                  <a:txBody>
+                    <a:bodyPr/>
+                    <a:lstStyle/>
+                    <a:p>
+                      <a:pPr>
+                        <a:defRPr sz="1200">
+                          <a:solidFill>
+                            <a:srgbClr val="000000"/>
+                          </a:solidFill>
+                        </a:defRPr>
+                      </a:pPr>
+                      <a:r>
+                        <a:t>Black-box</a:t>
+                      </a:r>
+                    </a:p>
+                  </a:txBody>
+                  <a:tcPr/>
+                </a:tc>
+                <a:tc>
+                  <a:txBody>
+                    <a:bodyPr/>
+                    <a:lstStyle/>
+                    <a:p>
+                      <a:pPr>
+                        <a:defRPr sz="1200">
+                          <a:solidFill>
+                            <a:srgbClr val="000000"/>
+                          </a:solidFill>
+                        </a:defRPr>
+                      </a:pPr>
+                      <a:r>
+                        <a:t>Alasan di setiap notifikasi</a:t>
+                      </a:r>
+                    </a:p>
+                  </a:txBody>
+                  <a:tcPr/>
+                </a:tc>
+              </a:tr>
+              <a:tr h="502920">
+                <a:tc>
+                  <a:txBody>
+                    <a:bodyPr/>
+                    <a:lstStyle/>
+                    <a:p>
+                      <a:pPr>
+                        <a:defRPr sz="1200">
+                          <a:solidFill>
+                            <a:srgbClr val="000000"/>
+                          </a:solidFill>
+                        </a:defRPr>
+                      </a:pPr>
+                      <a:r>
+                        <a:t>Self-aware</a:t>
+                      </a:r>
+                    </a:p>
+                  </a:txBody>
+                  <a:tcPr>
+                    <a:solidFill>
+                      <a:srgbClr val="F0F0F0"/>
+                    </a:solidFill>
+                  </a:tcPr>
+                </a:tc>
+                <a:tc>
+                  <a:txBody>
+                    <a:bodyPr/>
+                    <a:lstStyle/>
+                    <a:p>
+                      <a:pPr>
+                        <a:defRPr sz="1200">
+                          <a:solidFill>
+                            <a:srgbClr val="000000"/>
+                          </a:solidFill>
+                        </a:defRPr>
+                      </a:pPr>
+                      <a:r>
+                        <a:t>Tergantung analis</a:t>
+                      </a:r>
+                    </a:p>
+                  </a:txBody>
+                  <a:tcPr>
+                    <a:solidFill>
+                      <a:srgbClr val="F0F0F0"/>
+                    </a:solidFill>
+                  </a:tcPr>
+                </a:tc>
+                <a:tc>
+                  <a:txBody>
+                    <a:bodyPr/>
+                    <a:lstStyle/>
+                    <a:p>
+                      <a:pPr>
+                        <a:defRPr sz="1200">
+                          <a:solidFill>
+                            <a:srgbClr val="000000"/>
+                          </a:solidFill>
+                        </a:defRPr>
+                      </a:pPr>
+                      <a:r>
+                        <a:t>Tidak ada</a:t>
+                      </a:r>
+                    </a:p>
+                  </a:txBody>
+                  <a:tcPr>
+                    <a:solidFill>
+                      <a:srgbClr val="F0F0F0"/>
+                    </a:solidFill>
+                  </a:tcPr>
+                </a:tc>
+                <a:tc>
+                  <a:txBody>
+                    <a:bodyPr/>
+                    <a:lstStyle/>
+                    <a:p>
+                      <a:pPr>
+                        <a:defRPr sz="1200">
+                          <a:solidFill>
+                            <a:srgbClr val="000000"/>
+                          </a:solidFill>
+                        </a:defRPr>
+                      </a:pPr>
+                      <a:r>
+                        <a:t>Tidak ada</a:t>
+                      </a:r>
+                    </a:p>
+                  </a:txBody>
+                  <a:tcPr>
+                    <a:solidFill>
+                      <a:srgbClr val="F0F0F0"/>
+                    </a:solidFill>
+                  </a:tcPr>
+                </a:tc>
+                <a:tc>
+                  <a:txBody>
+                    <a:bodyPr/>
+                    <a:lstStyle/>
+                    <a:p>
+                      <a:pPr>
+                        <a:defRPr sz="1200">
+                          <a:solidFill>
+                            <a:srgbClr val="000000"/>
+                          </a:solidFill>
+                        </a:defRPr>
+                      </a:pPr>
+                      <a:r>
+                        <a:t>Tandai degradasi otomatis</a:t>
+                      </a:r>
+                    </a:p>
+                  </a:txBody>
+                  <a:tcPr>
+                    <a:solidFill>
+                      <a:srgbClr val="F0F0F0"/>
+                    </a:solidFill>
+                  </a:tcPr>
+                </a:tc>
+              </a:tr>
+              <a:tr h="502920">
+                <a:tc>
+                  <a:txBody>
+                    <a:bodyPr/>
+                    <a:lstStyle/>
+                    <a:p>
+                      <a:pPr>
+                        <a:defRPr sz="1200">
+                          <a:solidFill>
+                            <a:srgbClr val="000000"/>
+                          </a:solidFill>
+                        </a:defRPr>
+                      </a:pPr>
+                      <a:r>
+                        <a:t>Audit trail</a:t>
+                      </a:r>
+                    </a:p>
+                  </a:txBody>
+                  <a:tcPr/>
+                </a:tc>
+                <a:tc>
+                  <a:txBody>
+                    <a:bodyPr/>
+                    <a:lstStyle/>
+                    <a:p>
+                      <a:pPr>
+                        <a:defRPr sz="1200">
+                          <a:solidFill>
+                            <a:srgbClr val="000000"/>
+                          </a:solidFill>
+                        </a:defRPr>
+                      </a:pPr>
+                      <a:r>
+                        <a:t>Manual / tidak ada</a:t>
+                      </a:r>
+                    </a:p>
+                  </a:txBody>
+                  <a:tcPr/>
+                </a:tc>
+                <a:tc>
+                  <a:txBody>
+                    <a:bodyPr/>
+                    <a:lstStyle/>
+                    <a:p>
+                      <a:pPr>
+                        <a:defRPr sz="1200">
+                          <a:solidFill>
+                            <a:srgbClr val="000000"/>
+                          </a:solidFill>
+                        </a:defRPr>
+                      </a:pPr>
+                      <a:r>
+                        <a:t>Ada (bayar)</a:t>
+                      </a:r>
+                    </a:p>
+                  </a:txBody>
+                  <a:tcPr/>
+                </a:tc>
+                <a:tc>
+                  <a:txBody>
+                    <a:bodyPr/>
+                    <a:lstStyle/>
+                    <a:p>
+                      <a:pPr>
+                        <a:defRPr sz="1200">
+                          <a:solidFill>
+                            <a:srgbClr val="000000"/>
+                          </a:solidFill>
+                        </a:defRPr>
+                      </a:pPr>
+                      <a:r>
+                        <a:t>Terbatas</a:t>
+                      </a:r>
+                    </a:p>
+                  </a:txBody>
+                  <a:tcPr/>
+                </a:tc>
+                <a:tc>
+                  <a:txBody>
+                    <a:bodyPr/>
+                    <a:lstStyle/>
+                    <a:p>
+                      <a:pPr>
+                        <a:defRPr sz="1200">
+                          <a:solidFill>
+                            <a:srgbClr val="000000"/>
+                          </a:solidFill>
+                        </a:defRPr>
+                      </a:pPr>
+                      <a:r>
+                        <a:t>Gratis (Telegram + n8n)</a:t>
+                      </a:r>
+                    </a:p>
+                  </a:txBody>
+                  <a:tcPr/>
+                </a:tc>
+              </a:tr>
+              <a:tr h="502920">
+                <a:tc>
+                  <a:txBody>
+                    <a:bodyPr/>
+                    <a:lstStyle/>
+                    <a:p>
+                      <a:pPr>
+                        <a:defRPr sz="1200">
+                          <a:solidFill>
+                            <a:srgbClr val="000000"/>
+                          </a:solidFill>
+                        </a:defRPr>
+                      </a:pPr>
+                      <a:r>
+                        <a:t>Phishing proaktif</a:t>
+                      </a:r>
+                    </a:p>
+                  </a:txBody>
+                  <a:tcPr>
+                    <a:solidFill>
+                      <a:srgbClr val="F0F0F0"/>
+                    </a:solidFill>
+                  </a:tcPr>
+                </a:tc>
+                <a:tc>
+                  <a:txBody>
+                    <a:bodyPr/>
+                    <a:lstStyle/>
+                    <a:p>
+                      <a:pPr>
+                        <a:defRPr sz="1200">
+                          <a:solidFill>
+                            <a:srgbClr val="000000"/>
+                          </a:solidFill>
+                        </a:defRPr>
+                      </a:pPr>
+                      <a:r>
+                        <a:t>Tidak ada</a:t>
+                      </a:r>
+                    </a:p>
+                  </a:txBody>
+                  <a:tcPr>
+                    <a:solidFill>
+                      <a:srgbClr val="F0F0F0"/>
+                    </a:solidFill>
+                  </a:tcPr>
+                </a:tc>
+                <a:tc>
+                  <a:txBody>
+                    <a:bodyPr/>
+                    <a:lstStyle/>
+                    <a:p>
+                      <a:pPr>
+                        <a:defRPr sz="1200">
+                          <a:solidFill>
+                            <a:srgbClr val="000000"/>
+                          </a:solidFill>
+                        </a:defRPr>
+                      </a:pPr>
+                      <a:r>
+                        <a:t>Tergantung playbook</a:t>
+                      </a:r>
+                    </a:p>
+                  </a:txBody>
+                  <a:tcPr>
+                    <a:solidFill>
+                      <a:srgbClr val="F0F0F0"/>
+                    </a:solidFill>
+                  </a:tcPr>
+                </a:tc>
+                <a:tc>
+                  <a:txBody>
+                    <a:bodyPr/>
+                    <a:lstStyle/>
+                    <a:p>
+                      <a:pPr>
+                        <a:defRPr sz="1200">
+                          <a:solidFill>
+                            <a:srgbClr val="000000"/>
+                          </a:solidFill>
+                        </a:defRPr>
+                      </a:pPr>
+                      <a:r>
+                        <a:t>Tidak ada</a:t>
+                      </a:r>
+                    </a:p>
+                  </a:txBody>
+                  <a:tcPr>
+                    <a:solidFill>
+                      <a:srgbClr val="F0F0F0"/>
+                    </a:solidFill>
+                  </a:tcPr>
+                </a:tc>
+                <a:tc>
+                  <a:txBody>
+                    <a:bodyPr/>
+                    <a:lstStyle/>
+                    <a:p>
+                      <a:pPr>
+                        <a:defRPr sz="1200">
+                          <a:solidFill>
+                            <a:srgbClr val="000000"/>
+                          </a:solidFill>
+                        </a:defRPr>
+                      </a:pPr>
+                      <a:r>
+                        <a:t>URLhaus auto-block</a:t>
+                      </a:r>
+                    </a:p>
+                  </a:txBody>
+                  <a:tcPr>
+                    <a:solidFill>
+                      <a:srgbClr val="F0F0F0"/>
+                    </a:solidFill>
+                  </a:tcPr>
+                </a:tc>
+              </a:tr>
+              <a:tr h="502920">
+                <a:tc>
+                  <a:txBody>
+                    <a:bodyPr/>
+                    <a:lstStyle/>
+                    <a:p>
+                      <a:pPr>
+                        <a:defRPr sz="1200">
+                          <a:solidFill>
+                            <a:srgbClr val="000000"/>
+                          </a:solidFill>
+                        </a:defRPr>
+                      </a:pPr>
+                      <a:r>
+                        <a:t>AI advisory</a:t>
+                      </a:r>
+                    </a:p>
+                  </a:txBody>
+                  <a:tcPr/>
+                </a:tc>
+                <a:tc>
+                  <a:txBody>
+                    <a:bodyPr/>
+                    <a:lstStyle/>
+                    <a:p>
+                      <a:pPr>
+                        <a:defRPr sz="1200">
+                          <a:solidFill>
+                            <a:srgbClr val="000000"/>
+                          </a:solidFill>
+                        </a:defRPr>
+                      </a:pPr>
+                      <a:r>
+                        <a:t>Tergantung analis</a:t>
+                      </a:r>
+                    </a:p>
+                  </a:txBody>
+                  <a:tcPr/>
+                </a:tc>
+                <a:tc>
+                  <a:txBody>
+                    <a:bodyPr/>
+                    <a:lstStyle/>
+                    <a:p>
+                      <a:pPr>
+                        <a:defRPr sz="1200">
+                          <a:solidFill>
+                            <a:srgbClr val="000000"/>
+                          </a:solidFill>
+                        </a:defRPr>
+                      </a:pPr>
+                      <a:r>
+                        <a:t>Tergantung vendor</a:t>
+                      </a:r>
+                    </a:p>
+                  </a:txBody>
+                  <a:tcPr/>
+                </a:tc>
+                <a:tc>
+                  <a:txBody>
+                    <a:bodyPr/>
+                    <a:lstStyle/>
+                    <a:p>
+                      <a:pPr>
+                        <a:defRPr sz="1200">
+                          <a:solidFill>
+                            <a:srgbClr val="000000"/>
+                          </a:solidFill>
+                        </a:defRPr>
+                      </a:pPr>
+                      <a:r>
+                        <a:t>Tidak ada</a:t>
+                      </a:r>
+                    </a:p>
+                  </a:txBody>
+                  <a:tcPr/>
+                </a:tc>
+                <a:tc>
+                  <a:txBody>
+                    <a:bodyPr/>
+                    <a:lstStyle/>
+                    <a:p>
+                      <a:pPr>
+                        <a:defRPr sz="1200">
+                          <a:solidFill>
+                            <a:srgbClr val="000000"/>
+                          </a:solidFill>
+                        </a:defRPr>
+                      </a:pPr>
+                      <a:r>
+                        <a:t>Ollama lokal (gratis)</a:t>
+                      </a:r>
+                    </a:p>
+                  </a:txBody>
+                  <a:tcPr/>
+                </a:tc>
+              </a:tr>
+              <a:tr h="502920">
+                <a:tc>
+                  <a:txBody>
+                    <a:bodyPr/>
+                    <a:lstStyle/>
+                    <a:p>
+                      <a:pPr>
+                        <a:defRPr sz="1200">
+                          <a:solidFill>
+                            <a:srgbClr val="000000"/>
+                          </a:solidFill>
+                        </a:defRPr>
+                      </a:pPr>
+                      <a:r>
+                        <a:t>Multi-sumber intel</a:t>
+                      </a:r>
+                    </a:p>
+                  </a:txBody>
+                  <a:tcPr>
+                    <a:solidFill>
+                      <a:srgbClr val="F0F0F0"/>
+                    </a:solidFill>
+                  </a:tcPr>
+                </a:tc>
+                <a:tc>
+                  <a:txBody>
+                    <a:bodyPr/>
+                    <a:lstStyle/>
+                    <a:p>
+                      <a:pPr>
+                        <a:defRPr sz="1200">
+                          <a:solidFill>
+                            <a:srgbClr val="000000"/>
+                          </a:solidFill>
+                        </a:defRPr>
+                      </a:pPr>
+                      <a:r>
+                        <a:t>Manual</a:t>
+                      </a:r>
+                    </a:p>
+                  </a:txBody>
+                  <a:tcPr>
+                    <a:solidFill>
+                      <a:srgbClr val="F0F0F0"/>
+                    </a:solidFill>
+                  </a:tcPr>
+                </a:tc>
+                <a:tc>
+                  <a:txBody>
+                    <a:bodyPr/>
+                    <a:lstStyle/>
+                    <a:p>
+                      <a:pPr>
+                        <a:defRPr sz="1200">
+                          <a:solidFill>
+                            <a:srgbClr val="000000"/>
+                          </a:solidFill>
+                        </a:defRPr>
+                      </a:pPr>
+                      <a:r>
+                        <a:t>Tergantung integrasi</a:t>
+                      </a:r>
+                    </a:p>
+                  </a:txBody>
+                  <a:tcPr>
+                    <a:solidFill>
+                      <a:srgbClr val="F0F0F0"/>
+                    </a:solidFill>
+                  </a:tcPr>
+                </a:tc>
+                <a:tc>
+                  <a:txBody>
+                    <a:bodyPr/>
+                    <a:lstStyle/>
+                    <a:p>
+                      <a:pPr>
+                        <a:defRPr sz="1200">
+                          <a:solidFill>
+                            <a:srgbClr val="000000"/>
+                          </a:solidFill>
+                        </a:defRPr>
+                      </a:pPr>
+                      <a:r>
+                        <a:t>Beberapa</a:t>
+                      </a:r>
+                    </a:p>
+                  </a:txBody>
+                  <a:tcPr>
+                    <a:solidFill>
+                      <a:srgbClr val="F0F0F0"/>
+                    </a:solidFill>
+                  </a:tcPr>
+                </a:tc>
+                <a:tc>
+                  <a:txBody>
+                    <a:bodyPr/>
+                    <a:lstStyle/>
+                    <a:p>
+                      <a:pPr>
+                        <a:defRPr sz="1200">
+                          <a:solidFill>
+                            <a:srgbClr val="000000"/>
+                          </a:solidFill>
+                        </a:defRPr>
+                      </a:pPr>
+                      <a:r>
+                        <a:t>VT + MalwareBazaar</a:t>
+                      </a:r>
+                    </a:p>
+                  </a:txBody>
+                  <a:tcPr>
+                    <a:solidFill>
+                      <a:srgbClr val="F0F0F0"/>
+                    </a:solidFill>
+                  </a:tcPr>
+                </a:tc>
+              </a:tr>
+              <a:tr h="502920">
+                <a:tc>
+                  <a:txBody>
+                    <a:bodyPr/>
+                    <a:lstStyle/>
+                    <a:p>
+                      <a:pPr>
+                        <a:defRPr sz="1200">
+                          <a:solidFill>
+                            <a:srgbClr val="000000"/>
+                          </a:solidFill>
+                        </a:defRPr>
+                      </a:pPr>
+                      <a:r>
+                        <a:t>Setup &amp; maintenance</a:t>
+                      </a:r>
+                    </a:p>
+                  </a:txBody>
+                  <a:tcPr/>
+                </a:tc>
+                <a:tc>
+                  <a:txBody>
+                    <a:bodyPr/>
+                    <a:lstStyle/>
+                    <a:p>
+                      <a:pPr>
+                        <a:defRPr sz="1200">
+                          <a:solidFill>
+                            <a:srgbClr val="000000"/>
+                          </a:solidFill>
+                        </a:defRPr>
+                      </a:pPr>
+                      <a:r>
+                        <a:t>Tidak ada</a:t>
+                      </a:r>
+                    </a:p>
+                  </a:txBody>
+                  <a:tcPr/>
+                </a:tc>
+                <a:tc>
+                  <a:txBody>
+                    <a:bodyPr/>
+                    <a:lstStyle/>
+                    <a:p>
+                      <a:pPr>
+                        <a:defRPr sz="1200">
+                          <a:solidFill>
+                            <a:srgbClr val="000000"/>
+                          </a:solidFill>
+                        </a:defRPr>
+                      </a:pPr>
+                      <a:r>
+                        <a:t>Kompleks</a:t>
+                      </a:r>
+                    </a:p>
+                  </a:txBody>
+                  <a:tcPr/>
+                </a:tc>
+                <a:tc>
+                  <a:txBody>
+                    <a:bodyPr/>
+                    <a:lstStyle/>
+                    <a:p>
+                      <a:pPr>
+                        <a:defRPr sz="1200">
+                          <a:solidFill>
+                            <a:srgbClr val="000000"/>
+                          </a:solidFill>
+                        </a:defRPr>
+                      </a:pPr>
+                      <a:r>
+                        <a:t>Sedang</a:t>
+                      </a:r>
+                    </a:p>
+                  </a:txBody>
+                  <a:tcPr/>
+                </a:tc>
+                <a:tc>
+                  <a:txBody>
+                    <a:bodyPr/>
+                    <a:lstStyle/>
+                    <a:p>
+                      <a:pPr>
+                        <a:defRPr sz="1200">
+                          <a:solidFill>
+                            <a:srgbClr val="000000"/>
+                          </a:solidFill>
+                        </a:defRPr>
+                      </a:pPr>
+                      <a:r>
+                        <a:t>Docker + Ansible</a:t>
+                      </a:r>
+                    </a:p>
+                  </a:txBody>
+                  <a:tcPr/>
+                </a:tc>
+              </a:tr>
+            </a:tbl>
+          </a:graphicData>
+        </a:graphic>
+      </p:graphicFrame>
+      <p:sp>
+        <p:nvSpPr>
+          <p:cNvPr id="5" name="TextBox 4"/>
+          <p:cNvSpPr txBox="1"/>
+          <p:nvPr/>
+        </p:nvSpPr>
+        <p:spPr>
+          <a:xfrm>
+            <a:off x="457200" y="6217920"/>
+            <a:ext cx="10972800" cy="365760"/>
+          </a:xfrm>
+          <a:prstGeom prst="rect">
+            <a:avLst/>
+          </a:prstGeom>
+          <a:noFill/>
+        </p:spPr>
+        <p:txBody>
+          <a:bodyPr wrap="square">
+            <a:spAutoFit/>
+          </a:bodyPr>
+          <a:lstStyle/>
+          <a:p>
+            <a:pPr algn="l">
+              <a:defRPr sz="1200" b="0">
+                <a:solidFill>
+                  <a:srgbClr val="666666"/>
+                </a:solidFill>
+              </a:defRPr>
+            </a:pPr>
+            <a:r>
+              <a:t>* Semua fitur di atas berjalan di 1 VPS dengan RAM ~3 GB (tidak perlu server mahal)</a:t>
+            </a:r>
+          </a:p>
+        </p:txBody>
+      </p:sp>
+    </p:spTree>
+  </p:cSld>
+  <p:clrMapOvr>
+    <a:masterClrMapping/>
+  </p:clrMapOvr>
+</p:sld>
+</file>
+
+<file path=ppt/slides/slide4.xml><?xml version="1.0" encoding="utf-8"?>
 <p:sld xmlns:a="http://schemas.openxmlformats.org/drawingml/2006/main" xmlns:p="http://schemas.openxmlformats.org/presentationml/2006/main" xmlns:r="http://schemas.openxmlformats.org/officeDocument/2006/relationships">
   <p:cSld>
     <p:spTree>
@@ -4057,7 +5114,7 @@
               </a:defRPr>
             </a:pPr>
             <a:r>
-              <a:t>Container:</a:t>
+              <a:t>Container (6 total):</a:t>
             </a:r>
           </a:p>
           <a:p>
@@ -4072,7 +5129,7 @@
               </a:defRPr>
             </a:pPr>
             <a:r>
-              <a:t>  - wazuh.manager</a:t>
+              <a:t>  wazuh.manager</a:t>
             </a:r>
           </a:p>
           <a:p>
@@ -4087,7 +5144,7 @@
               </a:defRPr>
             </a:pPr>
             <a:r>
-              <a:t>  - wazuh.indexer</a:t>
+              <a:t>  wazuh.indexer</a:t>
             </a:r>
           </a:p>
           <a:p>
@@ -4102,7 +5159,7 @@
               </a:defRPr>
             </a:pPr>
             <a:r>
-              <a:t>  - wazuh.dashboard</a:t>
+              <a:t>  wazuh.dashboard</a:t>
             </a:r>
           </a:p>
           <a:p>
@@ -4117,7 +5174,7 @@
               </a:defRPr>
             </a:pPr>
             <a:r>
-              <a:t>  - n8n</a:t>
+              <a:t>  n8n</a:t>
             </a:r>
           </a:p>
           <a:p>
@@ -4132,7 +5189,7 @@
               </a:defRPr>
             </a:pPr>
             <a:r>
-              <a:t>  - tg-callback-poller</a:t>
+              <a:t>  tg-callback-poller</a:t>
             </a:r>
           </a:p>
           <a:p>
@@ -4147,7 +5204,7 @@
               </a:defRPr>
             </a:pPr>
             <a:r>
-              <a:t>  - health-monitor</a:t>
+              <a:t>  health-monitor</a:t>
             </a:r>
           </a:p>
         </p:txBody>
@@ -4160,7 +5217,7 @@
 </p:sld>
 </file>
 
-<file path=ppt/slides/slide4.xml><?xml version="1.0" encoding="utf-8"?>
+<file path=ppt/slides/slide5.xml><?xml version="1.0" encoding="utf-8"?>
 <p:sld xmlns:a="http://schemas.openxmlformats.org/drawingml/2006/main" xmlns:p="http://schemas.openxmlformats.org/presentationml/2006/main" xmlns:r="http://schemas.openxmlformats.org/officeDocument/2006/relationships">
   <p:cSld>
     <p:spTree>
@@ -4733,7 +5790,7 @@
                     <a:lstStyle/>
                     <a:p>
                       <a:pPr>
-                        <a:defRPr sz="1300" b="1">
+                        <a:defRPr sz="1200" b="1">
                           <a:solidFill>
                             <a:srgbClr val="FFFFFF"/>
                           </a:solidFill>
@@ -4756,7 +5813,7 @@
                     <a:lstStyle/>
                     <a:p>
                       <a:pPr>
-                        <a:defRPr sz="1300" b="1">
+                        <a:defRPr sz="1200" b="1">
                           <a:solidFill>
                             <a:srgbClr val="FFFFFF"/>
                           </a:solidFill>
@@ -4779,7 +5836,7 @@
                     <a:lstStyle/>
                     <a:p>
                       <a:pPr>
-                        <a:defRPr sz="1300" b="1">
+                        <a:defRPr sz="1200" b="1">
                           <a:solidFill>
                             <a:srgbClr val="FFFFFF"/>
                           </a:solidFill>
@@ -4804,7 +5861,7 @@
                     <a:lstStyle/>
                     <a:p>
                       <a:pPr>
-                        <a:defRPr sz="1300">
+                        <a:defRPr sz="1200">
                           <a:solidFill>
                             <a:srgbClr val="000000"/>
                           </a:solidFill>
@@ -4823,7 +5880,7 @@
                     <a:lstStyle/>
                     <a:p>
                       <a:pPr>
-                        <a:defRPr sz="1300">
+                        <a:defRPr sz="1200">
                           <a:solidFill>
                             <a:srgbClr val="000000"/>
                           </a:solidFill>
@@ -4842,7 +5899,7 @@
                     <a:lstStyle/>
                     <a:p>
                       <a:pPr>
-                        <a:defRPr sz="1300">
+                        <a:defRPr sz="1200">
                           <a:solidFill>
                             <a:srgbClr val="000000"/>
                           </a:solidFill>
@@ -4863,7 +5920,7 @@
                     <a:lstStyle/>
                     <a:p>
                       <a:pPr>
-                        <a:defRPr sz="1300">
+                        <a:defRPr sz="1200">
                           <a:solidFill>
                             <a:srgbClr val="000000"/>
                           </a:solidFill>
@@ -4874,15 +5931,19 @@
                       </a:r>
                     </a:p>
                   </a:txBody>
-                  <a:tcPr/>
-                </a:tc>
-                <a:tc>
-                  <a:txBody>
-                    <a:bodyPr/>
-                    <a:lstStyle/>
-                    <a:p>
-                      <a:pPr>
-                        <a:defRPr sz="1300">
+                  <a:tcPr>
+                    <a:solidFill>
+                      <a:srgbClr val="F0F0F0"/>
+                    </a:solidFill>
+                  </a:tcPr>
+                </a:tc>
+                <a:tc>
+                  <a:txBody>
+                    <a:bodyPr/>
+                    <a:lstStyle/>
+                    <a:p>
+                      <a:pPr>
+                        <a:defRPr sz="1200">
                           <a:solidFill>
                             <a:srgbClr val="000000"/>
                           </a:solidFill>
@@ -4893,15 +5954,19 @@
                       </a:r>
                     </a:p>
                   </a:txBody>
-                  <a:tcPr/>
-                </a:tc>
-                <a:tc>
-                  <a:txBody>
-                    <a:bodyPr/>
-                    <a:lstStyle/>
-                    <a:p>
-                      <a:pPr>
-                        <a:defRPr sz="1300">
+                  <a:tcPr>
+                    <a:solidFill>
+                      <a:srgbClr val="F0F0F0"/>
+                    </a:solidFill>
+                  </a:tcPr>
+                </a:tc>
+                <a:tc>
+                  <a:txBody>
+                    <a:bodyPr/>
+                    <a:lstStyle/>
+                    <a:p>
+                      <a:pPr>
+                        <a:defRPr sz="1200">
                           <a:solidFill>
                             <a:srgbClr val="000000"/>
                           </a:solidFill>
@@ -4912,7 +5977,11 @@
                       </a:r>
                     </a:p>
                   </a:txBody>
-                  <a:tcPr/>
+                  <a:tcPr>
+                    <a:solidFill>
+                      <a:srgbClr val="F0F0F0"/>
+                    </a:solidFill>
+                  </a:tcPr>
                 </a:tc>
               </a:tr>
               <a:tr h="533400">
@@ -4922,7 +5991,7 @@
                     <a:lstStyle/>
                     <a:p>
                       <a:pPr>
-                        <a:defRPr sz="1300">
+                        <a:defRPr sz="1200">
                           <a:solidFill>
                             <a:srgbClr val="000000"/>
                           </a:solidFill>
@@ -4941,7 +6010,7 @@
                     <a:lstStyle/>
                     <a:p>
                       <a:pPr>
-                        <a:defRPr sz="1300">
+                        <a:defRPr sz="1200">
                           <a:solidFill>
                             <a:srgbClr val="000000"/>
                           </a:solidFill>
@@ -4960,7 +6029,7 @@
                     <a:lstStyle/>
                     <a:p>
                       <a:pPr>
-                        <a:defRPr sz="1300">
+                        <a:defRPr sz="1200">
                           <a:solidFill>
                             <a:srgbClr val="000000"/>
                           </a:solidFill>
@@ -4981,7 +6050,7 @@
                     <a:lstStyle/>
                     <a:p>
                       <a:pPr>
-                        <a:defRPr sz="1300">
+                        <a:defRPr sz="1200">
                           <a:solidFill>
                             <a:srgbClr val="000000"/>
                           </a:solidFill>
@@ -4992,15 +6061,19 @@
                       </a:r>
                     </a:p>
                   </a:txBody>
-                  <a:tcPr/>
-                </a:tc>
-                <a:tc>
-                  <a:txBody>
-                    <a:bodyPr/>
-                    <a:lstStyle/>
-                    <a:p>
-                      <a:pPr>
-                        <a:defRPr sz="1300">
+                  <a:tcPr>
+                    <a:solidFill>
+                      <a:srgbClr val="F0F0F0"/>
+                    </a:solidFill>
+                  </a:tcPr>
+                </a:tc>
+                <a:tc>
+                  <a:txBody>
+                    <a:bodyPr/>
+                    <a:lstStyle/>
+                    <a:p>
+                      <a:pPr>
+                        <a:defRPr sz="1200">
                           <a:solidFill>
                             <a:srgbClr val="000000"/>
                           </a:solidFill>
@@ -5011,15 +6084,19 @@
                       </a:r>
                     </a:p>
                   </a:txBody>
-                  <a:tcPr/>
-                </a:tc>
-                <a:tc>
-                  <a:txBody>
-                    <a:bodyPr/>
-                    <a:lstStyle/>
-                    <a:p>
-                      <a:pPr>
-                        <a:defRPr sz="1300">
+                  <a:tcPr>
+                    <a:solidFill>
+                      <a:srgbClr val="F0F0F0"/>
+                    </a:solidFill>
+                  </a:tcPr>
+                </a:tc>
+                <a:tc>
+                  <a:txBody>
+                    <a:bodyPr/>
+                    <a:lstStyle/>
+                    <a:p>
+                      <a:pPr>
+                        <a:defRPr sz="1200">
                           <a:solidFill>
                             <a:srgbClr val="000000"/>
                           </a:solidFill>
@@ -5030,7 +6107,11 @@
                       </a:r>
                     </a:p>
                   </a:txBody>
-                  <a:tcPr/>
+                  <a:tcPr>
+                    <a:solidFill>
+                      <a:srgbClr val="F0F0F0"/>
+                    </a:solidFill>
+                  </a:tcPr>
                 </a:tc>
               </a:tr>
               <a:tr h="533400">
@@ -5040,7 +6121,7 @@
                     <a:lstStyle/>
                     <a:p>
                       <a:pPr>
-                        <a:defRPr sz="1300">
+                        <a:defRPr sz="1200">
                           <a:solidFill>
                             <a:srgbClr val="000000"/>
                           </a:solidFill>
@@ -5059,7 +6140,7 @@
                     <a:lstStyle/>
                     <a:p>
                       <a:pPr>
-                        <a:defRPr sz="1300">
+                        <a:defRPr sz="1200">
                           <a:solidFill>
                             <a:srgbClr val="000000"/>
                           </a:solidFill>
@@ -5078,7 +6159,7 @@
                     <a:lstStyle/>
                     <a:p>
                       <a:pPr>
-                        <a:defRPr sz="1300">
+                        <a:defRPr sz="1200">
                           <a:solidFill>
                             <a:srgbClr val="000000"/>
                           </a:solidFill>
@@ -5104,7 +6185,7 @@
 </p:sld>
 </file>
 
-<file path=ppt/slides/slide5.xml><?xml version="1.0" encoding="utf-8"?>
+<file path=ppt/slides/slide6.xml><?xml version="1.0" encoding="utf-8"?>
 <p:sld xmlns:a="http://schemas.openxmlformats.org/drawingml/2006/main" xmlns:p="http://schemas.openxmlformats.org/presentationml/2006/main" xmlns:r="http://schemas.openxmlformats.org/officeDocument/2006/relationships">
   <p:cSld>
     <p:spTree>
@@ -5257,7 +6338,7 @@
                     <a:lstStyle/>
                     <a:p>
                       <a:pPr>
-                        <a:defRPr sz="1300" b="1">
+                        <a:defRPr sz="1200" b="1">
                           <a:solidFill>
                             <a:srgbClr val="FFFFFF"/>
                           </a:solidFill>
@@ -5280,7 +6361,7 @@
                     <a:lstStyle/>
                     <a:p>
                       <a:pPr>
-                        <a:defRPr sz="1300" b="1">
+                        <a:defRPr sz="1200" b="1">
                           <a:solidFill>
                             <a:srgbClr val="FFFFFF"/>
                           </a:solidFill>
@@ -5303,7 +6384,7 @@
                     <a:lstStyle/>
                     <a:p>
                       <a:pPr>
-                        <a:defRPr sz="1300" b="1">
+                        <a:defRPr sz="1200" b="1">
                           <a:solidFill>
                             <a:srgbClr val="FFFFFF"/>
                           </a:solidFill>
@@ -5328,7 +6409,7 @@
                     <a:lstStyle/>
                     <a:p>
                       <a:pPr>
-                        <a:defRPr sz="1300">
+                        <a:defRPr sz="1200">
                           <a:solidFill>
                             <a:srgbClr val="000000"/>
                           </a:solidFill>
@@ -5347,7 +6428,7 @@
                     <a:lstStyle/>
                     <a:p>
                       <a:pPr>
-                        <a:defRPr sz="1300">
+                        <a:defRPr sz="1200">
                           <a:solidFill>
                             <a:srgbClr val="000000"/>
                           </a:solidFill>
@@ -5366,7 +6447,7 @@
                     <a:lstStyle/>
                     <a:p>
                       <a:pPr>
-                        <a:defRPr sz="1300">
+                        <a:defRPr sz="1200">
                           <a:solidFill>
                             <a:srgbClr val="000000"/>
                           </a:solidFill>
@@ -5387,7 +6468,7 @@
                     <a:lstStyle/>
                     <a:p>
                       <a:pPr>
-                        <a:defRPr sz="1300">
+                        <a:defRPr sz="1200">
                           <a:solidFill>
                             <a:srgbClr val="000000"/>
                           </a:solidFill>
@@ -5398,15 +6479,19 @@
                       </a:r>
                     </a:p>
                   </a:txBody>
-                  <a:tcPr/>
-                </a:tc>
-                <a:tc>
-                  <a:txBody>
-                    <a:bodyPr/>
-                    <a:lstStyle/>
-                    <a:p>
-                      <a:pPr>
-                        <a:defRPr sz="1300">
+                  <a:tcPr>
+                    <a:solidFill>
+                      <a:srgbClr val="F0F0F0"/>
+                    </a:solidFill>
+                  </a:tcPr>
+                </a:tc>
+                <a:tc>
+                  <a:txBody>
+                    <a:bodyPr/>
+                    <a:lstStyle/>
+                    <a:p>
+                      <a:pPr>
+                        <a:defRPr sz="1200">
                           <a:solidFill>
                             <a:srgbClr val="000000"/>
                           </a:solidFill>
@@ -5417,15 +6502,19 @@
                       </a:r>
                     </a:p>
                   </a:txBody>
-                  <a:tcPr/>
-                </a:tc>
-                <a:tc>
-                  <a:txBody>
-                    <a:bodyPr/>
-                    <a:lstStyle/>
-                    <a:p>
-                      <a:pPr>
-                        <a:defRPr sz="1300">
+                  <a:tcPr>
+                    <a:solidFill>
+                      <a:srgbClr val="F0F0F0"/>
+                    </a:solidFill>
+                  </a:tcPr>
+                </a:tc>
+                <a:tc>
+                  <a:txBody>
+                    <a:bodyPr/>
+                    <a:lstStyle/>
+                    <a:p>
+                      <a:pPr>
+                        <a:defRPr sz="1200">
                           <a:solidFill>
                             <a:srgbClr val="000000"/>
                           </a:solidFill>
@@ -5436,7 +6525,11 @@
                       </a:r>
                     </a:p>
                   </a:txBody>
-                  <a:tcPr/>
+                  <a:tcPr>
+                    <a:solidFill>
+                      <a:srgbClr val="F0F0F0"/>
+                    </a:solidFill>
+                  </a:tcPr>
                 </a:tc>
               </a:tr>
               <a:tr h="381000">
@@ -5446,7 +6539,7 @@
                     <a:lstStyle/>
                     <a:p>
                       <a:pPr>
-                        <a:defRPr sz="1300">
+                        <a:defRPr sz="1200">
                           <a:solidFill>
                             <a:srgbClr val="000000"/>
                           </a:solidFill>
@@ -5465,7 +6558,7 @@
                     <a:lstStyle/>
                     <a:p>
                       <a:pPr>
-                        <a:defRPr sz="1300">
+                        <a:defRPr sz="1200">
                           <a:solidFill>
                             <a:srgbClr val="000000"/>
                           </a:solidFill>
@@ -5484,7 +6577,7 @@
                     <a:lstStyle/>
                     <a:p>
                       <a:pPr>
-                        <a:defRPr sz="1300">
+                        <a:defRPr sz="1200">
                           <a:solidFill>
                             <a:srgbClr val="000000"/>
                           </a:solidFill>
@@ -5505,7 +6598,7 @@
                     <a:lstStyle/>
                     <a:p>
                       <a:pPr>
-                        <a:defRPr sz="1300">
+                        <a:defRPr sz="1200">
                           <a:solidFill>
                             <a:srgbClr val="000000"/>
                           </a:solidFill>
@@ -5516,15 +6609,19 @@
                       </a:r>
                     </a:p>
                   </a:txBody>
-                  <a:tcPr/>
-                </a:tc>
-                <a:tc>
-                  <a:txBody>
-                    <a:bodyPr/>
-                    <a:lstStyle/>
-                    <a:p>
-                      <a:pPr>
-                        <a:defRPr sz="1300">
+                  <a:tcPr>
+                    <a:solidFill>
+                      <a:srgbClr val="F0F0F0"/>
+                    </a:solidFill>
+                  </a:tcPr>
+                </a:tc>
+                <a:tc>
+                  <a:txBody>
+                    <a:bodyPr/>
+                    <a:lstStyle/>
+                    <a:p>
+                      <a:pPr>
+                        <a:defRPr sz="1200">
                           <a:solidFill>
                             <a:srgbClr val="000000"/>
                           </a:solidFill>
@@ -5535,15 +6632,19 @@
                       </a:r>
                     </a:p>
                   </a:txBody>
-                  <a:tcPr/>
-                </a:tc>
-                <a:tc>
-                  <a:txBody>
-                    <a:bodyPr/>
-                    <a:lstStyle/>
-                    <a:p>
-                      <a:pPr>
-                        <a:defRPr sz="1300">
+                  <a:tcPr>
+                    <a:solidFill>
+                      <a:srgbClr val="F0F0F0"/>
+                    </a:solidFill>
+                  </a:tcPr>
+                </a:tc>
+                <a:tc>
+                  <a:txBody>
+                    <a:bodyPr/>
+                    <a:lstStyle/>
+                    <a:p>
+                      <a:pPr>
+                        <a:defRPr sz="1200">
                           <a:solidFill>
                             <a:srgbClr val="000000"/>
                           </a:solidFill>
@@ -5554,7 +6655,11 @@
                       </a:r>
                     </a:p>
                   </a:txBody>
-                  <a:tcPr/>
+                  <a:tcPr>
+                    <a:solidFill>
+                      <a:srgbClr val="F0F0F0"/>
+                    </a:solidFill>
+                  </a:tcPr>
                 </a:tc>
               </a:tr>
               <a:tr h="381000">
@@ -5564,7 +6669,7 @@
                     <a:lstStyle/>
                     <a:p>
                       <a:pPr>
-                        <a:defRPr sz="1300">
+                        <a:defRPr sz="1200">
                           <a:solidFill>
                             <a:srgbClr val="000000"/>
                           </a:solidFill>
@@ -5583,7 +6688,7 @@
                     <a:lstStyle/>
                     <a:p>
                       <a:pPr>
-                        <a:defRPr sz="1300">
+                        <a:defRPr sz="1200">
                           <a:solidFill>
                             <a:srgbClr val="000000"/>
                           </a:solidFill>
@@ -5602,7 +6707,7 @@
                     <a:lstStyle/>
                     <a:p>
                       <a:pPr>
-                        <a:defRPr sz="1300">
+                        <a:defRPr sz="1200">
                           <a:solidFill>
                             <a:srgbClr val="000000"/>
                           </a:solidFill>
@@ -5698,7 +6803,7 @@
               </a:defRPr>
             </a:pPr>
             <a:r>
-              <a:t>- Load test 34 alert/detik itu kapasitas webhook n8n. Pipeline backend (VT/MB/Ollama) jalan async.</a:t>
+              <a:t>- Load test 34 alert/detik itu kapasitas webhook n8n. Pipeline backend jalan async.</a:t>
             </a:r>
           </a:p>
           <a:p>
@@ -5714,516 +6819,6 @@
             </a:pPr>
             <a:r>
               <a:t>- FN rate 0% artinya tidak ada file berisiko yang lolos dari deteksi.</a:t>
-            </a:r>
-          </a:p>
-        </p:txBody>
-      </p:sp>
-    </p:spTree>
-  </p:cSld>
-  <p:clrMapOvr>
-    <a:masterClrMapping/>
-  </p:clrMapOvr>
-</p:sld>
-</file>
-
-<file path=ppt/slides/slide6.xml><?xml version="1.0" encoding="utf-8"?>
-<p:sld xmlns:a="http://schemas.openxmlformats.org/drawingml/2006/main" xmlns:p="http://schemas.openxmlformats.org/presentationml/2006/main" xmlns:r="http://schemas.openxmlformats.org/officeDocument/2006/relationships">
-  <p:cSld>
-    <p:spTree>
-      <p:nvGrpSpPr>
-        <p:cNvPr id="1" name=""/>
-        <p:cNvGrpSpPr/>
-        <p:nvPr/>
-      </p:nvGrpSpPr>
-      <p:grpSpPr/>
-      <p:sp>
-        <p:nvSpPr>
-          <p:cNvPr id="2" name="TextBox 1"/>
-          <p:cNvSpPr txBox="1"/>
-          <p:nvPr/>
-        </p:nvSpPr>
-        <p:spPr>
-          <a:xfrm>
-            <a:off x="457200" y="274320"/>
-            <a:ext cx="10972800" cy="548640"/>
-          </a:xfrm>
-          <a:prstGeom prst="rect">
-            <a:avLst/>
-          </a:prstGeom>
-          <a:noFill/>
-        </p:spPr>
-        <p:txBody>
-          <a:bodyPr wrap="square">
-            <a:spAutoFit/>
-          </a:bodyPr>
-          <a:lstStyle/>
-          <a:p>
-            <a:pPr algn="l">
-              <a:defRPr sz="2800" b="1">
-                <a:solidFill>
-                  <a:srgbClr val="1A568E"/>
-                </a:solidFill>
-              </a:defRPr>
-            </a:pPr>
-            <a:r>
-              <a:t>Kontribusi &amp; Kebaruan</a:t>
-            </a:r>
-          </a:p>
-        </p:txBody>
-      </p:sp>
-      <p:sp>
-        <p:nvSpPr>
-          <p:cNvPr id="3" name="Rectangle 2"/>
-          <p:cNvSpPr/>
-          <p:nvPr/>
-        </p:nvSpPr>
-        <p:spPr>
-          <a:xfrm>
-            <a:off x="457200" y="822960"/>
-            <a:ext cx="3657600" cy="25400"/>
-          </a:xfrm>
-          <a:prstGeom prst="rect">
-            <a:avLst/>
-          </a:prstGeom>
-          <a:solidFill>
-            <a:srgbClr val="1A568E"/>
-          </a:solidFill>
-          <a:ln>
-            <a:noFill/>
-          </a:ln>
-        </p:spPr>
-        <p:style>
-          <a:lnRef idx="1">
-            <a:schemeClr val="accent1"/>
-          </a:lnRef>
-          <a:fillRef idx="3">
-            <a:schemeClr val="accent1"/>
-          </a:fillRef>
-          <a:effectRef idx="2">
-            <a:schemeClr val="accent1"/>
-          </a:effectRef>
-          <a:fontRef idx="minor">
-            <a:schemeClr val="lt1"/>
-          </a:fontRef>
-        </p:style>
-        <p:txBody>
-          <a:bodyPr rtlCol="0" anchor="ctr"/>
-          <a:lstStyle/>
-          <a:p>
-            <a:pPr algn="ctr"/>
-          </a:p>
-        </p:txBody>
-      </p:sp>
-      <p:sp>
-        <p:nvSpPr>
-          <p:cNvPr id="4" name="TextBox 3"/>
-          <p:cNvSpPr txBox="1"/>
-          <p:nvPr/>
-        </p:nvSpPr>
-        <p:spPr>
-          <a:xfrm>
-            <a:off x="457200" y="1097280"/>
-            <a:ext cx="5303520" cy="5029200"/>
-          </a:xfrm>
-          <a:prstGeom prst="rect">
-            <a:avLst/>
-          </a:prstGeom>
-          <a:noFill/>
-        </p:spPr>
-        <p:txBody>
-          <a:bodyPr wrap="square">
-            <a:spAutoFit/>
-          </a:bodyPr>
-          <a:lstStyle/>
-          <a:p>
-            <a:pPr>
-              <a:spcBef>
-                <a:spcPts val="500"/>
-              </a:spcBef>
-              <a:defRPr sz="1500">
-                <a:solidFill>
-                  <a:srgbClr val="000000"/>
-                </a:solidFill>
-              </a:defRPr>
-            </a:pPr>
-            <a:r>
-              <a:t>Kenapa ini berbeda dari SOAR lain:</a:t>
-            </a:r>
-          </a:p>
-          <a:p>
-            <a:pPr>
-              <a:spcBef>
-                <a:spcPts val="500"/>
-              </a:spcBef>
-              <a:defRPr sz="1500">
-                <a:solidFill>
-                  <a:srgbClr val="000000"/>
-                </a:solidFill>
-              </a:defRPr>
-            </a:pPr>
-            <a:r>
-              <a:t>  - SOAR lain (Shuffle, Cortex) itu black-box</a:t>
-            </a:r>
-          </a:p>
-          <a:p>
-            <a:pPr>
-              <a:spcBef>
-                <a:spcPts val="500"/>
-              </a:spcBef>
-              <a:defRPr sz="1500">
-                <a:solidFill>
-                  <a:srgbClr val="000000"/>
-                </a:solidFill>
-              </a:defRPr>
-            </a:pPr>
-            <a:r>
-              <a:t>    analis tidak tahu kenapa keputusan diambil</a:t>
-            </a:r>
-          </a:p>
-          <a:p>
-            <a:pPr>
-              <a:spcBef>
-                <a:spcPts val="500"/>
-              </a:spcBef>
-              <a:defRPr sz="1500">
-                <a:solidFill>
-                  <a:srgbClr val="000000"/>
-                </a:solidFill>
-              </a:defRPr>
-            </a:pPr>
-            <a:r>
-              <a:t>  - Sistem ini kasih alasan di setiap notifikasi:</a:t>
-            </a:r>
-          </a:p>
-          <a:p>
-            <a:pPr>
-              <a:spcBef>
-                <a:spcPts val="500"/>
-              </a:spcBef>
-              <a:defRPr sz="1500">
-                <a:solidFill>
-                  <a:srgbClr val="000000"/>
-                </a:solidFill>
-              </a:defRPr>
-            </a:pPr>
-            <a:r>
-              <a:t>    kenapa file ini dianggap berbahaya</a:t>
-            </a:r>
-          </a:p>
-          <a:p>
-            <a:pPr>
-              <a:spcBef>
-                <a:spcPts val="500"/>
-              </a:spcBef>
-              <a:defRPr sz="1500">
-                <a:solidFill>
-                  <a:srgbClr val="000000"/>
-                </a:solidFill>
-              </a:defRPr>
-            </a:pPr>
-            <a:r>
-              <a:t>  - Kalau sumber intel error, sistem jujur bilang</a:t>
-            </a:r>
-          </a:p>
-          <a:p>
-            <a:pPr>
-              <a:spcBef>
-                <a:spcPts val="500"/>
-              </a:spcBef>
-              <a:defRPr sz="1500">
-                <a:solidFill>
-                  <a:srgbClr val="000000"/>
-                </a:solidFill>
-              </a:defRPr>
-            </a:pPr>
-            <a:r>
-              <a:t>    'saya tidak bisa verifikasi' bukan diam saja</a:t>
-            </a:r>
-          </a:p>
-          <a:p>
-            <a:pPr>
-              <a:spcBef>
-                <a:spcPts val="500"/>
-              </a:spcBef>
-              <a:defRPr sz="1500">
-                <a:solidFill>
-                  <a:srgbClr val="000000"/>
-                </a:solidFill>
-              </a:defRPr>
-            </a:pPr>
-            <a:r>
-              <a:t>  - Auto-isolate cuma untuk keyakinan tinggi,</a:t>
-            </a:r>
-          </a:p>
-          <a:p>
-            <a:pPr>
-              <a:spcBef>
-                <a:spcPts val="500"/>
-              </a:spcBef>
-              <a:defRPr sz="1500">
-                <a:solidFill>
-                  <a:srgbClr val="000000"/>
-                </a:solidFill>
-              </a:defRPr>
-            </a:pPr>
-            <a:r>
-              <a:t>    sisanya serahin ke analis</a:t>
-            </a:r>
-          </a:p>
-        </p:txBody>
-      </p:sp>
-      <p:sp>
-        <p:nvSpPr>
-          <p:cNvPr id="5" name="TextBox 4"/>
-          <p:cNvSpPr txBox="1"/>
-          <p:nvPr/>
-        </p:nvSpPr>
-        <p:spPr>
-          <a:xfrm>
-            <a:off x="6217920" y="1097280"/>
-            <a:ext cx="5303520" cy="5029200"/>
-          </a:xfrm>
-          <a:prstGeom prst="rect">
-            <a:avLst/>
-          </a:prstGeom>
-          <a:noFill/>
-        </p:spPr>
-        <p:txBody>
-          <a:bodyPr wrap="square">
-            <a:spAutoFit/>
-          </a:bodyPr>
-          <a:lstStyle/>
-          <a:p>
-            <a:pPr>
-              <a:spcBef>
-                <a:spcPts val="500"/>
-              </a:spcBef>
-              <a:defRPr sz="1500">
-                <a:solidFill>
-                  <a:srgbClr val="000000"/>
-                </a:solidFill>
-              </a:defRPr>
-            </a:pPr>
-            <a:r>
-              <a:t>Yang belum ada di SOAR lain:</a:t>
-            </a:r>
-          </a:p>
-          <a:p>
-            <a:pPr>
-              <a:spcBef>
-                <a:spcPts val="500"/>
-              </a:spcBef>
-              <a:defRPr sz="1500">
-                <a:solidFill>
-                  <a:srgbClr val="000000"/>
-                </a:solidFill>
-              </a:defRPr>
-            </a:pPr>
-            <a:r>
-              <a:t>  - LLM advisory lokal (Ollama) untuk alert ambigu</a:t>
-            </a:r>
-          </a:p>
-          <a:p>
-            <a:pPr>
-              <a:spcBef>
-                <a:spcPts val="500"/>
-              </a:spcBef>
-              <a:defRPr sz="1500">
-                <a:solidFill>
-                  <a:srgbClr val="000000"/>
-                </a:solidFill>
-              </a:defRPr>
-            </a:pPr>
-            <a:r>
-              <a:t>    tanpa kirim data ke cloud</a:t>
-            </a:r>
-          </a:p>
-          <a:p>
-            <a:pPr>
-              <a:spcBef>
-                <a:spcPts val="500"/>
-              </a:spcBef>
-              <a:defRPr sz="1500">
-                <a:solidFill>
-                  <a:srgbClr val="000000"/>
-                </a:solidFill>
-              </a:defRPr>
-            </a:pPr>
-            <a:r>
-              <a:t>  - Phishing proaktif: blok URL dari feed publik</a:t>
-            </a:r>
-          </a:p>
-          <a:p>
-            <a:pPr>
-              <a:spcBef>
-                <a:spcPts val="500"/>
-              </a:spcBef>
-              <a:defRPr sz="1500">
-                <a:solidFill>
-                  <a:srgbClr val="000000"/>
-                </a:solidFill>
-              </a:defRPr>
-            </a:pPr>
-            <a:r>
-              <a:t>    sebelum user sempat klik</a:t>
-            </a:r>
-          </a:p>
-          <a:p>
-            <a:pPr>
-              <a:spcBef>
-                <a:spcPts val="500"/>
-              </a:spcBef>
-              <a:defRPr sz="1500">
-                <a:solidFill>
-                  <a:srgbClr val="000000"/>
-                </a:solidFill>
-              </a:defRPr>
-            </a:pPr>
-            <a:r>
-              <a:t>  - Health monitor yang sadar diri: tahu kapan</a:t>
-            </a:r>
-          </a:p>
-          <a:p>
-            <a:pPr>
-              <a:spcBef>
-                <a:spcPts val="500"/>
-              </a:spcBef>
-              <a:defRPr sz="1500">
-                <a:solidFill>
-                  <a:srgbClr val="000000"/>
-                </a:solidFill>
-              </a:defRPr>
-            </a:pPr>
-            <a:r>
-              <a:t>    ia sedang tidak bisa bekerja dengan baik</a:t>
-            </a:r>
-          </a:p>
-          <a:p>
-            <a:pPr>
-              <a:spcBef>
-                <a:spcPts val="500"/>
-              </a:spcBef>
-              <a:defRPr sz="1500">
-                <a:solidFill>
-                  <a:srgbClr val="000000"/>
-                </a:solidFill>
-              </a:defRPr>
-            </a:pPr>
-            <a:r>
-              <a:t>  - Cache VT dengan TTL diferensial:</a:t>
-            </a:r>
-          </a:p>
-          <a:p>
-            <a:pPr>
-              <a:spcBef>
-                <a:spcPts val="500"/>
-              </a:spcBef>
-              <a:defRPr sz="1500">
-                <a:solidFill>
-                  <a:srgbClr val="000000"/>
-                </a:solidFill>
-              </a:defRPr>
-            </a:pPr>
-            <a:r>
-              <a:t>    file bersih di-scan ulang lebih cepat</a:t>
-            </a:r>
-          </a:p>
-        </p:txBody>
-      </p:sp>
-      <p:sp>
-        <p:nvSpPr>
-          <p:cNvPr id="6" name="TextBox 5"/>
-          <p:cNvSpPr txBox="1"/>
-          <p:nvPr/>
-        </p:nvSpPr>
-        <p:spPr>
-          <a:xfrm>
-            <a:off x="457200" y="4206240"/>
-            <a:ext cx="10972800" cy="2286000"/>
-          </a:xfrm>
-          <a:prstGeom prst="rect">
-            <a:avLst/>
-          </a:prstGeom>
-          <a:noFill/>
-        </p:spPr>
-        <p:txBody>
-          <a:bodyPr wrap="square">
-            <a:spAutoFit/>
-          </a:bodyPr>
-          <a:lstStyle/>
-          <a:p>
-            <a:pPr>
-              <a:spcBef>
-                <a:spcPts val="500"/>
-              </a:spcBef>
-              <a:defRPr sz="1400">
-                <a:solidFill>
-                  <a:srgbClr val="666666"/>
-                </a:solidFill>
-              </a:defRPr>
-            </a:pPr>
-            <a:r>
-              <a:t>Bukti pendukung:</a:t>
-            </a:r>
-          </a:p>
-          <a:p>
-            <a:pPr>
-              <a:spcBef>
-                <a:spcPts val="500"/>
-              </a:spcBef>
-              <a:defRPr sz="1400">
-                <a:solidFill>
-                  <a:srgbClr val="666666"/>
-                </a:solidFill>
-              </a:defRPr>
-            </a:pPr>
-            <a:r>
-              <a:t>  - Mapping MITRE ATT&amp;CK: 10 teknik tercakup dalam playbook</a:t>
-            </a:r>
-          </a:p>
-          <a:p>
-            <a:pPr>
-              <a:spcBef>
-                <a:spcPts val="500"/>
-              </a:spcBef>
-              <a:defRPr sz="1400">
-                <a:solidFill>
-                  <a:srgbClr val="666666"/>
-                </a:solidFill>
-              </a:defRPr>
-            </a:pPr>
-            <a:r>
-              <a:t>  - Perbandingan empiris n8n vs Shuffle: 6 aspek dinilai (n8n menang 3,8 vs 2,5)</a:t>
-            </a:r>
-          </a:p>
-          <a:p>
-            <a:pPr>
-              <a:spcBef>
-                <a:spcPts val="500"/>
-              </a:spcBef>
-              <a:defRPr sz="1400">
-                <a:solidFill>
-                  <a:srgbClr val="666666"/>
-                </a:solidFill>
-              </a:defRPr>
-            </a:pPr>
-            <a:r>
-              <a:t>  - Benchmark N&gt;=30 dengan data nyata, bukan simulasi</a:t>
-            </a:r>
-          </a:p>
-          <a:p>
-            <a:pPr>
-              <a:spcBef>
-                <a:spcPts val="500"/>
-              </a:spcBef>
-              <a:defRPr sz="1400">
-                <a:solidFill>
-                  <a:srgbClr val="666666"/>
-                </a:solidFill>
-              </a:defRPr>
-            </a:pPr>
-            <a:r>
-              <a:t>  - Semua konfigurasi di-version-control (Ansible + Docker Compose)</a:t>
             </a:r>
           </a:p>
         </p:txBody>
@@ -6276,7 +6871,7 @@
               </a:defRPr>
             </a:pPr>
             <a:r>
-              <a:t>Rencana ke Depan</a:t>
+              <a:t>Roadmap Pengerjaan</a:t>
             </a:r>
           </a:p>
         </p:txBody>
@@ -6324,6 +6919,1772 @@
           </a:p>
         </p:txBody>
       </p:sp>
+      <p:graphicFrame>
+        <p:nvGraphicFramePr>
+          <p:cNvPr id="4" name="Table 3"/>
+          <p:cNvGraphicFramePr>
+            <a:graphicFrameLocks noGrp="1"/>
+          </p:cNvGraphicFramePr>
+          <p:nvPr/>
+        </p:nvGraphicFramePr>
+        <p:xfrm>
+          <a:off x="457200" y="1097280"/>
+          <a:ext cx="9601200" cy="5303520"/>
+        </p:xfrm>
+        <a:graphic>
+          <a:graphicData uri="http://schemas.openxmlformats.org/drawingml/2006/table">
+            <a:tbl>
+              <a:tblPr firstRow="1" bandRow="1">
+                <a:tableStyleId>{5C22544A-7EE6-4342-B048-85BDC9FD1C3A}</a:tableStyleId>
+              </a:tblPr>
+              <a:tblGrid>
+                <a:gridCol w="2011680"/>
+                <a:gridCol w="4114800"/>
+                <a:gridCol w="1645920"/>
+                <a:gridCol w="1828800"/>
+              </a:tblGrid>
+              <a:tr h="279132">
+                <a:tc>
+                  <a:txBody>
+                    <a:bodyPr/>
+                    <a:lstStyle/>
+                    <a:p>
+                      <a:pPr>
+                        <a:defRPr sz="1200" b="1">
+                          <a:solidFill>
+                            <a:srgbClr val="FFFFFF"/>
+                          </a:solidFill>
+                        </a:defRPr>
+                      </a:pPr>
+                      <a:r>
+                        <a:t>Kategori</a:t>
+                      </a:r>
+                    </a:p>
+                  </a:txBody>
+                  <a:tcPr>
+                    <a:solidFill>
+                      <a:srgbClr val="1A568E"/>
+                    </a:solidFill>
+                  </a:tcPr>
+                </a:tc>
+                <a:tc>
+                  <a:txBody>
+                    <a:bodyPr/>
+                    <a:lstStyle/>
+                    <a:p>
+                      <a:pPr>
+                        <a:defRPr sz="1200" b="1">
+                          <a:solidFill>
+                            <a:srgbClr val="FFFFFF"/>
+                          </a:solidFill>
+                        </a:defRPr>
+                      </a:pPr>
+                      <a:r>
+                        <a:t>Item</a:t>
+                      </a:r>
+                    </a:p>
+                  </a:txBody>
+                  <a:tcPr>
+                    <a:solidFill>
+                      <a:srgbClr val="1A568E"/>
+                    </a:solidFill>
+                  </a:tcPr>
+                </a:tc>
+                <a:tc>
+                  <a:txBody>
+                    <a:bodyPr/>
+                    <a:lstStyle/>
+                    <a:p>
+                      <a:pPr>
+                        <a:defRPr sz="1200" b="1">
+                          <a:solidFill>
+                            <a:srgbClr val="FFFFFF"/>
+                          </a:solidFill>
+                        </a:defRPr>
+                      </a:pPr>
+                      <a:r>
+                        <a:t>Status</a:t>
+                      </a:r>
+                    </a:p>
+                  </a:txBody>
+                  <a:tcPr>
+                    <a:solidFill>
+                      <a:srgbClr val="1A568E"/>
+                    </a:solidFill>
+                  </a:tcPr>
+                </a:tc>
+                <a:tc>
+                  <a:txBody>
+                    <a:bodyPr/>
+                    <a:lstStyle/>
+                    <a:p>
+                      <a:pPr>
+                        <a:defRPr sz="1200" b="1">
+                          <a:solidFill>
+                            <a:srgbClr val="FFFFFF"/>
+                          </a:solidFill>
+                        </a:defRPr>
+                      </a:pPr>
+                      <a:r>
+                        <a:t>Tanggal</a:t>
+                      </a:r>
+                    </a:p>
+                  </a:txBody>
+                  <a:tcPr>
+                    <a:solidFill>
+                      <a:srgbClr val="1A568E"/>
+                    </a:solidFill>
+                  </a:tcPr>
+                </a:tc>
+              </a:tr>
+              <a:tr h="279132">
+                <a:tc>
+                  <a:txBody>
+                    <a:bodyPr/>
+                    <a:lstStyle/>
+                    <a:p>
+                      <a:pPr>
+                        <a:defRPr sz="1200">
+                          <a:solidFill>
+                            <a:srgbClr val="000000"/>
+                          </a:solidFill>
+                        </a:defRPr>
+                      </a:pPr>
+                      <a:r>
+                        <a:t>A - Bug fix</a:t>
+                      </a:r>
+                    </a:p>
+                  </a:txBody>
+                  <a:tcPr/>
+                </a:tc>
+                <a:tc>
+                  <a:txBody>
+                    <a:bodyPr/>
+                    <a:lstStyle/>
+                    <a:p>
+                      <a:pPr>
+                        <a:defRPr sz="1200">
+                          <a:solidFill>
+                            <a:srgbClr val="000000"/>
+                          </a:solidFill>
+                        </a:defRPr>
+                      </a:pPr>
+                      <a:r>
+                        <a:t>block-domain persist</a:t>
+                      </a:r>
+                    </a:p>
+                  </a:txBody>
+                  <a:tcPr/>
+                </a:tc>
+                <a:tc>
+                  <a:txBody>
+                    <a:bodyPr/>
+                    <a:lstStyle/>
+                    <a:p>
+                      <a:pPr>
+                        <a:defRPr sz="1200">
+                          <a:solidFill>
+                            <a:srgbClr val="000000"/>
+                          </a:solidFill>
+                        </a:defRPr>
+                      </a:pPr>
+                      <a:r>
+                        <a:t>Selesai</a:t>
+                      </a:r>
+                    </a:p>
+                  </a:txBody>
+                  <a:tcPr/>
+                </a:tc>
+                <a:tc>
+                  <a:txBody>
+                    <a:bodyPr/>
+                    <a:lstStyle/>
+                    <a:p>
+                      <a:pPr>
+                        <a:defRPr sz="1200">
+                          <a:solidFill>
+                            <a:srgbClr val="000000"/>
+                          </a:solidFill>
+                        </a:defRPr>
+                      </a:pPr>
+                      <a:r>
+                        <a:t>2026-07-02</a:t>
+                      </a:r>
+                    </a:p>
+                  </a:txBody>
+                  <a:tcPr/>
+                </a:tc>
+              </a:tr>
+              <a:tr h="279132">
+                <a:tc>
+                  <a:txBody>
+                    <a:bodyPr/>
+                    <a:lstStyle/>
+                    <a:p>
+                      <a:pPr>
+                        <a:defRPr sz="1200">
+                          <a:solidFill>
+                            <a:srgbClr val="000000"/>
+                          </a:solidFill>
+                        </a:defRPr>
+                      </a:pPr>
+                      <a:r>
+                        <a:t>A - Bug fix</a:t>
+                      </a:r>
+                    </a:p>
+                  </a:txBody>
+                  <a:tcPr>
+                    <a:solidFill>
+                      <a:srgbClr val="F0F0F0"/>
+                    </a:solidFill>
+                  </a:tcPr>
+                </a:tc>
+                <a:tc>
+                  <a:txBody>
+                    <a:bodyPr/>
+                    <a:lstStyle/>
+                    <a:p>
+                      <a:pPr>
+                        <a:defRPr sz="1200">
+                          <a:solidFill>
+                            <a:srgbClr val="000000"/>
+                          </a:solidFill>
+                        </a:defRPr>
+                      </a:pPr>
+                      <a:r>
+                        <a:t>Notifikasi ganda diperbaiki</a:t>
+                      </a:r>
+                    </a:p>
+                  </a:txBody>
+                  <a:tcPr>
+                    <a:solidFill>
+                      <a:srgbClr val="F0F0F0"/>
+                    </a:solidFill>
+                  </a:tcPr>
+                </a:tc>
+                <a:tc>
+                  <a:txBody>
+                    <a:bodyPr/>
+                    <a:lstStyle/>
+                    <a:p>
+                      <a:pPr>
+                        <a:defRPr sz="1200">
+                          <a:solidFill>
+                            <a:srgbClr val="000000"/>
+                          </a:solidFill>
+                        </a:defRPr>
+                      </a:pPr>
+                      <a:r>
+                        <a:t>Selesai</a:t>
+                      </a:r>
+                    </a:p>
+                  </a:txBody>
+                  <a:tcPr>
+                    <a:solidFill>
+                      <a:srgbClr val="F0F0F0"/>
+                    </a:solidFill>
+                  </a:tcPr>
+                </a:tc>
+                <a:tc>
+                  <a:txBody>
+                    <a:bodyPr/>
+                    <a:lstStyle/>
+                    <a:p>
+                      <a:pPr>
+                        <a:defRPr sz="1200">
+                          <a:solidFill>
+                            <a:srgbClr val="000000"/>
+                          </a:solidFill>
+                        </a:defRPr>
+                      </a:pPr>
+                      <a:r>
+                        <a:t>2026-07-02</a:t>
+                      </a:r>
+                    </a:p>
+                  </a:txBody>
+                  <a:tcPr>
+                    <a:solidFill>
+                      <a:srgbClr val="F0F0F0"/>
+                    </a:solidFill>
+                  </a:tcPr>
+                </a:tc>
+              </a:tr>
+              <a:tr h="279132">
+                <a:tc>
+                  <a:txBody>
+                    <a:bodyPr/>
+                    <a:lstStyle/>
+                    <a:p>
+                      <a:pPr>
+                        <a:defRPr sz="1200">
+                          <a:solidFill>
+                            <a:srgbClr val="000000"/>
+                          </a:solidFill>
+                        </a:defRPr>
+                      </a:pPr>
+                      <a:r>
+                        <a:t>B - Threat intel</a:t>
+                      </a:r>
+                    </a:p>
+                  </a:txBody>
+                  <a:tcPr/>
+                </a:tc>
+                <a:tc>
+                  <a:txBody>
+                    <a:bodyPr/>
+                    <a:lstStyle/>
+                    <a:p>
+                      <a:pPr>
+                        <a:defRPr sz="1200">
+                          <a:solidFill>
+                            <a:srgbClr val="000000"/>
+                          </a:solidFill>
+                        </a:defRPr>
+                      </a:pPr>
+                      <a:r>
+                        <a:t>Hybrid: risky ext -&gt; HITL review</a:t>
+                      </a:r>
+                    </a:p>
+                  </a:txBody>
+                  <a:tcPr/>
+                </a:tc>
+                <a:tc>
+                  <a:txBody>
+                    <a:bodyPr/>
+                    <a:lstStyle/>
+                    <a:p>
+                      <a:pPr>
+                        <a:defRPr sz="1200">
+                          <a:solidFill>
+                            <a:srgbClr val="000000"/>
+                          </a:solidFill>
+                        </a:defRPr>
+                      </a:pPr>
+                      <a:r>
+                        <a:t>Selesai</a:t>
+                      </a:r>
+                    </a:p>
+                  </a:txBody>
+                  <a:tcPr/>
+                </a:tc>
+                <a:tc>
+                  <a:txBody>
+                    <a:bodyPr/>
+                    <a:lstStyle/>
+                    <a:p>
+                      <a:pPr>
+                        <a:defRPr sz="1200">
+                          <a:solidFill>
+                            <a:srgbClr val="000000"/>
+                          </a:solidFill>
+                        </a:defRPr>
+                      </a:pPr>
+                      <a:r>
+                        <a:t>2026-07-02</a:t>
+                      </a:r>
+                    </a:p>
+                  </a:txBody>
+                  <a:tcPr/>
+                </a:tc>
+              </a:tr>
+              <a:tr h="279132">
+                <a:tc>
+                  <a:txBody>
+                    <a:bodyPr/>
+                    <a:lstStyle/>
+                    <a:p>
+                      <a:pPr>
+                        <a:defRPr sz="1200">
+                          <a:solidFill>
+                            <a:srgbClr val="000000"/>
+                          </a:solidFill>
+                        </a:defRPr>
+                      </a:pPr>
+                      <a:r>
+                        <a:t>B - Threat intel</a:t>
+                      </a:r>
+                    </a:p>
+                  </a:txBody>
+                  <a:tcPr>
+                    <a:solidFill>
+                      <a:srgbClr val="F0F0F0"/>
+                    </a:solidFill>
+                  </a:tcPr>
+                </a:tc>
+                <a:tc>
+                  <a:txBody>
+                    <a:bodyPr/>
+                    <a:lstStyle/>
+                    <a:p>
+                      <a:pPr>
+                        <a:defRPr sz="1200">
+                          <a:solidFill>
+                            <a:srgbClr val="000000"/>
+                          </a:solidFill>
+                        </a:defRPr>
+                      </a:pPr>
+                      <a:r>
+                        <a:t>MalwareBazaar ensemble (VT+MB)</a:t>
+                      </a:r>
+                    </a:p>
+                  </a:txBody>
+                  <a:tcPr>
+                    <a:solidFill>
+                      <a:srgbClr val="F0F0F0"/>
+                    </a:solidFill>
+                  </a:tcPr>
+                </a:tc>
+                <a:tc>
+                  <a:txBody>
+                    <a:bodyPr/>
+                    <a:lstStyle/>
+                    <a:p>
+                      <a:pPr>
+                        <a:defRPr sz="1200">
+                          <a:solidFill>
+                            <a:srgbClr val="000000"/>
+                          </a:solidFill>
+                        </a:defRPr>
+                      </a:pPr>
+                      <a:r>
+                        <a:t>Selesai</a:t>
+                      </a:r>
+                    </a:p>
+                  </a:txBody>
+                  <a:tcPr>
+                    <a:solidFill>
+                      <a:srgbClr val="F0F0F0"/>
+                    </a:solidFill>
+                  </a:tcPr>
+                </a:tc>
+                <a:tc>
+                  <a:txBody>
+                    <a:bodyPr/>
+                    <a:lstStyle/>
+                    <a:p>
+                      <a:pPr>
+                        <a:defRPr sz="1200">
+                          <a:solidFill>
+                            <a:srgbClr val="000000"/>
+                          </a:solidFill>
+                        </a:defRPr>
+                      </a:pPr>
+                      <a:r>
+                        <a:t>2026-09-02</a:t>
+                      </a:r>
+                    </a:p>
+                  </a:txBody>
+                  <a:tcPr>
+                    <a:solidFill>
+                      <a:srgbClr val="F0F0F0"/>
+                    </a:solidFill>
+                  </a:tcPr>
+                </a:tc>
+              </a:tr>
+              <a:tr h="279132">
+                <a:tc>
+                  <a:txBody>
+                    <a:bodyPr/>
+                    <a:lstStyle/>
+                    <a:p>
+                      <a:pPr>
+                        <a:defRPr sz="1200">
+                          <a:solidFill>
+                            <a:srgbClr val="000000"/>
+                          </a:solidFill>
+                        </a:defRPr>
+                      </a:pPr>
+                      <a:r>
+                        <a:t>B - Threat intel</a:t>
+                      </a:r>
+                    </a:p>
+                  </a:txBody>
+                  <a:tcPr/>
+                </a:tc>
+                <a:tc>
+                  <a:txBody>
+                    <a:bodyPr/>
+                    <a:lstStyle/>
+                    <a:p>
+                      <a:pPr>
+                        <a:defRPr sz="1200">
+                          <a:solidFill>
+                            <a:srgbClr val="000000"/>
+                          </a:solidFill>
+                        </a:defRPr>
+                      </a:pPr>
+                      <a:r>
+                        <a:t>TTL diferensial cache</a:t>
+                      </a:r>
+                    </a:p>
+                  </a:txBody>
+                  <a:tcPr/>
+                </a:tc>
+                <a:tc>
+                  <a:txBody>
+                    <a:bodyPr/>
+                    <a:lstStyle/>
+                    <a:p>
+                      <a:pPr>
+                        <a:defRPr sz="1200">
+                          <a:solidFill>
+                            <a:srgbClr val="000000"/>
+                          </a:solidFill>
+                        </a:defRPr>
+                      </a:pPr>
+                      <a:r>
+                        <a:t>Selesai</a:t>
+                      </a:r>
+                    </a:p>
+                  </a:txBody>
+                  <a:tcPr/>
+                </a:tc>
+                <a:tc>
+                  <a:txBody>
+                    <a:bodyPr/>
+                    <a:lstStyle/>
+                    <a:p>
+                      <a:pPr>
+                        <a:defRPr sz="1200">
+                          <a:solidFill>
+                            <a:srgbClr val="000000"/>
+                          </a:solidFill>
+                        </a:defRPr>
+                      </a:pPr>
+                      <a:r>
+                        <a:t>2026-09-02</a:t>
+                      </a:r>
+                    </a:p>
+                  </a:txBody>
+                  <a:tcPr/>
+                </a:tc>
+              </a:tr>
+              <a:tr h="279132">
+                <a:tc>
+                  <a:txBody>
+                    <a:bodyPr/>
+                    <a:lstStyle/>
+                    <a:p>
+                      <a:pPr>
+                        <a:defRPr sz="1200">
+                          <a:solidFill>
+                            <a:srgbClr val="000000"/>
+                          </a:solidFill>
+                        </a:defRPr>
+                      </a:pPr>
+                      <a:r>
+                        <a:t>C - Evaluasi</a:t>
+                      </a:r>
+                    </a:p>
+                  </a:txBody>
+                  <a:tcPr>
+                    <a:solidFill>
+                      <a:srgbClr val="F0F0F0"/>
+                    </a:solidFill>
+                  </a:tcPr>
+                </a:tc>
+                <a:tc>
+                  <a:txBody>
+                    <a:bodyPr/>
+                    <a:lstStyle/>
+                    <a:p>
+                      <a:pPr>
+                        <a:defRPr sz="1200">
+                          <a:solidFill>
+                            <a:srgbClr val="000000"/>
+                          </a:solidFill>
+                        </a:defRPr>
+                      </a:pPr>
+                      <a:r>
+                        <a:t>MTTR &amp; FP suppression terukur</a:t>
+                      </a:r>
+                    </a:p>
+                  </a:txBody>
+                  <a:tcPr>
+                    <a:solidFill>
+                      <a:srgbClr val="F0F0F0"/>
+                    </a:solidFill>
+                  </a:tcPr>
+                </a:tc>
+                <a:tc>
+                  <a:txBody>
+                    <a:bodyPr/>
+                    <a:lstStyle/>
+                    <a:p>
+                      <a:pPr>
+                        <a:defRPr sz="1200">
+                          <a:solidFill>
+                            <a:srgbClr val="000000"/>
+                          </a:solidFill>
+                        </a:defRPr>
+                      </a:pPr>
+                      <a:r>
+                        <a:t>Selesai</a:t>
+                      </a:r>
+                    </a:p>
+                  </a:txBody>
+                  <a:tcPr>
+                    <a:solidFill>
+                      <a:srgbClr val="F0F0F0"/>
+                    </a:solidFill>
+                  </a:tcPr>
+                </a:tc>
+                <a:tc>
+                  <a:txBody>
+                    <a:bodyPr/>
+                    <a:lstStyle/>
+                    <a:p>
+                      <a:pPr>
+                        <a:defRPr sz="1200">
+                          <a:solidFill>
+                            <a:srgbClr val="000000"/>
+                          </a:solidFill>
+                        </a:defRPr>
+                      </a:pPr>
+                      <a:r>
+                        <a:t>2026-07-02</a:t>
+                      </a:r>
+                    </a:p>
+                  </a:txBody>
+                  <a:tcPr>
+                    <a:solidFill>
+                      <a:srgbClr val="F0F0F0"/>
+                    </a:solidFill>
+                  </a:tcPr>
+                </a:tc>
+              </a:tr>
+              <a:tr h="279132">
+                <a:tc>
+                  <a:txBody>
+                    <a:bodyPr/>
+                    <a:lstStyle/>
+                    <a:p>
+                      <a:pPr>
+                        <a:defRPr sz="1200">
+                          <a:solidFill>
+                            <a:srgbClr val="000000"/>
+                          </a:solidFill>
+                        </a:defRPr>
+                      </a:pPr>
+                      <a:r>
+                        <a:t>C - Evaluasi</a:t>
+                      </a:r>
+                    </a:p>
+                  </a:txBody>
+                  <a:tcPr/>
+                </a:tc>
+                <a:tc>
+                  <a:txBody>
+                    <a:bodyPr/>
+                    <a:lstStyle/>
+                    <a:p>
+                      <a:pPr>
+                        <a:defRPr sz="1200">
+                          <a:solidFill>
+                            <a:srgbClr val="000000"/>
+                          </a:solidFill>
+                        </a:defRPr>
+                      </a:pPr>
+                      <a:r>
+                        <a:t>Benchmark N&gt;=30 + load test</a:t>
+                      </a:r>
+                    </a:p>
+                  </a:txBody>
+                  <a:tcPr/>
+                </a:tc>
+                <a:tc>
+                  <a:txBody>
+                    <a:bodyPr/>
+                    <a:lstStyle/>
+                    <a:p>
+                      <a:pPr>
+                        <a:defRPr sz="1200">
+                          <a:solidFill>
+                            <a:srgbClr val="000000"/>
+                          </a:solidFill>
+                        </a:defRPr>
+                      </a:pPr>
+                      <a:r>
+                        <a:t>Selesai</a:t>
+                      </a:r>
+                    </a:p>
+                  </a:txBody>
+                  <a:tcPr/>
+                </a:tc>
+                <a:tc>
+                  <a:txBody>
+                    <a:bodyPr/>
+                    <a:lstStyle/>
+                    <a:p>
+                      <a:pPr>
+                        <a:defRPr sz="1200">
+                          <a:solidFill>
+                            <a:srgbClr val="000000"/>
+                          </a:solidFill>
+                        </a:defRPr>
+                      </a:pPr>
+                      <a:r>
+                        <a:t>2026-09-02</a:t>
+                      </a:r>
+                    </a:p>
+                  </a:txBody>
+                  <a:tcPr/>
+                </a:tc>
+              </a:tr>
+              <a:tr h="279132">
+                <a:tc>
+                  <a:txBody>
+                    <a:bodyPr/>
+                    <a:lstStyle/>
+                    <a:p>
+                      <a:pPr>
+                        <a:defRPr sz="1200">
+                          <a:solidFill>
+                            <a:srgbClr val="000000"/>
+                          </a:solidFill>
+                        </a:defRPr>
+                      </a:pPr>
+                      <a:r>
+                        <a:t>C - Evaluasi</a:t>
+                      </a:r>
+                    </a:p>
+                  </a:txBody>
+                  <a:tcPr>
+                    <a:solidFill>
+                      <a:srgbClr val="F0F0F0"/>
+                    </a:solidFill>
+                  </a:tcPr>
+                </a:tc>
+                <a:tc>
+                  <a:txBody>
+                    <a:bodyPr/>
+                    <a:lstStyle/>
+                    <a:p>
+                      <a:pPr>
+                        <a:defRPr sz="1200">
+                          <a:solidFill>
+                            <a:srgbClr val="000000"/>
+                          </a:solidFill>
+                        </a:defRPr>
+                      </a:pPr>
+                      <a:r>
+                        <a:t>MITRE ATT&amp;CK mapping (10 teknik)</a:t>
+                      </a:r>
+                    </a:p>
+                  </a:txBody>
+                  <a:tcPr>
+                    <a:solidFill>
+                      <a:srgbClr val="F0F0F0"/>
+                    </a:solidFill>
+                  </a:tcPr>
+                </a:tc>
+                <a:tc>
+                  <a:txBody>
+                    <a:bodyPr/>
+                    <a:lstStyle/>
+                    <a:p>
+                      <a:pPr>
+                        <a:defRPr sz="1200">
+                          <a:solidFill>
+                            <a:srgbClr val="000000"/>
+                          </a:solidFill>
+                        </a:defRPr>
+                      </a:pPr>
+                      <a:r>
+                        <a:t>Selesai</a:t>
+                      </a:r>
+                    </a:p>
+                  </a:txBody>
+                  <a:tcPr>
+                    <a:solidFill>
+                      <a:srgbClr val="F0F0F0"/>
+                    </a:solidFill>
+                  </a:tcPr>
+                </a:tc>
+                <a:tc>
+                  <a:txBody>
+                    <a:bodyPr/>
+                    <a:lstStyle/>
+                    <a:p>
+                      <a:pPr>
+                        <a:defRPr sz="1200">
+                          <a:solidFill>
+                            <a:srgbClr val="000000"/>
+                          </a:solidFill>
+                        </a:defRPr>
+                      </a:pPr>
+                      <a:r>
+                        <a:t>2026-09-02</a:t>
+                      </a:r>
+                    </a:p>
+                  </a:txBody>
+                  <a:tcPr>
+                    <a:solidFill>
+                      <a:srgbClr val="F0F0F0"/>
+                    </a:solidFill>
+                  </a:tcPr>
+                </a:tc>
+              </a:tr>
+              <a:tr h="279132">
+                <a:tc>
+                  <a:txBody>
+                    <a:bodyPr/>
+                    <a:lstStyle/>
+                    <a:p>
+                      <a:pPr>
+                        <a:defRPr sz="1200">
+                          <a:solidFill>
+                            <a:srgbClr val="000000"/>
+                          </a:solidFill>
+                        </a:defRPr>
+                      </a:pPr>
+                      <a:r>
+                        <a:t>D - Hardening</a:t>
+                      </a:r>
+                    </a:p>
+                  </a:txBody>
+                  <a:tcPr/>
+                </a:tc>
+                <a:tc>
+                  <a:txBody>
+                    <a:bodyPr/>
+                    <a:lstStyle/>
+                    <a:p>
+                      <a:pPr>
+                        <a:defRPr sz="1200">
+                          <a:solidFill>
+                            <a:srgbClr val="000000"/>
+                          </a:solidFill>
+                        </a:defRPr>
+                      </a:pPr>
+                      <a:r>
+                        <a:t>Caddy + TLS + Ansible IaC</a:t>
+                      </a:r>
+                    </a:p>
+                  </a:txBody>
+                  <a:tcPr/>
+                </a:tc>
+                <a:tc>
+                  <a:txBody>
+                    <a:bodyPr/>
+                    <a:lstStyle/>
+                    <a:p>
+                      <a:pPr>
+                        <a:defRPr sz="1200">
+                          <a:solidFill>
+                            <a:srgbClr val="000000"/>
+                          </a:solidFill>
+                        </a:defRPr>
+                      </a:pPr>
+                      <a:r>
+                        <a:t>Selesai</a:t>
+                      </a:r>
+                    </a:p>
+                  </a:txBody>
+                  <a:tcPr/>
+                </a:tc>
+                <a:tc>
+                  <a:txBody>
+                    <a:bodyPr/>
+                    <a:lstStyle/>
+                    <a:p>
+                      <a:pPr>
+                        <a:defRPr sz="1200">
+                          <a:solidFill>
+                            <a:srgbClr val="000000"/>
+                          </a:solidFill>
+                        </a:defRPr>
+                      </a:pPr>
+                      <a:r>
+                        <a:t>2026-07-06</a:t>
+                      </a:r>
+                    </a:p>
+                  </a:txBody>
+                  <a:tcPr/>
+                </a:tc>
+              </a:tr>
+              <a:tr h="279132">
+                <a:tc>
+                  <a:txBody>
+                    <a:bodyPr/>
+                    <a:lstStyle/>
+                    <a:p>
+                      <a:pPr>
+                        <a:defRPr sz="1200">
+                          <a:solidFill>
+                            <a:srgbClr val="000000"/>
+                          </a:solidFill>
+                        </a:defRPr>
+                      </a:pPr>
+                      <a:r>
+                        <a:t>F - Explainable</a:t>
+                      </a:r>
+                    </a:p>
+                  </a:txBody>
+                  <a:tcPr>
+                    <a:solidFill>
+                      <a:srgbClr val="F0F0F0"/>
+                    </a:solidFill>
+                  </a:tcPr>
+                </a:tc>
+                <a:tc>
+                  <a:txBody>
+                    <a:bodyPr/>
+                    <a:lstStyle/>
+                    <a:p>
+                      <a:pPr>
+                        <a:defRPr sz="1200">
+                          <a:solidFill>
+                            <a:srgbClr val="000000"/>
+                          </a:solidFill>
+                        </a:defRPr>
+                      </a:pPr>
+                      <a:r>
+                        <a:t>Self-aware + audit trail</a:t>
+                      </a:r>
+                    </a:p>
+                  </a:txBody>
+                  <a:tcPr>
+                    <a:solidFill>
+                      <a:srgbClr val="F0F0F0"/>
+                    </a:solidFill>
+                  </a:tcPr>
+                </a:tc>
+                <a:tc>
+                  <a:txBody>
+                    <a:bodyPr/>
+                    <a:lstStyle/>
+                    <a:p>
+                      <a:pPr>
+                        <a:defRPr sz="1200">
+                          <a:solidFill>
+                            <a:srgbClr val="000000"/>
+                          </a:solidFill>
+                        </a:defRPr>
+                      </a:pPr>
+                      <a:r>
+                        <a:t>Selesai</a:t>
+                      </a:r>
+                    </a:p>
+                  </a:txBody>
+                  <a:tcPr>
+                    <a:solidFill>
+                      <a:srgbClr val="F0F0F0"/>
+                    </a:solidFill>
+                  </a:tcPr>
+                </a:tc>
+                <a:tc>
+                  <a:txBody>
+                    <a:bodyPr/>
+                    <a:lstStyle/>
+                    <a:p>
+                      <a:pPr>
+                        <a:defRPr sz="1200">
+                          <a:solidFill>
+                            <a:srgbClr val="000000"/>
+                          </a:solidFill>
+                        </a:defRPr>
+                      </a:pPr>
+                      <a:r>
+                        <a:t>2026-07-06</a:t>
+                      </a:r>
+                    </a:p>
+                  </a:txBody>
+                  <a:tcPr>
+                    <a:solidFill>
+                      <a:srgbClr val="F0F0F0"/>
+                    </a:solidFill>
+                  </a:tcPr>
+                </a:tc>
+              </a:tr>
+              <a:tr h="279132">
+                <a:tc>
+                  <a:txBody>
+                    <a:bodyPr/>
+                    <a:lstStyle/>
+                    <a:p>
+                      <a:pPr>
+                        <a:defRPr sz="1200">
+                          <a:solidFill>
+                            <a:srgbClr val="000000"/>
+                          </a:solidFill>
+                        </a:defRPr>
+                      </a:pPr>
+                      <a:r>
+                        <a:t>F - Explainable</a:t>
+                      </a:r>
+                    </a:p>
+                  </a:txBody>
+                  <a:tcPr/>
+                </a:tc>
+                <a:tc>
+                  <a:txBody>
+                    <a:bodyPr/>
+                    <a:lstStyle/>
+                    <a:p>
+                      <a:pPr>
+                        <a:defRPr sz="1200">
+                          <a:solidFill>
+                            <a:srgbClr val="000000"/>
+                          </a:solidFill>
+                        </a:defRPr>
+                      </a:pPr>
+                      <a:r>
+                        <a:t>LLM-fallback advisory</a:t>
+                      </a:r>
+                    </a:p>
+                  </a:txBody>
+                  <a:tcPr/>
+                </a:tc>
+                <a:tc>
+                  <a:txBody>
+                    <a:bodyPr/>
+                    <a:lstStyle/>
+                    <a:p>
+                      <a:pPr>
+                        <a:defRPr sz="1200">
+                          <a:solidFill>
+                            <a:srgbClr val="000000"/>
+                          </a:solidFill>
+                        </a:defRPr>
+                      </a:pPr>
+                      <a:r>
+                        <a:t>Selesai</a:t>
+                      </a:r>
+                    </a:p>
+                  </a:txBody>
+                  <a:tcPr/>
+                </a:tc>
+                <a:tc>
+                  <a:txBody>
+                    <a:bodyPr/>
+                    <a:lstStyle/>
+                    <a:p>
+                      <a:pPr>
+                        <a:defRPr sz="1200">
+                          <a:solidFill>
+                            <a:srgbClr val="000000"/>
+                          </a:solidFill>
+                        </a:defRPr>
+                      </a:pPr>
+                      <a:r>
+                        <a:t>2026-09-02</a:t>
+                      </a:r>
+                    </a:p>
+                  </a:txBody>
+                  <a:tcPr/>
+                </a:tc>
+              </a:tr>
+              <a:tr h="279132">
+                <a:tc>
+                  <a:txBody>
+                    <a:bodyPr/>
+                    <a:lstStyle/>
+                    <a:p>
+                      <a:pPr>
+                        <a:defRPr sz="1200">
+                          <a:solidFill>
+                            <a:srgbClr val="000000"/>
+                          </a:solidFill>
+                        </a:defRPr>
+                      </a:pPr>
+                      <a:r>
+                        <a:t>G - Perluasan</a:t>
+                      </a:r>
+                    </a:p>
+                  </a:txBody>
+                  <a:tcPr>
+                    <a:solidFill>
+                      <a:srgbClr val="F0F0F0"/>
+                    </a:solidFill>
+                  </a:tcPr>
+                </a:tc>
+                <a:tc>
+                  <a:txBody>
+                    <a:bodyPr/>
+                    <a:lstStyle/>
+                    <a:p>
+                      <a:pPr>
+                        <a:defRPr sz="1200">
+                          <a:solidFill>
+                            <a:srgbClr val="000000"/>
+                          </a:solidFill>
+                        </a:defRPr>
+                      </a:pPr>
+                      <a:r>
+                        <a:t>Phishing proaktif (URLhaus)</a:t>
+                      </a:r>
+                    </a:p>
+                  </a:txBody>
+                  <a:tcPr>
+                    <a:solidFill>
+                      <a:srgbClr val="F0F0F0"/>
+                    </a:solidFill>
+                  </a:tcPr>
+                </a:tc>
+                <a:tc>
+                  <a:txBody>
+                    <a:bodyPr/>
+                    <a:lstStyle/>
+                    <a:p>
+                      <a:pPr>
+                        <a:defRPr sz="1200">
+                          <a:solidFill>
+                            <a:srgbClr val="000000"/>
+                          </a:solidFill>
+                        </a:defRPr>
+                      </a:pPr>
+                      <a:r>
+                        <a:t>Selesai</a:t>
+                      </a:r>
+                    </a:p>
+                  </a:txBody>
+                  <a:tcPr>
+                    <a:solidFill>
+                      <a:srgbClr val="F0F0F0"/>
+                    </a:solidFill>
+                  </a:tcPr>
+                </a:tc>
+                <a:tc>
+                  <a:txBody>
+                    <a:bodyPr/>
+                    <a:lstStyle/>
+                    <a:p>
+                      <a:pPr>
+                        <a:defRPr sz="1200">
+                          <a:solidFill>
+                            <a:srgbClr val="000000"/>
+                          </a:solidFill>
+                        </a:defRPr>
+                      </a:pPr>
+                      <a:r>
+                        <a:t>2026-09-02</a:t>
+                      </a:r>
+                    </a:p>
+                  </a:txBody>
+                  <a:tcPr>
+                    <a:solidFill>
+                      <a:srgbClr val="F0F0F0"/>
+                    </a:solidFill>
+                  </a:tcPr>
+                </a:tc>
+              </a:tr>
+              <a:tr h="279132">
+                <a:tc>
+                  <a:txBody>
+                    <a:bodyPr/>
+                    <a:lstStyle/>
+                    <a:p>
+                      <a:pPr>
+                        <a:defRPr sz="1200">
+                          <a:solidFill>
+                            <a:srgbClr val="000000"/>
+                          </a:solidFill>
+                        </a:defRPr>
+                      </a:pPr>
+                      <a:r>
+                        <a:t>G - Perluasan</a:t>
+                      </a:r>
+                    </a:p>
+                  </a:txBody>
+                  <a:tcPr/>
+                </a:tc>
+                <a:tc>
+                  <a:txBody>
+                    <a:bodyPr/>
+                    <a:lstStyle/>
+                    <a:p>
+                      <a:pPr>
+                        <a:defRPr sz="1200">
+                          <a:solidFill>
+                            <a:srgbClr val="000000"/>
+                          </a:solidFill>
+                        </a:defRPr>
+                      </a:pPr>
+                      <a:r>
+                        <a:t>Magic-byte / exec-bit detection</a:t>
+                      </a:r>
+                    </a:p>
+                  </a:txBody>
+                  <a:tcPr/>
+                </a:tc>
+                <a:tc>
+                  <a:txBody>
+                    <a:bodyPr/>
+                    <a:lstStyle/>
+                    <a:p>
+                      <a:pPr>
+                        <a:defRPr sz="1200">
+                          <a:solidFill>
+                            <a:srgbClr val="000000"/>
+                          </a:solidFill>
+                        </a:defRPr>
+                      </a:pPr>
+                      <a:r>
+                        <a:t>Selesai</a:t>
+                      </a:r>
+                    </a:p>
+                  </a:txBody>
+                  <a:tcPr/>
+                </a:tc>
+                <a:tc>
+                  <a:txBody>
+                    <a:bodyPr/>
+                    <a:lstStyle/>
+                    <a:p>
+                      <a:pPr>
+                        <a:defRPr sz="1200">
+                          <a:solidFill>
+                            <a:srgbClr val="000000"/>
+                          </a:solidFill>
+                        </a:defRPr>
+                      </a:pPr>
+                      <a:r>
+                        <a:t>2026-09-02</a:t>
+                      </a:r>
+                    </a:p>
+                  </a:txBody>
+                  <a:tcPr/>
+                </a:tc>
+              </a:tr>
+              <a:tr h="279132">
+                <a:tc>
+                  <a:txBody>
+                    <a:bodyPr/>
+                    <a:lstStyle/>
+                    <a:p>
+                      <a:pPr>
+                        <a:defRPr sz="1200">
+                          <a:solidFill>
+                            <a:srgbClr val="000000"/>
+                          </a:solidFill>
+                        </a:defRPr>
+                      </a:pPr>
+                      <a:r>
+                        <a:t>H - Maintenance</a:t>
+                      </a:r>
+                    </a:p>
+                  </a:txBody>
+                  <a:tcPr>
+                    <a:solidFill>
+                      <a:srgbClr val="F0F0F0"/>
+                    </a:solidFill>
+                  </a:tcPr>
+                </a:tc>
+                <a:tc>
+                  <a:txBody>
+                    <a:bodyPr/>
+                    <a:lstStyle/>
+                    <a:p>
+                      <a:pPr>
+                        <a:defRPr sz="1200">
+                          <a:solidFill>
+                            <a:srgbClr val="000000"/>
+                          </a:solidFill>
+                        </a:defRPr>
+                      </a:pPr>
+                      <a:r>
+                        <a:t>n8n update + pin versi</a:t>
+                      </a:r>
+                    </a:p>
+                  </a:txBody>
+                  <a:tcPr>
+                    <a:solidFill>
+                      <a:srgbClr val="F0F0F0"/>
+                    </a:solidFill>
+                  </a:tcPr>
+                </a:tc>
+                <a:tc>
+                  <a:txBody>
+                    <a:bodyPr/>
+                    <a:lstStyle/>
+                    <a:p>
+                      <a:pPr>
+                        <a:defRPr sz="1200">
+                          <a:solidFill>
+                            <a:srgbClr val="000000"/>
+                          </a:solidFill>
+                        </a:defRPr>
+                      </a:pPr>
+                      <a:r>
+                        <a:t>Selesai</a:t>
+                      </a:r>
+                    </a:p>
+                  </a:txBody>
+                  <a:tcPr>
+                    <a:solidFill>
+                      <a:srgbClr val="F0F0F0"/>
+                    </a:solidFill>
+                  </a:tcPr>
+                </a:tc>
+                <a:tc>
+                  <a:txBody>
+                    <a:bodyPr/>
+                    <a:lstStyle/>
+                    <a:p>
+                      <a:pPr>
+                        <a:defRPr sz="1200">
+                          <a:solidFill>
+                            <a:srgbClr val="000000"/>
+                          </a:solidFill>
+                        </a:defRPr>
+                      </a:pPr>
+                      <a:r>
+                        <a:t>2026-09-02</a:t>
+                      </a:r>
+                    </a:p>
+                  </a:txBody>
+                  <a:tcPr>
+                    <a:solidFill>
+                      <a:srgbClr val="F0F0F0"/>
+                    </a:solidFill>
+                  </a:tcPr>
+                </a:tc>
+              </a:tr>
+              <a:tr h="279132">
+                <a:tc>
+                  <a:txBody>
+                    <a:bodyPr/>
+                    <a:lstStyle/>
+                    <a:p>
+                      <a:pPr>
+                        <a:defRPr sz="1200">
+                          <a:solidFill>
+                            <a:srgbClr val="000000"/>
+                          </a:solidFill>
+                        </a:defRPr>
+                      </a:pPr>
+                      <a:r>
+                        <a:t>F - Lanjutan</a:t>
+                      </a:r>
+                    </a:p>
+                  </a:txBody>
+                  <a:tcPr/>
+                </a:tc>
+                <a:tc>
+                  <a:txBody>
+                    <a:bodyPr/>
+                    <a:lstStyle/>
+                    <a:p>
+                      <a:pPr>
+                        <a:defRPr sz="1200">
+                          <a:solidFill>
+                            <a:srgbClr val="000000"/>
+                          </a:solidFill>
+                        </a:defRPr>
+                      </a:pPr>
+                      <a:r>
+                        <a:t>Trusted autonomy (timeout/SLA)</a:t>
+                      </a:r>
+                    </a:p>
+                  </a:txBody>
+                  <a:tcPr/>
+                </a:tc>
+                <a:tc>
+                  <a:txBody>
+                    <a:bodyPr/>
+                    <a:lstStyle/>
+                    <a:p>
+                      <a:pPr>
+                        <a:defRPr sz="1200">
+                          <a:solidFill>
+                            <a:srgbClr val="000000"/>
+                          </a:solidFill>
+                        </a:defRPr>
+                      </a:pPr>
+                      <a:r>
+                        <a:t>Belum</a:t>
+                      </a:r>
+                    </a:p>
+                  </a:txBody>
+                  <a:tcPr/>
+                </a:tc>
+                <a:tc>
+                  <a:txBody>
+                    <a:bodyPr/>
+                    <a:lstStyle/>
+                    <a:p>
+                      <a:pPr>
+                        <a:defRPr sz="1200">
+                          <a:solidFill>
+                            <a:srgbClr val="000000"/>
+                          </a:solidFill>
+                        </a:defRPr>
+                      </a:pPr>
+                      <a:r>
+                        <a:t>-</a:t>
+                      </a:r>
+                    </a:p>
+                  </a:txBody>
+                  <a:tcPr/>
+                </a:tc>
+              </a:tr>
+              <a:tr h="279132">
+                <a:tc>
+                  <a:txBody>
+                    <a:bodyPr/>
+                    <a:lstStyle/>
+                    <a:p>
+                      <a:pPr>
+                        <a:defRPr sz="1200">
+                          <a:solidFill>
+                            <a:srgbClr val="000000"/>
+                          </a:solidFill>
+                        </a:defRPr>
+                      </a:pPr>
+                      <a:r>
+                        <a:t>F - Lanjutan</a:t>
+                      </a:r>
+                    </a:p>
+                  </a:txBody>
+                  <a:tcPr>
+                    <a:solidFill>
+                      <a:srgbClr val="F0F0F0"/>
+                    </a:solidFill>
+                  </a:tcPr>
+                </a:tc>
+                <a:tc>
+                  <a:txBody>
+                    <a:bodyPr/>
+                    <a:lstStyle/>
+                    <a:p>
+                      <a:pPr>
+                        <a:defRPr sz="1200">
+                          <a:solidFill>
+                            <a:srgbClr val="000000"/>
+                          </a:solidFill>
+                        </a:defRPr>
+                      </a:pPr>
+                      <a:r>
+                        <a:t>RAG anti-halusinasi</a:t>
+                      </a:r>
+                    </a:p>
+                  </a:txBody>
+                  <a:tcPr>
+                    <a:solidFill>
+                      <a:srgbClr val="F0F0F0"/>
+                    </a:solidFill>
+                  </a:tcPr>
+                </a:tc>
+                <a:tc>
+                  <a:txBody>
+                    <a:bodyPr/>
+                    <a:lstStyle/>
+                    <a:p>
+                      <a:pPr>
+                        <a:defRPr sz="1200">
+                          <a:solidFill>
+                            <a:srgbClr val="000000"/>
+                          </a:solidFill>
+                        </a:defRPr>
+                      </a:pPr>
+                      <a:r>
+                        <a:t>Belum</a:t>
+                      </a:r>
+                    </a:p>
+                  </a:txBody>
+                  <a:tcPr>
+                    <a:solidFill>
+                      <a:srgbClr val="F0F0F0"/>
+                    </a:solidFill>
+                  </a:tcPr>
+                </a:tc>
+                <a:tc>
+                  <a:txBody>
+                    <a:bodyPr/>
+                    <a:lstStyle/>
+                    <a:p>
+                      <a:pPr>
+                        <a:defRPr sz="1200">
+                          <a:solidFill>
+                            <a:srgbClr val="000000"/>
+                          </a:solidFill>
+                        </a:defRPr>
+                      </a:pPr>
+                      <a:r>
+                        <a:t>-</a:t>
+                      </a:r>
+                    </a:p>
+                  </a:txBody>
+                  <a:tcPr>
+                    <a:solidFill>
+                      <a:srgbClr val="F0F0F0"/>
+                    </a:solidFill>
+                  </a:tcPr>
+                </a:tc>
+              </a:tr>
+              <a:tr h="279132">
+                <a:tc>
+                  <a:txBody>
+                    <a:bodyPr/>
+                    <a:lstStyle/>
+                    <a:p>
+                      <a:pPr>
+                        <a:defRPr sz="1200">
+                          <a:solidFill>
+                            <a:srgbClr val="000000"/>
+                          </a:solidFill>
+                        </a:defRPr>
+                      </a:pPr>
+                      <a:r>
+                        <a:t>E - Arsitektur</a:t>
+                      </a:r>
+                    </a:p>
+                  </a:txBody>
+                  <a:tcPr/>
+                </a:tc>
+                <a:tc>
+                  <a:txBody>
+                    <a:bodyPr/>
+                    <a:lstStyle/>
+                    <a:p>
+                      <a:pPr>
+                        <a:defRPr sz="1200">
+                          <a:solidFill>
+                            <a:srgbClr val="000000"/>
+                          </a:solidFill>
+                        </a:defRPr>
+                      </a:pPr>
+                      <a:r>
+                        <a:t>HA: queue-mode + Redis + PG</a:t>
+                      </a:r>
+                    </a:p>
+                  </a:txBody>
+                  <a:tcPr/>
+                </a:tc>
+                <a:tc>
+                  <a:txBody>
+                    <a:bodyPr/>
+                    <a:lstStyle/>
+                    <a:p>
+                      <a:pPr>
+                        <a:defRPr sz="1200">
+                          <a:solidFill>
+                            <a:srgbClr val="000000"/>
+                          </a:solidFill>
+                        </a:defRPr>
+                      </a:pPr>
+                      <a:r>
+                        <a:t>Belum</a:t>
+                      </a:r>
+                    </a:p>
+                  </a:txBody>
+                  <a:tcPr/>
+                </a:tc>
+                <a:tc>
+                  <a:txBody>
+                    <a:bodyPr/>
+                    <a:lstStyle/>
+                    <a:p>
+                      <a:pPr>
+                        <a:defRPr sz="1200">
+                          <a:solidFill>
+                            <a:srgbClr val="000000"/>
+                          </a:solidFill>
+                        </a:defRPr>
+                      </a:pPr>
+                      <a:r>
+                        <a:t>-</a:t>
+                      </a:r>
+                    </a:p>
+                  </a:txBody>
+                  <a:tcPr/>
+                </a:tc>
+              </a:tr>
+              <a:tr h="279144">
+                <a:tc>
+                  <a:txBody>
+                    <a:bodyPr/>
+                    <a:lstStyle/>
+                    <a:p>
+                      <a:pPr>
+                        <a:defRPr sz="1200">
+                          <a:solidFill>
+                            <a:srgbClr val="000000"/>
+                          </a:solidFill>
+                        </a:defRPr>
+                      </a:pPr>
+                      <a:r>
+                        <a:t>H - Maintenance</a:t>
+                      </a:r>
+                    </a:p>
+                  </a:txBody>
+                  <a:tcPr>
+                    <a:solidFill>
+                      <a:srgbClr val="F0F0F0"/>
+                    </a:solidFill>
+                  </a:tcPr>
+                </a:tc>
+                <a:tc>
+                  <a:txBody>
+                    <a:bodyPr/>
+                    <a:lstStyle/>
+                    <a:p>
+                      <a:pPr>
+                        <a:defRPr sz="1200">
+                          <a:solidFill>
+                            <a:srgbClr val="000000"/>
+                          </a:solidFill>
+                        </a:defRPr>
+                      </a:pPr>
+                      <a:r>
+                        <a:t>Upgrade Wazuh 4.14.7</a:t>
+                      </a:r>
+                    </a:p>
+                  </a:txBody>
+                  <a:tcPr>
+                    <a:solidFill>
+                      <a:srgbClr val="F0F0F0"/>
+                    </a:solidFill>
+                  </a:tcPr>
+                </a:tc>
+                <a:tc>
+                  <a:txBody>
+                    <a:bodyPr/>
+                    <a:lstStyle/>
+                    <a:p>
+                      <a:pPr>
+                        <a:defRPr sz="1200">
+                          <a:solidFill>
+                            <a:srgbClr val="000000"/>
+                          </a:solidFill>
+                        </a:defRPr>
+                      </a:pPr>
+                      <a:r>
+                        <a:t>Belum</a:t>
+                      </a:r>
+                    </a:p>
+                  </a:txBody>
+                  <a:tcPr>
+                    <a:solidFill>
+                      <a:srgbClr val="F0F0F0"/>
+                    </a:solidFill>
+                  </a:tcPr>
+                </a:tc>
+                <a:tc>
+                  <a:txBody>
+                    <a:bodyPr/>
+                    <a:lstStyle/>
+                    <a:p>
+                      <a:pPr>
+                        <a:defRPr sz="1200">
+                          <a:solidFill>
+                            <a:srgbClr val="000000"/>
+                          </a:solidFill>
+                        </a:defRPr>
+                      </a:pPr>
+                      <a:r>
+                        <a:t>PascTA</a:t>
+                      </a:r>
+                    </a:p>
+                  </a:txBody>
+                  <a:tcPr>
+                    <a:solidFill>
+                      <a:srgbClr val="F0F0F0"/>
+                    </a:solidFill>
+                  </a:tcPr>
+                </a:tc>
+              </a:tr>
+            </a:tbl>
+          </a:graphicData>
+        </a:graphic>
+      </p:graphicFrame>
+    </p:spTree>
+  </p:cSld>
+  <p:clrMapOvr>
+    <a:masterClrMapping/>
+  </p:clrMapOvr>
+</p:sld>
+</file>
+
+<file path=ppt/slides/slide8.xml><?xml version="1.0" encoding="utf-8"?>
+<p:sld xmlns:a="http://schemas.openxmlformats.org/drawingml/2006/main" xmlns:p="http://schemas.openxmlformats.org/presentationml/2006/main" xmlns:r="http://schemas.openxmlformats.org/officeDocument/2006/relationships">
+  <p:cSld>
+    <p:spTree>
+      <p:nvGrpSpPr>
+        <p:cNvPr id="1" name=""/>
+        <p:cNvGrpSpPr/>
+        <p:nvPr/>
+      </p:nvGrpSpPr>
+      <p:grpSpPr/>
+      <p:sp>
+        <p:nvSpPr>
+          <p:cNvPr id="2" name="TextBox 1"/>
+          <p:cNvSpPr txBox="1"/>
+          <p:nvPr/>
+        </p:nvSpPr>
+        <p:spPr>
+          <a:xfrm>
+            <a:off x="457200" y="274320"/>
+            <a:ext cx="10972800" cy="548640"/>
+          </a:xfrm>
+          <a:prstGeom prst="rect">
+            <a:avLst/>
+          </a:prstGeom>
+          <a:noFill/>
+        </p:spPr>
+        <p:txBody>
+          <a:bodyPr wrap="square">
+            <a:spAutoFit/>
+          </a:bodyPr>
+          <a:lstStyle/>
+          <a:p>
+            <a:pPr algn="l">
+              <a:defRPr sz="2800" b="1">
+                <a:solidFill>
+                  <a:srgbClr val="1A568E"/>
+                </a:solidFill>
+              </a:defRPr>
+            </a:pPr>
+            <a:r>
+              <a:t>Rencana ke Depan</a:t>
+            </a:r>
+          </a:p>
+        </p:txBody>
+      </p:sp>
+      <p:sp>
+        <p:nvSpPr>
+          <p:cNvPr id="3" name="Rectangle 2"/>
+          <p:cNvSpPr/>
+          <p:nvPr/>
+        </p:nvSpPr>
+        <p:spPr>
+          <a:xfrm>
+            <a:off x="457200" y="822960"/>
+            <a:ext cx="3200400" cy="25400"/>
+          </a:xfrm>
+          <a:prstGeom prst="rect">
+            <a:avLst/>
+          </a:prstGeom>
+          <a:solidFill>
+            <a:srgbClr val="1A568E"/>
+          </a:solidFill>
+          <a:ln>
+            <a:noFill/>
+          </a:ln>
+        </p:spPr>
+        <p:style>
+          <a:lnRef idx="1">
+            <a:schemeClr val="accent1"/>
+          </a:lnRef>
+          <a:fillRef idx="3">
+            <a:schemeClr val="accent1"/>
+          </a:fillRef>
+          <a:effectRef idx="2">
+            <a:schemeClr val="accent1"/>
+          </a:effectRef>
+          <a:fontRef idx="minor">
+            <a:schemeClr val="lt1"/>
+          </a:fontRef>
+        </p:style>
+        <p:txBody>
+          <a:bodyPr rtlCol="0" anchor="ctr"/>
+          <a:lstStyle/>
+          <a:p>
+            <a:pPr algn="ctr"/>
+          </a:p>
+        </p:txBody>
+      </p:sp>
       <p:sp>
         <p:nvSpPr>
           <p:cNvPr id="4" name="TextBox 3"/>
@@ -6556,7 +8917,7 @@
 </p:sld>
 </file>
 
-<file path=ppt/slides/slide8.xml><?xml version="1.0" encoding="utf-8"?>
+<file path=ppt/slides/slide9.xml><?xml version="1.0" encoding="utf-8"?>
 <p:sld xmlns:a="http://schemas.openxmlformats.org/drawingml/2006/main" xmlns:p="http://schemas.openxmlformats.org/presentationml/2006/main" xmlns:r="http://schemas.openxmlformats.org/officeDocument/2006/relationships">
   <p:cSld>
     <p:spTree>

</xml_diff>

<commit_message>
docs: PPT v6 — perbaiki layout roadmap table
- Slide 7: pindah tabel dari top=1.2 ke top=1.1, height 5.8 -> 6.1
- Row height naik dari 22pt ke 23pt (lebih nyaman dibaca)
- Bottom margin 0.30 in (dari 0.50 in sebelumnya, masih aman)
- Semua slide sudah dicek: tidak ada overflow/overlap
</commit_message>
<xml_diff>
--- a/docs/BIMBINGAN-TA-SOAR.pptx
+++ b/docs/BIMBINGAN-TA-SOAR.pptx
@@ -6928,8 +6928,8 @@
           <p:nvPr/>
         </p:nvGraphicFramePr>
         <p:xfrm>
-          <a:off x="457200" y="1097280"/>
-          <a:ext cx="9601200" cy="5303520"/>
+          <a:off x="457200" y="1005840"/>
+          <a:ext cx="9601200" cy="5577840"/>
         </p:xfrm>
         <a:graphic>
           <a:graphicData uri="http://schemas.openxmlformats.org/drawingml/2006/table">
@@ -6943,7 +6943,7 @@
                 <a:gridCol w="1645920"/>
                 <a:gridCol w="1828800"/>
               </a:tblGrid>
-              <a:tr h="279132">
+              <a:tr h="293570">
                 <a:tc>
                   <a:txBody>
                     <a:bodyPr/>
@@ -7037,7 +7037,7 @@
                   </a:tcPr>
                 </a:tc>
               </a:tr>
-              <a:tr h="279132">
+              <a:tr h="293570">
                 <a:tc>
                   <a:txBody>
                     <a:bodyPr/>
@@ -7115,7 +7115,7 @@
                   <a:tcPr/>
                 </a:tc>
               </a:tr>
-              <a:tr h="279132">
+              <a:tr h="293570">
                 <a:tc>
                   <a:txBody>
                     <a:bodyPr/>
@@ -7209,7 +7209,7 @@
                   </a:tcPr>
                 </a:tc>
               </a:tr>
-              <a:tr h="279132">
+              <a:tr h="293570">
                 <a:tc>
                   <a:txBody>
                     <a:bodyPr/>
@@ -7287,7 +7287,7 @@
                   <a:tcPr/>
                 </a:tc>
               </a:tr>
-              <a:tr h="279132">
+              <a:tr h="293570">
                 <a:tc>
                   <a:txBody>
                     <a:bodyPr/>
@@ -7381,7 +7381,7 @@
                   </a:tcPr>
                 </a:tc>
               </a:tr>
-              <a:tr h="279132">
+              <a:tr h="293570">
                 <a:tc>
                   <a:txBody>
                     <a:bodyPr/>
@@ -7459,7 +7459,7 @@
                   <a:tcPr/>
                 </a:tc>
               </a:tr>
-              <a:tr h="279132">
+              <a:tr h="293570">
                 <a:tc>
                   <a:txBody>
                     <a:bodyPr/>
@@ -7553,7 +7553,7 @@
                   </a:tcPr>
                 </a:tc>
               </a:tr>
-              <a:tr h="279132">
+              <a:tr h="293570">
                 <a:tc>
                   <a:txBody>
                     <a:bodyPr/>
@@ -7631,7 +7631,7 @@
                   <a:tcPr/>
                 </a:tc>
               </a:tr>
-              <a:tr h="279132">
+              <a:tr h="293570">
                 <a:tc>
                   <a:txBody>
                     <a:bodyPr/>
@@ -7725,7 +7725,7 @@
                   </a:tcPr>
                 </a:tc>
               </a:tr>
-              <a:tr h="279132">
+              <a:tr h="293570">
                 <a:tc>
                   <a:txBody>
                     <a:bodyPr/>
@@ -7803,7 +7803,7 @@
                   <a:tcPr/>
                 </a:tc>
               </a:tr>
-              <a:tr h="279132">
+              <a:tr h="293570">
                 <a:tc>
                   <a:txBody>
                     <a:bodyPr/>
@@ -7897,7 +7897,7 @@
                   </a:tcPr>
                 </a:tc>
               </a:tr>
-              <a:tr h="279132">
+              <a:tr h="293570">
                 <a:tc>
                   <a:txBody>
                     <a:bodyPr/>
@@ -7975,7 +7975,7 @@
                   <a:tcPr/>
                 </a:tc>
               </a:tr>
-              <a:tr h="279132">
+              <a:tr h="293570">
                 <a:tc>
                   <a:txBody>
                     <a:bodyPr/>
@@ -8069,7 +8069,7 @@
                   </a:tcPr>
                 </a:tc>
               </a:tr>
-              <a:tr h="279132">
+              <a:tr h="293570">
                 <a:tc>
                   <a:txBody>
                     <a:bodyPr/>
@@ -8147,7 +8147,7 @@
                   <a:tcPr/>
                 </a:tc>
               </a:tr>
-              <a:tr h="279132">
+              <a:tr h="293570">
                 <a:tc>
                   <a:txBody>
                     <a:bodyPr/>
@@ -8241,7 +8241,7 @@
                   </a:tcPr>
                 </a:tc>
               </a:tr>
-              <a:tr h="279132">
+              <a:tr h="293570">
                 <a:tc>
                   <a:txBody>
                     <a:bodyPr/>
@@ -8319,7 +8319,7 @@
                   <a:tcPr/>
                 </a:tc>
               </a:tr>
-              <a:tr h="279132">
+              <a:tr h="293570">
                 <a:tc>
                   <a:txBody>
                     <a:bodyPr/>
@@ -8413,7 +8413,7 @@
                   </a:tcPr>
                 </a:tc>
               </a:tr>
-              <a:tr h="279132">
+              <a:tr h="293570">
                 <a:tc>
                   <a:txBody>
                     <a:bodyPr/>
@@ -8491,7 +8491,7 @@
                   <a:tcPr/>
                 </a:tc>
               </a:tr>
-              <a:tr h="279144">
+              <a:tr h="293580">
                 <a:tc>
                   <a:txBody>
                     <a:bodyPr/>

</xml_diff>